<commit_message>
Update BOM deck: add bonus Challenge 5 + live GitHub repo link
Add the optional bonus Challenge 5 (Safety, Red-Teaming & Continuous Eval) row to the Delivery table so the one-pager matches the repo, and turn the 'GitHub Repo HERE' placeholder into a live hyperlink to the repository. Remaining HERE placeholders (Tech-Talk decks, Train-the-Trainer video, Extra Learning) are still-pending deliverables.

Co-authored-by: Copilot App <223556219+Copilot@users.noreply.github.com>

Copilot-Session: f443d6dc-c293-430e-b78b-e176ebc6c075
</commit_message>
<xml_diff>
--- a/docs/marketing/CLM-Microhack-BOM.pptx
+++ b/docs/marketing/CLM-Microhack-BOM.pptx
@@ -3325,13 +3325,20 @@
               <a:buNone/>
             </a:pPr>
             <a:r>
-              <a:rPr lang="en-US" sz="850" b="1" dirty="0">
+              <a:rPr lang="en-US" sz="850" b="1" u="sng" dirty="0">
                 <a:solidFill>
                   <a:srgbClr val="F4C430"/>
                 </a:solidFill>
                 <a:latin typeface="Segoe UI" pitchFamily="34" charset="0"/>
                 <a:ea typeface="Segoe UI" pitchFamily="34" charset="-122"/>
                 <a:cs typeface="Segoe UI" pitchFamily="34" charset="-120"/>
+                <a:hlinkClick r:id="rId8" invalidUrl="" action="" tgtFrame="" tooltip="" history="1" highlightClick="0" endSnd="0">
+                  <a:extLst>
+                    <a:ext uri="{A12FA001-AC4F-418D-AE19-62706E023703}">
+                      <ahyp:hlinkClr xmlns:ahyp="http://schemas.microsoft.com/office/drawing/2018/hyperlinkcolor" val="tx"/>
+                    </a:ext>
+                  </a:extLst>
+                </a:hlinkClick>
               </a:rPr>
               <a:t>HERE</a:t>
             </a:r>
@@ -3393,7 +3400,7 @@
                 <a:gridCol w="4919472"/>
                 <a:gridCol w="822960"/>
               </a:tblGrid>
-              <a:tr h="265176">
+              <a:tr h="228600">
                 <a:tc>
                   <a:txBody>
                     <a:bodyPr/>
@@ -3531,7 +3538,7 @@
                   </a:tcPr>
                 </a:tc>
               </a:tr>
-              <a:tr h="265176">
+              <a:tr h="228600">
                 <a:tc>
                   <a:txBody>
                     <a:bodyPr/>
@@ -3669,7 +3676,7 @@
                   </a:tcPr>
                 </a:tc>
               </a:tr>
-              <a:tr h="265176">
+              <a:tr h="228600">
                 <a:tc>
                   <a:txBody>
                     <a:bodyPr/>
@@ -3807,7 +3814,7 @@
                   </a:tcPr>
                 </a:tc>
               </a:tr>
-              <a:tr h="265176">
+              <a:tr h="228600">
                 <a:tc>
                   <a:txBody>
                     <a:bodyPr/>
@@ -3945,7 +3952,7 @@
                   </a:tcPr>
                 </a:tc>
               </a:tr>
-              <a:tr h="265176">
+              <a:tr h="228600">
                 <a:tc>
                   <a:txBody>
                     <a:bodyPr/>
@@ -4083,7 +4090,7 @@
                   </a:tcPr>
                 </a:tc>
               </a:tr>
-              <a:tr h="265176">
+              <a:tr h="228600">
                 <a:tc>
                   <a:txBody>
                     <a:bodyPr/>
@@ -4221,6 +4228,158 @@
                   </a:tcPr>
                 </a:tc>
               </a:tr>
+              <a:tr h="228600">
+                <a:tc>
+                  <a:txBody>
+                    <a:bodyPr/>
+                    <a:lstStyle/>
+                    <a:p>
+                      <a:pPr indent="0" marL="0">
+                        <a:buNone/>
+                      </a:pPr>
+                      <a:r>
+                        <a:rPr lang="en-US" sz="900" dirty="0">
+                          <a:solidFill>
+                            <a:srgbClr val="2B2B2B"/>
+                          </a:solidFill>
+                          <a:latin typeface="Segoe UI" pitchFamily="34" charset="0"/>
+                          <a:ea typeface="Segoe UI" pitchFamily="34" charset="-122"/>
+                          <a:cs typeface="Segoe UI" pitchFamily="34" charset="-120"/>
+                        </a:rPr>
+                        <a:t>5   Safety, Red-Teaming &amp; Continuous Eval   </a:t>
+                      </a:r>
+                      <a:pPr indent="0" marL="0">
+                        <a:buNone/>
+                      </a:pPr>
+                      <a:r>
+                        <a:rPr lang="en-US" sz="900" b="1" dirty="0">
+                          <a:solidFill>
+                            <a:srgbClr val="1F6FB4"/>
+                          </a:solidFill>
+                          <a:latin typeface="Segoe UI" pitchFamily="34" charset="0"/>
+                          <a:ea typeface="Segoe UI" pitchFamily="34" charset="-122"/>
+                          <a:cs typeface="Segoe UI" pitchFamily="34" charset="-120"/>
+                        </a:rPr>
+                        <a:t>Bonus</a:t>
+                      </a:r>
+                      <a:endParaRPr lang="en-US" sz="900" dirty="0">
+                        <a:latin typeface="Segoe UI" charset="0"/>
+                        <a:ea typeface="Segoe UI" charset="0"/>
+                        <a:cs typeface="Segoe UI" charset="0"/>
+                      </a:endParaRPr>
+                    </a:p>
+                  </a:txBody>
+                  <a:tcPr marL="91440" marR="91440" marT="45720" marB="45720" anchor="ctr">
+                    <a:lnL w="6350" cap="flat" cmpd="sng" algn="ctr">
+                      <a:solidFill>
+                        <a:srgbClr val="D6DEE8"/>
+                      </a:solidFill>
+                      <a:prstDash val="solid"/>
+                      <a:round/>
+                      <a:headEnd type="none" w="med" len="med"/>
+                      <a:tailEnd type="none" w="med" len="med"/>
+                    </a:lnL>
+                    <a:lnR w="6350" cap="flat" cmpd="sng" algn="ctr">
+                      <a:solidFill>
+                        <a:srgbClr val="D6DEE8"/>
+                      </a:solidFill>
+                      <a:prstDash val="solid"/>
+                      <a:round/>
+                      <a:headEnd type="none" w="med" len="med"/>
+                      <a:tailEnd type="none" w="med" len="med"/>
+                    </a:lnR>
+                    <a:lnT w="6350" cap="flat" cmpd="sng" algn="ctr">
+                      <a:solidFill>
+                        <a:srgbClr val="D6DEE8"/>
+                      </a:solidFill>
+                      <a:prstDash val="solid"/>
+                      <a:round/>
+                      <a:headEnd type="none" w="med" len="med"/>
+                      <a:tailEnd type="none" w="med" len="med"/>
+                    </a:lnT>
+                    <a:lnB w="6350" cap="flat" cmpd="sng" algn="ctr">
+                      <a:solidFill>
+                        <a:srgbClr val="D6DEE8"/>
+                      </a:solidFill>
+                      <a:prstDash val="solid"/>
+                      <a:round/>
+                      <a:headEnd type="none" w="med" len="med"/>
+                      <a:tailEnd type="none" w="med" len="med"/>
+                    </a:lnB>
+                    <a:solidFill>
+                      <a:srgbClr val="FFFFFF"/>
+                    </a:solidFill>
+                  </a:tcPr>
+                </a:tc>
+                <a:tc>
+                  <a:txBody>
+                    <a:bodyPr/>
+                    <a:lstStyle/>
+                    <a:p>
+                      <a:pPr algn="r" indent="0" marL="0">
+                        <a:buNone/>
+                      </a:pPr>
+                      <a:r>
+                        <a:rPr lang="en-US" sz="900" i="1" dirty="0">
+                          <a:solidFill>
+                            <a:srgbClr val="6B7A8D"/>
+                          </a:solidFill>
+                          <a:latin typeface="Segoe UI" pitchFamily="34" charset="0"/>
+                          <a:ea typeface="Segoe UI" pitchFamily="34" charset="-122"/>
+                          <a:cs typeface="Segoe UI" pitchFamily="34" charset="-120"/>
+                        </a:rPr>
+                        <a:t>opt</a:t>
+                      </a:r>
+                      <a:endParaRPr lang="en-US" sz="900" dirty="0">
+                        <a:latin typeface="Segoe UI" charset="0"/>
+                        <a:ea typeface="Segoe UI" charset="0"/>
+                        <a:cs typeface="Segoe UI" charset="0"/>
+                      </a:endParaRPr>
+                    </a:p>
+                  </a:txBody>
+                  <a:tcPr marL="91440" marR="91440" marT="45720" marB="45720" anchor="ctr">
+                    <a:lnL w="6350" cap="flat" cmpd="sng" algn="ctr">
+                      <a:solidFill>
+                        <a:srgbClr val="D6DEE8"/>
+                      </a:solidFill>
+                      <a:prstDash val="solid"/>
+                      <a:round/>
+                      <a:headEnd type="none" w="med" len="med"/>
+                      <a:tailEnd type="none" w="med" len="med"/>
+                    </a:lnL>
+                    <a:lnR w="6350" cap="flat" cmpd="sng" algn="ctr">
+                      <a:solidFill>
+                        <a:srgbClr val="D6DEE8"/>
+                      </a:solidFill>
+                      <a:prstDash val="solid"/>
+                      <a:round/>
+                      <a:headEnd type="none" w="med" len="med"/>
+                      <a:tailEnd type="none" w="med" len="med"/>
+                    </a:lnR>
+                    <a:lnT w="6350" cap="flat" cmpd="sng" algn="ctr">
+                      <a:solidFill>
+                        <a:srgbClr val="D6DEE8"/>
+                      </a:solidFill>
+                      <a:prstDash val="solid"/>
+                      <a:round/>
+                      <a:headEnd type="none" w="med" len="med"/>
+                      <a:tailEnd type="none" w="med" len="med"/>
+                    </a:lnT>
+                    <a:lnB w="6350" cap="flat" cmpd="sng" algn="ctr">
+                      <a:solidFill>
+                        <a:srgbClr val="D6DEE8"/>
+                      </a:solidFill>
+                      <a:prstDash val="solid"/>
+                      <a:round/>
+                      <a:headEnd type="none" w="med" len="med"/>
+                      <a:tailEnd type="none" w="med" len="med"/>
+                    </a:lnB>
+                    <a:solidFill>
+                      <a:srgbClr val="FFFFFF"/>
+                    </a:solidFill>
+                  </a:tcPr>
+                </a:tc>
+              </a:tr>
             </a:tbl>
           </a:graphicData>
         </a:graphic>
@@ -4234,7 +4393,7 @@
           <p:nvPr/>
         </p:nvPicPr>
         <p:blipFill>
-          <a:blip r:embed="rId8"/>
+          <a:blip r:embed="rId9"/>
           <a:stretch>
             <a:fillRect/>
           </a:stretch>

</xml_diff>

<commit_message>
docs(marketing): update BOM deck orchestrator model to GPT-5.3
Co-authored-by: Copilot App <223556219+Copilot@users.noreply.github.com>

Copilot-Session: 045db514-059c-4c90-8dda-2ad610cbdec6
</commit_message>
<xml_diff>
--- a/docs/marketing/CLM-Microhack-BOM.pptx
+++ b/docs/marketing/CLM-Microhack-BOM.pptx
@@ -951,7 +951,7 @@
       </p:sp>
       <p:pic>
         <p:nvPicPr>
-          <p:cNvPr id="3" name="Image 0" descr="header_gradient.png">    </p:cNvPr>
+          <p:cNvPr id="3" name="Image 0" descr="header_gradient.png"/>
           <p:cNvPicPr>
             <a:picLocks noChangeAspect="1"/>
           </p:cNvPicPr>
@@ -1123,7 +1123,7 @@
       </p:sp>
       <p:pic>
         <p:nvPicPr>
-          <p:cNvPr id="6" name="Image 1" descr="header_gradient.png">    </p:cNvPr>
+          <p:cNvPr id="6" name="Image 1" descr="header_gradient.png"/>
           <p:cNvPicPr>
             <a:picLocks noChangeAspect="1"/>
           </p:cNvPicPr>
@@ -1327,7 +1327,7 @@
       </p:sp>
       <p:pic>
         <p:nvPicPr>
-          <p:cNvPr id="10" name="Image 2" descr="header_gradient.png">    </p:cNvPr>
+          <p:cNvPr id="10" name="Image 2" descr="header_gradient.png"/>
           <p:cNvPicPr>
             <a:picLocks noChangeAspect="1"/>
           </p:cNvPicPr>
@@ -1564,7 +1564,7 @@
                 <a:ea typeface="Segoe UI" pitchFamily="34" charset="-122"/>
                 <a:cs typeface="Segoe UI" pitchFamily="34" charset="-120"/>
               </a:rPr>
-              <a:t>    ·    GPT-4.1</a:t>
+              <a:t>    ·    GPT-5.3</a:t>
             </a:r>
             <a:endParaRPr lang="en-US" sz="1000" dirty="0"/>
           </a:p>
@@ -2087,7 +2087,7 @@
       </p:sp>
       <p:pic>
         <p:nvPicPr>
-          <p:cNvPr id="31" name="Image 3" descr="header_gradient.png">    </p:cNvPr>
+          <p:cNvPr id="31" name="Image 3" descr="header_gradient.png"/>
           <p:cNvPicPr>
             <a:picLocks noChangeAspect="1"/>
           </p:cNvPicPr>
@@ -3008,7 +3008,7 @@
       </p:graphicFrame>
       <p:pic>
         <p:nvPicPr>
-          <p:cNvPr id="34" name="Image 4" descr="header_gradient.png">    </p:cNvPr>
+          <p:cNvPr id="34" name="Image 4" descr="header_gradient.png"/>
           <p:cNvPicPr>
             <a:picLocks noChangeAspect="1"/>
           </p:cNvPicPr>
@@ -3225,7 +3225,7 @@
       </p:sp>
       <p:pic>
         <p:nvPicPr>
-          <p:cNvPr id="39" name="Image 5" descr="header_gradient.png">    </p:cNvPr>
+          <p:cNvPr id="39" name="Image 5" descr="header_gradient.png"/>
           <p:cNvPicPr>
             <a:picLocks noChangeAspect="1"/>
           </p:cNvPicPr>
@@ -4386,7 +4386,7 @@
       </p:graphicFrame>
       <p:pic>
         <p:nvPicPr>
-          <p:cNvPr id="43" name="Image 6" descr="header_gradient.png">    </p:cNvPr>
+          <p:cNvPr id="43" name="Image 6" descr="header_gradient.png"/>
           <p:cNvPicPr>
             <a:picLocks noChangeAspect="1"/>
           </p:cNvPicPr>

</xml_diff>

<commit_message>
Update CLM BOM deck to current model fleet
Align docs/marketing/CLM-Microhack-BOM.pptx with the repo's canonical model deployments (README, .env.example, deploy.ps1):

- Orchestrator: GPT-5.3 -> GPT-5.4
- Intake & Drafting: Claude Sonnet 4.5 -> Claude Opus 4.8
- Clause & Risk: Claude Sonnet 4.5 -> GPT-5.6 Sol
- Obligation & Renewal: GPT-4o-mini -> GPT-5-mini
- Grounding strip: Web IQ -> Bing web search

Co-authored-by: Copilot App <223556219+Copilot@users.noreply.github.com>
Copilot-Session: 2fc86db1-1f76-4b83-b234-329556a5f335
</commit_message>
<xml_diff>
--- a/docs/marketing/CLM-Microhack-BOM.pptx
+++ b/docs/marketing/CLM-Microhack-BOM.pptx
@@ -929,7 +929,7 @@
                 <a:ea typeface="Segoe UI" pitchFamily="34" charset="-122"/>
                 <a:cs typeface="Segoe UI" pitchFamily="34" charset="-120"/>
               </a:rPr>
-              <a:t>  |  </a:t>
+              <a:t xml:space="preserve">  |  </a:t>
             </a:r>
             <a:pPr algn="l" indent="0" marL="0">
               <a:buNone/>
@@ -1045,7 +1045,7 @@
                 <a:ea typeface="Segoe UI" pitchFamily="34" charset="-122"/>
                 <a:cs typeface="Segoe UI" pitchFamily="34" charset="-120"/>
               </a:rPr>
-              <a:t>Reg Page Copy </a:t>
+              <a:t xml:space="preserve">Reg Page Copy </a:t>
             </a:r>
             <a:pPr algn="r" indent="0" marL="0">
               <a:buNone/>
@@ -1073,7 +1073,7 @@
                 <a:ea typeface="Segoe UI" pitchFamily="34" charset="-122"/>
                 <a:cs typeface="Segoe UI" pitchFamily="34" charset="-120"/>
               </a:rPr>
-              <a:t> / Invitation Copy </a:t>
+              <a:t xml:space="preserve"> / Invitation Copy </a:t>
             </a:r>
             <a:pPr algn="r" indent="0" marL="0">
               <a:buNone/>
@@ -1101,7 +1101,7 @@
                 <a:ea typeface="Segoe UI" pitchFamily="34" charset="-122"/>
                 <a:cs typeface="Segoe UI" pitchFamily="34" charset="-120"/>
               </a:rPr>
-              <a:t> / Marketing BOM </a:t>
+              <a:t xml:space="preserve"> / Marketing BOM </a:t>
             </a:r>
             <a:pPr algn="r" indent="0" marL="0">
               <a:buNone/>
@@ -1305,7 +1305,7 @@
                 <a:ea typeface="Segoe UI" pitchFamily="34" charset="-122"/>
                 <a:cs typeface="Segoe UI" pitchFamily="34" charset="-120"/>
               </a:rPr>
-              <a:t>Agentic CLM </a:t>
+              <a:t xml:space="preserve">Agentic CLM </a:t>
             </a:r>
             <a:pPr algn="l" indent="0" marL="0">
               <a:buNone/>
@@ -1564,7 +1564,7 @@
                 <a:ea typeface="Segoe UI" pitchFamily="34" charset="-122"/>
                 <a:cs typeface="Segoe UI" pitchFamily="34" charset="-120"/>
               </a:rPr>
-              <a:t>    ·    GPT-5.3</a:t>
+              <a:t xml:space="preserve">    ·    GPT-5.4</a:t>
             </a:r>
             <a:endParaRPr lang="en-US" sz="1000" dirty="0"/>
           </a:p>
@@ -1682,7 +1682,7 @@
                 <a:ea typeface="Segoe UI" pitchFamily="34" charset="-122"/>
                 <a:cs typeface="Segoe UI" pitchFamily="34" charset="-120"/>
               </a:rPr>
-              <a:t>Claude Sonnet 4.5</a:t>
+              <a:t>Claude Opus 4.8</a:t>
             </a:r>
             <a:endParaRPr lang="en-US" sz="950" dirty="0"/>
           </a:p>
@@ -1800,7 +1800,7 @@
                 <a:ea typeface="Segoe UI" pitchFamily="34" charset="-122"/>
                 <a:cs typeface="Segoe UI" pitchFamily="34" charset="-120"/>
               </a:rPr>
-              <a:t>Claude Sonnet 4.5</a:t>
+              <a:t>GPT-5.6 Sol</a:t>
             </a:r>
             <a:endParaRPr lang="en-US" sz="950" dirty="0"/>
           </a:p>
@@ -1918,7 +1918,7 @@
                 <a:ea typeface="Segoe UI" pitchFamily="34" charset="-122"/>
                 <a:cs typeface="Segoe UI" pitchFamily="34" charset="-120"/>
               </a:rPr>
-              <a:t>GPT-4o-mini</a:t>
+              <a:t>GPT-5-mini</a:t>
             </a:r>
             <a:endParaRPr lang="en-US" sz="950" dirty="0"/>
           </a:p>
@@ -1979,7 +1979,7 @@
                 <a:ea typeface="Segoe UI" pitchFamily="34" charset="-122"/>
                 <a:cs typeface="Segoe UI" pitchFamily="34" charset="-120"/>
               </a:rPr>
-              <a:t>Foundry IQ  ·  Azure AI Search  ·  Azure SQL  ·  Web IQ  ·  MCP</a:t>
+              <a:t>Foundry IQ  ·  Azure AI Search  ·  Azure SQL  ·  Bing web search  ·  MCP</a:t>
             </a:r>
             <a:endParaRPr lang="en-US" sz="800" dirty="0"/>
           </a:p>
@@ -3102,7 +3102,7 @@
                 <a:ea typeface="Segoe UI" pitchFamily="34" charset="-122"/>
                 <a:cs typeface="Segoe UI" pitchFamily="34" charset="-120"/>
               </a:rPr>
-              <a:t>Agnostic </a:t>
+              <a:t xml:space="preserve">Agnostic </a:t>
             </a:r>
             <a:pPr algn="r" indent="0" marL="0">
               <a:buNone/>
@@ -3130,7 +3130,7 @@
                 <a:ea typeface="Segoe UI" pitchFamily="34" charset="-122"/>
                 <a:cs typeface="Segoe UI" pitchFamily="34" charset="-120"/>
               </a:rPr>
-              <a:t> / FSI-Legal </a:t>
+              <a:t xml:space="preserve"> / FSI-Legal </a:t>
             </a:r>
             <a:pPr algn="r" indent="0" marL="0">
               <a:buNone/>
@@ -3319,7 +3319,7 @@
                 <a:ea typeface="Segoe UI" pitchFamily="34" charset="-122"/>
                 <a:cs typeface="Segoe UI" pitchFamily="34" charset="-120"/>
               </a:rPr>
-              <a:t>GitHub Repo </a:t>
+              <a:t xml:space="preserve">GitHub Repo </a:t>
             </a:r>
             <a:pPr algn="r" indent="0" marL="0">
               <a:buNone/>
@@ -3354,7 +3354,7 @@
                 <a:ea typeface="Segoe UI" pitchFamily="34" charset="-122"/>
                 <a:cs typeface="Segoe UI" pitchFamily="34" charset="-120"/>
               </a:rPr>
-              <a:t> / Train the Trainer video </a:t>
+              <a:t xml:space="preserve"> / Train the Trainer video </a:t>
             </a:r>
             <a:pPr algn="r" indent="0" marL="0">
               <a:buNone/>
@@ -4246,7 +4246,7 @@
                           <a:ea typeface="Segoe UI" pitchFamily="34" charset="-122"/>
                           <a:cs typeface="Segoe UI" pitchFamily="34" charset="-120"/>
                         </a:rPr>
-                        <a:t>5   Safety, Red-Teaming &amp; Continuous Eval   </a:t>
+                        <a:t xml:space="preserve">5   Safety, Red-Teaming &amp; Continuous Eval   </a:t>
                       </a:r>
                       <a:pPr indent="0" marL="0">
                         <a:buNone/>

</xml_diff>

<commit_message>
docs(marketing): enrich BOM deck Use case & Tech Talk boxes
Add a concise "Concretely:" outcome line under the Use case box
(cited template drafts, risk-scored clauses, human-approved renewal
alerts) and a paragraph under Tech Talk summarizing the multi-model /
multi-agent pattern, grounding with Foundry IQ, the GenAIOps loop, and
MCP publishing to Microsoft 365 Copilot & Teams. Left architecture
block nudged down to keep spacing balanced; no content removed.

Co-authored-by: Copilot App <223556219+Copilot@users.noreply.github.com>
Copilot-Session: 2fc86db1-1f76-4b83-b234-329556a5f335
</commit_message>
<xml_diff>
--- a/docs/marketing/CLM-Microhack-BOM.pptx
+++ b/docs/marketing/CLM-Microhack-BOM.pptx
@@ -1193,7 +1193,7 @@
         <p:spPr>
           <a:xfrm>
             <a:off x="292608" y="1627632"/>
-            <a:ext cx="5650992" cy="1389888"/>
+            <a:ext cx="5650992" cy="1610868"/>
           </a:xfrm>
           <a:prstGeom prst="roundRect">
             <a:avLst>
@@ -1227,7 +1227,7 @@
         <p:spPr>
           <a:xfrm>
             <a:off x="438912" y="1700784"/>
-            <a:ext cx="5358384" cy="1243584"/>
+            <a:ext cx="5358384" cy="1543584"/>
           </a:xfrm>
           <a:prstGeom prst="rect">
             <a:avLst/>
@@ -1320,6 +1320,37 @@
                 <a:cs typeface="Segoe UI" pitchFamily="34" charset="-120"/>
               </a:rPr>
               <a:t>puts an orchestrator + grounded specialist agents on top: draft from approved templates, extract and risk-score clauses, answer cited questions, and proactively alert on renewals — with human sign-off and full tracing.</a:t>
+            </a:r>
+            <a:endParaRPr lang="en-US" sz="950" dirty="0"/>
+          </a:p>
+          <a:p>
+            <a:pPr algn="l" indent="0" marL="0">
+              <a:spcBef>
+                <a:spcPts val="600"/>
+              </a:spcBef>
+              <a:buNone/>
+            </a:pPr>
+            <a:r>
+              <a:rPr lang="en-US" sz="950" b="1" dirty="0">
+                <a:solidFill>
+                  <a:srgbClr val="1F6FB4"/>
+                </a:solidFill>
+                <a:latin typeface="Segoe UI" pitchFamily="34" charset="0"/>
+                <a:ea typeface="Segoe UI" pitchFamily="34" charset="-122"/>
+                <a:cs typeface="Segoe UI" pitchFamily="34" charset="-120"/>
+              </a:rPr>
+              <a:t xml:space="preserve">Concretely: </a:t>
+            </a:r>
+            <a:r>
+              <a:rPr lang="en-US" sz="950" dirty="0">
+                <a:solidFill>
+                  <a:srgbClr val="2B2B2B"/>
+                </a:solidFill>
+                <a:latin typeface="Segoe UI" pitchFamily="34" charset="0"/>
+                <a:ea typeface="Segoe UI" pitchFamily="34" charset="-122"/>
+                <a:cs typeface="Segoe UI" pitchFamily="34" charset="-120"/>
+              </a:rPr>
+              <a:t>cited template drafts, risk-scored clauses, and human-approved renewal alerts.</a:t>
             </a:r>
             <a:endParaRPr lang="en-US" sz="950" dirty="0"/>
           </a:p>
@@ -1341,7 +1372,7 @@
         </p:blipFill>
         <p:spPr>
           <a:xfrm>
-            <a:off x="292608" y="3108960"/>
+            <a:off x="292608" y="3328960"/>
             <a:ext cx="5650992" cy="329184"/>
           </a:xfrm>
           <a:prstGeom prst="rect">
@@ -1357,7 +1388,7 @@
         </p:nvSpPr>
         <p:spPr>
           <a:xfrm>
-            <a:off x="420624" y="3108960"/>
+            <a:off x="420624" y="3328960"/>
             <a:ext cx="3108046" cy="329184"/>
           </a:xfrm>
           <a:prstGeom prst="rect">
@@ -1396,7 +1427,7 @@
         </p:nvSpPr>
         <p:spPr>
           <a:xfrm>
-            <a:off x="292608" y="3456432"/>
+            <a:off x="292608" y="3676432"/>
             <a:ext cx="5650992" cy="329184"/>
           </a:xfrm>
           <a:prstGeom prst="roundRect">
@@ -1430,7 +1461,7 @@
         </p:nvSpPr>
         <p:spPr>
           <a:xfrm>
-            <a:off x="438912" y="3456432"/>
+            <a:off x="438912" y="3676432"/>
             <a:ext cx="5358384" cy="329184"/>
           </a:xfrm>
           <a:prstGeom prst="rect">
@@ -1469,7 +1500,7 @@
         </p:nvSpPr>
         <p:spPr>
           <a:xfrm>
-            <a:off x="292608" y="3822192"/>
+            <a:off x="292608" y="4042192"/>
             <a:ext cx="5650992" cy="2724912"/>
           </a:xfrm>
           <a:prstGeom prst="roundRect">
@@ -1503,7 +1534,7 @@
         </p:nvSpPr>
         <p:spPr>
           <a:xfrm>
-            <a:off x="438912" y="3950208"/>
+            <a:off x="438912" y="4170208"/>
             <a:ext cx="5358384" cy="310896"/>
           </a:xfrm>
           <a:prstGeom prst="roundRect">
@@ -1525,7 +1556,7 @@
         </p:nvSpPr>
         <p:spPr>
           <a:xfrm>
-            <a:off x="438912" y="3950208"/>
+            <a:off x="438912" y="4170208"/>
             <a:ext cx="5358384" cy="310896"/>
           </a:xfrm>
           <a:prstGeom prst="rect">
@@ -1578,7 +1609,7 @@
         </p:nvSpPr>
         <p:spPr>
           <a:xfrm>
-            <a:off x="1289304" y="4261104"/>
+            <a:off x="1289304" y="4481104"/>
             <a:ext cx="0" cy="201168"/>
           </a:xfrm>
           <a:prstGeom prst="line">
@@ -1601,7 +1632,7 @@
         </p:nvSpPr>
         <p:spPr>
           <a:xfrm>
-            <a:off x="438912" y="4462272"/>
+            <a:off x="438912" y="4682272"/>
             <a:ext cx="1700784" cy="859536"/>
           </a:xfrm>
           <a:prstGeom prst="roundRect">
@@ -1623,7 +1654,7 @@
         </p:nvSpPr>
         <p:spPr>
           <a:xfrm>
-            <a:off x="475488" y="4462272"/>
+            <a:off x="475488" y="4682272"/>
             <a:ext cx="1627632" cy="859536"/>
           </a:xfrm>
           <a:prstGeom prst="rect">
@@ -1696,7 +1727,7 @@
         </p:nvSpPr>
         <p:spPr>
           <a:xfrm>
-            <a:off x="3118104" y="4261104"/>
+            <a:off x="3118104" y="4481104"/>
             <a:ext cx="0" cy="201168"/>
           </a:xfrm>
           <a:prstGeom prst="line">
@@ -1719,7 +1750,7 @@
         </p:nvSpPr>
         <p:spPr>
           <a:xfrm>
-            <a:off x="2267712" y="4462272"/>
+            <a:off x="2267712" y="4682272"/>
             <a:ext cx="1700784" cy="859536"/>
           </a:xfrm>
           <a:prstGeom prst="roundRect">
@@ -1741,7 +1772,7 @@
         </p:nvSpPr>
         <p:spPr>
           <a:xfrm>
-            <a:off x="2304288" y="4462272"/>
+            <a:off x="2304288" y="4682272"/>
             <a:ext cx="1627632" cy="859536"/>
           </a:xfrm>
           <a:prstGeom prst="rect">
@@ -1814,7 +1845,7 @@
         </p:nvSpPr>
         <p:spPr>
           <a:xfrm>
-            <a:off x="4946904" y="4261104"/>
+            <a:off x="4946904" y="4481104"/>
             <a:ext cx="0" cy="201168"/>
           </a:xfrm>
           <a:prstGeom prst="line">
@@ -1837,7 +1868,7 @@
         </p:nvSpPr>
         <p:spPr>
           <a:xfrm>
-            <a:off x="4096512" y="4462272"/>
+            <a:off x="4096512" y="4682272"/>
             <a:ext cx="1700784" cy="859536"/>
           </a:xfrm>
           <a:prstGeom prst="roundRect">
@@ -1859,7 +1890,7 @@
         </p:nvSpPr>
         <p:spPr>
           <a:xfrm>
-            <a:off x="4133088" y="4462272"/>
+            <a:off x="4133088" y="4682272"/>
             <a:ext cx="1627632" cy="859536"/>
           </a:xfrm>
           <a:prstGeom prst="rect">
@@ -1932,7 +1963,7 @@
         </p:nvSpPr>
         <p:spPr>
           <a:xfrm>
-            <a:off x="438912" y="5449824"/>
+            <a:off x="438912" y="5669824"/>
             <a:ext cx="5358384" cy="292608"/>
           </a:xfrm>
           <a:prstGeom prst="roundRect">
@@ -1954,7 +1985,7 @@
         </p:nvSpPr>
         <p:spPr>
           <a:xfrm>
-            <a:off x="438912" y="5449824"/>
+            <a:off x="438912" y="5669824"/>
             <a:ext cx="5358384" cy="292608"/>
           </a:xfrm>
           <a:prstGeom prst="rect">
@@ -1993,7 +2024,7 @@
         </p:nvSpPr>
         <p:spPr>
           <a:xfrm>
-            <a:off x="438912" y="5779008"/>
+            <a:off x="438912" y="5999008"/>
             <a:ext cx="5358384" cy="292608"/>
           </a:xfrm>
           <a:prstGeom prst="roundRect">
@@ -2015,7 +2046,7 @@
         </p:nvSpPr>
         <p:spPr>
           <a:xfrm>
-            <a:off x="438912" y="5779008"/>
+            <a:off x="438912" y="5999008"/>
             <a:ext cx="5358384" cy="292608"/>
           </a:xfrm>
           <a:prstGeom prst="rect">
@@ -2054,7 +2085,7 @@
         </p:nvSpPr>
         <p:spPr>
           <a:xfrm>
-            <a:off x="438912" y="6108192"/>
+            <a:off x="438912" y="6328192"/>
             <a:ext cx="5358384" cy="274320"/>
           </a:xfrm>
           <a:prstGeom prst="rect">
@@ -3193,7 +3224,7 @@
         <p:spPr>
           <a:xfrm>
             <a:off x="6291072" y="3108960"/>
-            <a:ext cx="5449824" cy="859536"/>
+            <a:ext cx="5449824" cy="900000"/>
           </a:xfrm>
           <a:prstGeom prst="rect">
             <a:avLst/>
@@ -3218,6 +3249,26 @@
                 <a:cs typeface="Segoe UI" pitchFamily="34" charset="-120"/>
               </a:rPr>
               <a:t>Set the stage on Agentic AI + the Foundry platform, the CLM scenario and the IQ family (Foundry IQ / Web IQ). Includes a short demo of the assistant answering in Teams and firing a renewal alert. Two decks: FSI-Legal + industry-agnostic.</a:t>
+            </a:r>
+            <a:endParaRPr lang="en-US" sz="930" dirty="0"/>
+          </a:p>
+          <a:p>
+            <a:pPr algn="l" indent="0" marL="0">
+              <a:spcBef>
+                <a:spcPts val="500"/>
+              </a:spcBef>
+              <a:buNone/>
+            </a:pPr>
+            <a:r>
+              <a:rPr lang="en-US" sz="930" dirty="0">
+                <a:solidFill>
+                  <a:srgbClr val="2B2B2B"/>
+                </a:solidFill>
+                <a:latin typeface="Segoe UI" pitchFamily="34" charset="0"/>
+                <a:ea typeface="Segoe UI" pitchFamily="34" charset="-122"/>
+                <a:cs typeface="Segoe UI" pitchFamily="34" charset="-120"/>
+              </a:rPr>
+              <a:t>Covers the multi-model, multi-agent pattern (orchestrator + grounded specialists), grounding and citations with Foundry IQ, the GenAIOps loop — tracing, evaluation and safety — and MCP publishing to Microsoft 365 Copilot &amp; Teams. ~45–60 min: slides plus a live demo, no coding required to follow along.</a:t>
             </a:r>
             <a:endParaRPr lang="en-US" sz="930" dirty="0"/>
           </a:p>

</xml_diff>

<commit_message>
docs(marketing): rewrite Tech Talk box as clear three-beats overview
Replace the two dense Tech Talk paragraphs with a scannable three-beats
structure (Transformation & impact / Architecture & services / Build ->
Deploy -> Operate) modeled on the sibling Agentic AI Hacks decks. Bold
lead-ins, tighter copy; the two-deck note is dropped from the body since
the header already shows Agnostic / FSI-Legal.

Co-authored-by: Copilot App <223556219+Copilot@users.noreply.github.com>
Copilot-Session: 2fc86db1-1f76-4b83-b234-329556a5f335
</commit_message>
<xml_diff>
--- a/docs/marketing/CLM-Microhack-BOM.pptx
+++ b/docs/marketing/CLM-Microhack-BOM.pptx
@@ -3240,7 +3240,7 @@
               <a:buNone/>
             </a:pPr>
             <a:r>
-              <a:rPr lang="en-US" sz="930" dirty="0">
+              <a:rPr lang="en-US" sz="820" dirty="0">
                 <a:solidFill>
                   <a:srgbClr val="2B2B2B"/>
                 </a:solidFill>
@@ -3248,19 +3248,19 @@
                 <a:ea typeface="Segoe UI" pitchFamily="34" charset="-122"/>
                 <a:cs typeface="Segoe UI" pitchFamily="34" charset="-120"/>
               </a:rPr>
-              <a:t>Set the stage on Agentic AI + the Foundry platform, the CLM scenario and the IQ family (Foundry IQ / Web IQ). Includes a short demo of the assistant answering in Teams and firing a renewal alert. Two decks: FSI-Legal + industry-agnostic.</a:t>
-            </a:r>
-            <a:endParaRPr lang="en-US" sz="930" dirty="0"/>
+              <a:t>A short Tech Talk sets the stage on Agentic AI for contracts, in three beats:</a:t>
+            </a:r>
+            <a:endParaRPr lang="en-US" sz="820" dirty="0"/>
           </a:p>
           <a:p>
             <a:pPr algn="l" indent="0" marL="0">
               <a:spcBef>
-                <a:spcPts val="500"/>
+                <a:spcPts val="200"/>
               </a:spcBef>
               <a:buNone/>
             </a:pPr>
             <a:r>
-              <a:rPr lang="en-US" sz="930" dirty="0">
+              <a:rPr lang="en-US" sz="820" b="1" dirty="0">
                 <a:solidFill>
                   <a:srgbClr val="2B2B2B"/>
                 </a:solidFill>
@@ -3268,9 +3268,82 @@
                 <a:ea typeface="Segoe UI" pitchFamily="34" charset="-122"/>
                 <a:cs typeface="Segoe UI" pitchFamily="34" charset="-120"/>
               </a:rPr>
-              <a:t>Covers the multi-model, multi-agent pattern (orchestrator + grounded specialists), grounding and citations with Foundry IQ, the GenAIOps loop — tracing, evaluation and safety — and MCP publishing to Microsoft 365 Copilot &amp; Teams. ~45–60 min: slides plus a live demo, no coding required to follow along.</a:t>
-            </a:r>
-            <a:endParaRPr lang="en-US" sz="930" dirty="0"/>
+              <a:t>Transformation &amp; impact — </a:t>
+            </a:r>
+            <a:r>
+              <a:rPr lang="en-US" sz="820" dirty="0">
+                <a:solidFill>
+                  <a:srgbClr val="2B2B2B"/>
+                </a:solidFill>
+                <a:latin typeface="Segoe UI" pitchFamily="34" charset="0"/>
+                <a:ea typeface="Segoe UI" pitchFamily="34" charset="-122"/>
+                <a:cs typeface="Segoe UI" pitchFamily="34" charset="-120"/>
+              </a:rPr>
+              <a:t>moving from copilots to autonomous, reasoning agents — value in speed, risk and compliance, on Azure AI Foundry.</a:t>
+            </a:r>
+            <a:endParaRPr lang="en-US" sz="820" dirty="0"/>
+          </a:p>
+          <a:p>
+            <a:pPr algn="l" indent="0" marL="0">
+              <a:spcBef>
+                <a:spcPts val="200"/>
+              </a:spcBef>
+              <a:buNone/>
+            </a:pPr>
+            <a:r>
+              <a:rPr lang="en-US" sz="820" b="1" dirty="0">
+                <a:solidFill>
+                  <a:srgbClr val="2B2B2B"/>
+                </a:solidFill>
+                <a:latin typeface="Segoe UI" pitchFamily="34" charset="0"/>
+                <a:ea typeface="Segoe UI" pitchFamily="34" charset="-122"/>
+                <a:cs typeface="Segoe UI" pitchFamily="34" charset="-120"/>
+              </a:rPr>
+              <a:t>Architecture &amp; services — </a:t>
+            </a:r>
+            <a:r>
+              <a:rPr lang="en-US" sz="820" dirty="0">
+                <a:solidFill>
+                  <a:srgbClr val="2B2B2B"/>
+                </a:solidFill>
+                <a:latin typeface="Segoe UI" pitchFamily="34" charset="0"/>
+                <a:ea typeface="Segoe UI" pitchFamily="34" charset="-122"/>
+                <a:cs typeface="Segoe UI" pitchFamily="34" charset="-120"/>
+              </a:rPr>
+              <a:t>the multi-model, multi-agent pattern (orchestrator + grounded specialists) and the exact services used — Foundry IQ / Web IQ grounding and citations — familiar before you start.</a:t>
+            </a:r>
+            <a:endParaRPr lang="en-US" sz="820" dirty="0"/>
+          </a:p>
+          <a:p>
+            <a:pPr algn="l" indent="0" marL="0">
+              <a:spcBef>
+                <a:spcPts val="200"/>
+              </a:spcBef>
+              <a:buNone/>
+            </a:pPr>
+            <a:r>
+              <a:rPr lang="en-US" sz="820" b="1" dirty="0">
+                <a:solidFill>
+                  <a:srgbClr val="2B2B2B"/>
+                </a:solidFill>
+                <a:latin typeface="Segoe UI" pitchFamily="34" charset="0"/>
+                <a:ea typeface="Segoe UI" pitchFamily="34" charset="-122"/>
+                <a:cs typeface="Segoe UI" pitchFamily="34" charset="-120"/>
+              </a:rPr>
+              <a:t>Build → Deploy → Operate — </a:t>
+            </a:r>
+            <a:r>
+              <a:rPr lang="en-US" sz="820" dirty="0">
+                <a:solidFill>
+                  <a:srgbClr val="2B2B2B"/>
+                </a:solidFill>
+                <a:latin typeface="Segoe UI" pitchFamily="34" charset="0"/>
+                <a:ea typeface="Segoe UI" pitchFamily="34" charset="-122"/>
+                <a:cs typeface="Segoe UI" pitchFamily="34" charset="-120"/>
+              </a:rPr>
+              <a:t>build the agents, run the GenAIOps loop (tracing, evaluation, safety), and publish via MCP to Microsoft 365 Copilot &amp; Teams — capped with a live demo.</a:t>
+            </a:r>
+            <a:endParaRPr lang="en-US" sz="820" dirty="0"/>
           </a:p>
         </p:txBody>
       </p:sp>

</xml_diff>

<commit_message>
Merge reference-draft feature with upstream improve-a-draft mode
</commit_message>
<xml_diff>
--- a/docs/marketing/CLM-Microhack-BOM.pptx
+++ b/docs/marketing/CLM-Microhack-BOM.pptx
@@ -4,12 +4,12 @@
   <p:sldMasterIdLst>
     <p:sldMasterId id="2147483648" r:id="rId1"/>
   </p:sldMasterIdLst>
+  <p:notesMasterIdLst>
+    <p:notesMasterId r:id="rId3"/>
+  </p:notesMasterIdLst>
   <p:sldIdLst>
     <p:sldId id="256" r:id="rId2"/>
   </p:sldIdLst>
-  <p:notesMasterIdLst>
-    <p:notesMasterId r:id="rId3"/>
-  </p:notesMasterIdLst>
   <p:sldSz cx="12192000" cy="6858000"/>
   <p:notesSz cx="6858000" cy="12192000"/>
   <p:defaultTextStyle>
@@ -104,6 +104,11 @@
       </a:defRPr>
     </a:lvl9pPr>
   </p:defaultTextStyle>
+  <p:extLst>
+    <p:ext uri="{EFAFB233-063F-42B5-8137-9DF3F51BA10A}">
+      <p15:sldGuideLst xmlns:p15="http://schemas.microsoft.com/office/powerpoint/2012/main"/>
+    </p:ext>
+  </p:extLst>
 </p:presentation>
 </file>
 
@@ -129,234 +134,10 @@
           <a:chExt cx="0" cy="0"/>
         </a:xfrm>
       </p:grpSpPr>
-      <p:sp>
-        <p:nvSpPr>
-          <p:cNvPr id="2" name="Header Placeholder 1"/>
-          <p:cNvSpPr>
-            <a:spLocks noGrp="1"/>
-          </p:cNvSpPr>
-          <p:nvPr>
-            <p:ph type="hdr" sz="quarter"/>
-          </p:nvPr>
-        </p:nvSpPr>
-        <p:spPr>
-          <a:xfrm>
-            <a:off x="0" y="0"/>
-            <a:ext cx="2971800" cy="458788"/>
-          </a:xfrm>
-          <a:prstGeom prst="rect">
-            <a:avLst/>
-          </a:prstGeom>
-        </p:spPr>
-        <p:txBody>
-          <a:bodyPr vert="horz" lIns="91440" tIns="45720" rIns="91440" bIns="45720" rtlCol="0"/>
-          <a:lstStyle>
-            <a:lvl1pPr algn="l">
-              <a:defRPr sz="1200"/>
-            </a:lvl1pPr>
-          </a:lstStyle>
-          <a:p>
-            <a:endParaRPr lang="en-US"/>
-          </a:p>
-        </p:txBody>
-      </p:sp>
-      <p:sp>
-        <p:nvSpPr>
-          <p:cNvPr id="3" name="Date Placeholder 2"/>
-          <p:cNvSpPr>
-            <a:spLocks noGrp="1"/>
-          </p:cNvSpPr>
-          <p:nvPr>
-            <p:ph type="dt" idx="1"/>
-          </p:nvPr>
-        </p:nvSpPr>
-        <p:spPr>
-          <a:xfrm>
-            <a:off x="3884613" y="0"/>
-            <a:ext cx="2971800" cy="458788"/>
-          </a:xfrm>
-          <a:prstGeom prst="rect">
-            <a:avLst/>
-          </a:prstGeom>
-        </p:spPr>
-        <p:txBody>
-          <a:bodyPr vert="horz" lIns="91440" tIns="45720" rIns="91440" bIns="45720" rtlCol="0"/>
-          <a:lstStyle>
-            <a:lvl1pPr algn="r">
-              <a:defRPr sz="1200"/>
-            </a:lvl1pPr>
-          </a:lstStyle>
-          <a:p>
-            <a:fld id="{5282F153-3F37-0F45-9E97-73ACFA13230C}" type="datetimeFigureOut">
-              <a:rPr lang="en-US"/>
-              <a:t>7/23/19</a:t>
-            </a:fld>
-            <a:endParaRPr lang="en-US"/>
-          </a:p>
-        </p:txBody>
-      </p:sp>
-      <p:sp>
-        <p:nvSpPr>
-          <p:cNvPr id="4" name="Slide Image Placeholder 3"/>
-          <p:cNvSpPr>
-            <a:spLocks noGrp="1" noRot="1" noChangeAspect="1"/>
-          </p:cNvSpPr>
-          <p:nvPr>
-            <p:ph type="sldImg" idx="2"/>
-          </p:nvPr>
-        </p:nvSpPr>
-        <p:spPr>
-          <a:xfrm>
-            <a:off x="685800" y="1143000"/>
-            <a:ext cx="5486400" cy="3086100"/>
-          </a:xfrm>
-          <a:prstGeom prst="rect">
-            <a:avLst/>
-          </a:prstGeom>
-          <a:noFill/>
-          <a:ln w="12700">
-            <a:solidFill>
-              <a:prstClr val="black"/>
-            </a:solidFill>
-          </a:ln>
-        </p:spPr>
-        <p:txBody>
-          <a:bodyPr vert="horz" lIns="91440" tIns="45720" rIns="91440" bIns="45720" rtlCol="0" anchor="ctr"/>
-          <a:lstStyle/>
-          <a:p>
-            <a:endParaRPr lang="en-US"/>
-          </a:p>
-        </p:txBody>
-      </p:sp>
-      <p:sp>
-        <p:nvSpPr>
-          <p:cNvPr id="5" name="Notes Placeholder 4"/>
-          <p:cNvSpPr>
-            <a:spLocks noGrp="1"/>
-          </p:cNvSpPr>
-          <p:nvPr>
-            <p:ph type="body" sz="quarter" idx="3"/>
-          </p:nvPr>
-        </p:nvSpPr>
-        <p:spPr>
-          <a:xfrm>
-            <a:off x="685800" y="4400550"/>
-            <a:ext cx="5486400" cy="3600450"/>
-          </a:xfrm>
-          <a:prstGeom prst="rect">
-            <a:avLst/>
-          </a:prstGeom>
-        </p:spPr>
-        <p:txBody>
-          <a:bodyPr vert="horz" lIns="91440" tIns="45720" rIns="91440" bIns="45720" rtlCol="0"/>
-          <a:lstStyle/>
-          <a:p>
-            <a:pPr lvl="0"/>
-            <a:r>
-              <a:rPr lang="en-US"/>
-              <a:t>Click to edit Master text styles</a:t>
-            </a:r>
-          </a:p>
-          <a:p>
-            <a:pPr lvl="1"/>
-            <a:r>
-              <a:rPr lang="en-US"/>
-              <a:t>Second level</a:t>
-            </a:r>
-          </a:p>
-          <a:p>
-            <a:pPr lvl="2"/>
-            <a:r>
-              <a:rPr lang="en-US"/>
-              <a:t>Third level</a:t>
-            </a:r>
-          </a:p>
-          <a:p>
-            <a:pPr lvl="3"/>
-            <a:r>
-              <a:rPr lang="en-US"/>
-              <a:t>Fourth level</a:t>
-            </a:r>
-          </a:p>
-          <a:p>
-            <a:pPr lvl="4"/>
-            <a:r>
-              <a:rPr lang="en-US"/>
-              <a:t>Fifth level</a:t>
-            </a:r>
-          </a:p>
-        </p:txBody>
-      </p:sp>
-      <p:sp>
-        <p:nvSpPr>
-          <p:cNvPr id="6" name="Footer Placeholder 5"/>
-          <p:cNvSpPr>
-            <a:spLocks noGrp="1"/>
-          </p:cNvSpPr>
-          <p:nvPr>
-            <p:ph type="ftr" sz="quarter" idx="4"/>
-          </p:nvPr>
-        </p:nvSpPr>
-        <p:spPr>
-          <a:xfrm>
-            <a:off x="0" y="8685213"/>
-            <a:ext cx="2971800" cy="458787"/>
-          </a:xfrm>
-          <a:prstGeom prst="rect">
-            <a:avLst/>
-          </a:prstGeom>
-        </p:spPr>
-        <p:txBody>
-          <a:bodyPr vert="horz" lIns="91440" tIns="45720" rIns="91440" bIns="45720" rtlCol="0" anchor="b"/>
-          <a:lstStyle>
-            <a:lvl1pPr algn="l">
-              <a:defRPr sz="1200"/>
-            </a:lvl1pPr>
-          </a:lstStyle>
-          <a:p>
-            <a:endParaRPr lang="en-US"/>
-          </a:p>
-        </p:txBody>
-      </p:sp>
-      <p:sp>
-        <p:nvSpPr>
-          <p:cNvPr id="7" name="Slide Number Placeholder 6"/>
-          <p:cNvSpPr>
-            <a:spLocks noGrp="1"/>
-          </p:cNvSpPr>
-          <p:nvPr>
-            <p:ph type="sldNum" sz="quarter" idx="5"/>
-          </p:nvPr>
-        </p:nvSpPr>
-        <p:spPr>
-          <a:xfrm>
-            <a:off x="3884613" y="8685213"/>
-            <a:ext cx="2971800" cy="458787"/>
-          </a:xfrm>
-          <a:prstGeom prst="rect">
-            <a:avLst/>
-          </a:prstGeom>
-        </p:spPr>
-        <p:txBody>
-          <a:bodyPr vert="horz" lIns="91440" tIns="45720" rIns="91440" bIns="45720" rtlCol="0" anchor="b"/>
-          <a:lstStyle>
-            <a:lvl1pPr algn="r">
-              <a:defRPr sz="1200"/>
-            </a:lvl1pPr>
-          </a:lstStyle>
-          <a:p>
-            <a:fld id="{CE5E9CC1-C706-0F49-92D6-E571CC5EEA8F}" type="slidenum">
-              <a:rPr lang="en-US"/>
-              <a:t>‹#›</a:t>
-            </a:fld>
-            <a:endParaRPr lang="en-US"/>
-          </a:p>
-        </p:txBody>
-      </p:sp>
     </p:spTree>
     <p:extLst>
       <p:ext uri="{BB962C8B-B14F-4D97-AF65-F5344CB8AC3E}">
-        <p14:creationId xmlns:p14="http://schemas.microsoft.com/office/powerpoint/2010/main" val="1024086991"/>
+        <p14:creationId xmlns:p14="http://schemas.microsoft.com/office/powerpoint/2010/main" val="567719757"/>
       </p:ext>
     </p:extLst>
   </p:cSld>
@@ -500,10 +281,6 @@
           <a:bodyPr/>
           <a:lstStyle/>
           <a:p>
-            <a:r>
-              <a:rPr lang="en-US" dirty="0"/>
-              <a:t/>
-            </a:r>
             <a:endParaRPr lang="en-US" dirty="0"/>
           </a:p>
         </p:txBody>
@@ -577,6 +354,11 @@
 <file path=ppt/slideMasters/slideMaster1.xml><?xml version="1.0" encoding="utf-8"?>
 <p:sldMaster xmlns:a="http://schemas.openxmlformats.org/drawingml/2006/main" xmlns:r="http://schemas.openxmlformats.org/officeDocument/2006/relationships" xmlns:p="http://schemas.openxmlformats.org/presentationml/2006/main">
   <p:cSld>
+    <p:bg>
+      <p:bgRef idx="1001">
+        <a:schemeClr val="bg1"/>
+      </p:bgRef>
+    </p:bg>
     <p:spTree>
       <p:nvGrpSpPr>
         <p:cNvPr id="1" name=""/>
@@ -857,7 +639,7 @@
     <p:bg>
       <p:bgPr>
         <a:blipFill dpi="0" rotWithShape="1">
-          <a:blip r:embed="rId1">
+          <a:blip r:embed="rId3">
             <a:lum/>
           </a:blip>
           <a:srcRect/>
@@ -903,7 +685,7 @@
           <a:bodyPr wrap="square" lIns="0" tIns="0" rIns="0" bIns="0" rtlCol="0" anchor="ctr"/>
           <a:lstStyle/>
           <a:p>
-            <a:pPr algn="l" indent="0" marL="0">
+            <a:pPr marL="0" indent="0" algn="l">
               <a:buNone/>
             </a:pPr>
             <a:r>
@@ -917,9 +699,6 @@
               </a:rPr>
               <a:t>Agentic AI Hacks</a:t>
             </a:r>
-            <a:pPr algn="l" indent="0" marL="0">
-              <a:buNone/>
-            </a:pPr>
             <a:r>
               <a:rPr lang="en-US" sz="2700" b="1" dirty="0">
                 <a:solidFill>
@@ -929,11 +708,8 @@
                 <a:ea typeface="Segoe UI" pitchFamily="34" charset="-122"/>
                 <a:cs typeface="Segoe UI" pitchFamily="34" charset="-120"/>
               </a:rPr>
-              <a:t xml:space="preserve">  |  </a:t>
+              <a:t>  |  </a:t>
             </a:r>
-            <a:pPr algn="l" indent="0" marL="0">
-              <a:buNone/>
-            </a:pPr>
             <a:r>
               <a:rPr lang="en-US" sz="2700" b="1" dirty="0">
                 <a:solidFill>
@@ -958,7 +734,7 @@
           <p:nvPr/>
         </p:nvPicPr>
         <p:blipFill>
-          <a:blip r:embed="rId2"/>
+          <a:blip r:embed="rId4"/>
           <a:stretch>
             <a:fillRect/>
           </a:stretch>
@@ -994,7 +770,7 @@
           <a:bodyPr wrap="square" lIns="0" tIns="0" rIns="0" bIns="0" rtlCol="0" anchor="ctr"/>
           <a:lstStyle/>
           <a:p>
-            <a:pPr algn="l" indent="0" marL="0">
+            <a:pPr marL="0" indent="0" algn="l">
               <a:buNone/>
             </a:pPr>
             <a:r>
@@ -1033,7 +809,7 @@
           <a:bodyPr wrap="square" lIns="0" tIns="0" rIns="0" bIns="0" rtlCol="0" anchor="ctr"/>
           <a:lstStyle/>
           <a:p>
-            <a:pPr algn="r" indent="0" marL="0">
+            <a:pPr marL="0" indent="0" algn="r">
               <a:buNone/>
             </a:pPr>
             <a:r>
@@ -1045,11 +821,8 @@
                 <a:ea typeface="Segoe UI" pitchFamily="34" charset="-122"/>
                 <a:cs typeface="Segoe UI" pitchFamily="34" charset="-120"/>
               </a:rPr>
-              <a:t xml:space="preserve">Reg Page Copy </a:t>
+              <a:t>Reg Page Copy </a:t>
             </a:r>
-            <a:pPr algn="r" indent="0" marL="0">
-              <a:buNone/>
-            </a:pPr>
             <a:r>
               <a:rPr lang="en-US" sz="850" b="1" dirty="0">
                 <a:solidFill>
@@ -1061,9 +834,6 @@
               </a:rPr>
               <a:t>HERE</a:t>
             </a:r>
-            <a:pPr algn="r" indent="0" marL="0">
-              <a:buNone/>
-            </a:pPr>
             <a:r>
               <a:rPr lang="en-US" sz="850" dirty="0">
                 <a:solidFill>
@@ -1073,11 +843,8 @@
                 <a:ea typeface="Segoe UI" pitchFamily="34" charset="-122"/>
                 <a:cs typeface="Segoe UI" pitchFamily="34" charset="-120"/>
               </a:rPr>
-              <a:t xml:space="preserve"> / Invitation Copy </a:t>
+              <a:t> / Invitation Copy </a:t>
             </a:r>
-            <a:pPr algn="r" indent="0" marL="0">
-              <a:buNone/>
-            </a:pPr>
             <a:r>
               <a:rPr lang="en-US" sz="850" b="1" dirty="0">
                 <a:solidFill>
@@ -1089,9 +856,6 @@
               </a:rPr>
               <a:t>HERE</a:t>
             </a:r>
-            <a:pPr algn="r" indent="0" marL="0">
-              <a:buNone/>
-            </a:pPr>
             <a:r>
               <a:rPr lang="en-US" sz="850" dirty="0">
                 <a:solidFill>
@@ -1101,11 +865,8 @@
                 <a:ea typeface="Segoe UI" pitchFamily="34" charset="-122"/>
                 <a:cs typeface="Segoe UI" pitchFamily="34" charset="-120"/>
               </a:rPr>
-              <a:t xml:space="preserve"> / Marketing BOM </a:t>
+              <a:t> / Marketing BOM </a:t>
             </a:r>
-            <a:pPr algn="r" indent="0" marL="0">
-              <a:buNone/>
-            </a:pPr>
             <a:r>
               <a:rPr lang="en-US" sz="850" b="1" dirty="0">
                 <a:solidFill>
@@ -1130,7 +891,7 @@
           <p:nvPr/>
         </p:nvPicPr>
         <p:blipFill>
-          <a:blip r:embed="rId3"/>
+          <a:blip r:embed="rId4"/>
           <a:stretch>
             <a:fillRect/>
           </a:stretch>
@@ -1166,7 +927,7 @@
           <a:bodyPr wrap="square" lIns="0" tIns="0" rIns="0" bIns="0" rtlCol="0" anchor="ctr"/>
           <a:lstStyle/>
           <a:p>
-            <a:pPr algn="l" indent="0" marL="0">
+            <a:pPr marL="0" indent="0" algn="l">
               <a:buNone/>
             </a:pPr>
             <a:r>
@@ -1210,13 +971,20 @@
             <a:prstDash val="solid"/>
           </a:ln>
           <a:effectLst>
-            <a:outerShdw sx="100000" sy="100000" kx="0" ky="0" algn="bl" rotWithShape="0" blurRad="63500" dist="25400" dir="8100000">
+            <a:outerShdw blurRad="63500" dist="25400" dir="8100000" algn="bl" rotWithShape="0">
               <a:srgbClr val="1F3864">
                 <a:alpha val="12000"/>
               </a:srgbClr>
             </a:outerShdw>
           </a:effectLst>
         </p:spPr>
+        <p:txBody>
+          <a:bodyPr/>
+          <a:lstStyle/>
+          <a:p>
+            <a:endParaRPr lang="en-DE"/>
+          </a:p>
+        </p:txBody>
       </p:sp>
       <p:sp>
         <p:nvSpPr>
@@ -1239,7 +1007,7 @@
           <a:bodyPr wrap="square" lIns="0" tIns="0" rIns="0" bIns="0" rtlCol="0" anchor="t"/>
           <a:lstStyle/>
           <a:p>
-            <a:pPr algn="l" indent="0" marL="0">
+            <a:pPr marL="0" indent="0" algn="l">
               <a:spcAft>
                 <a:spcPts val="600"/>
               </a:spcAft>
@@ -1259,7 +1027,7 @@
             <a:endParaRPr lang="en-US" sz="950" dirty="0"/>
           </a:p>
           <a:p>
-            <a:pPr algn="l" indent="0" marL="0">
+            <a:pPr marL="0" indent="0" algn="l">
               <a:spcAft>
                 <a:spcPts val="600"/>
               </a:spcAft>
@@ -1279,21 +1047,7 @@
             <a:endParaRPr lang="en-US" sz="950" dirty="0"/>
           </a:p>
           <a:p>
-            <a:pPr algn="l" indent="0" marL="0">
-              <a:buNone/>
-            </a:pPr>
-            <a:r>
-              <a:rPr lang="en-US" sz="950" dirty="0">
-                <a:solidFill>
-                  <a:srgbClr val="2B2B2B"/>
-                </a:solidFill>
-                <a:latin typeface="Segoe UI" pitchFamily="34" charset="0"/>
-                <a:ea typeface="Segoe UI" pitchFamily="34" charset="-122"/>
-                <a:cs typeface="Segoe UI" pitchFamily="34" charset="-120"/>
-              </a:rPr>
-              <a:t/>
-            </a:r>
-            <a:pPr algn="l" indent="0" marL="0">
+            <a:pPr marL="0" indent="0" algn="l">
               <a:buNone/>
             </a:pPr>
             <a:r>
@@ -1305,11 +1059,8 @@
                 <a:ea typeface="Segoe UI" pitchFamily="34" charset="-122"/>
                 <a:cs typeface="Segoe UI" pitchFamily="34" charset="-120"/>
               </a:rPr>
-              <a:t xml:space="preserve">Agentic CLM </a:t>
+              <a:t>Agentic CLM </a:t>
             </a:r>
-            <a:pPr algn="l" indent="0" marL="0">
-              <a:buNone/>
-            </a:pPr>
             <a:r>
               <a:rPr lang="en-US" sz="950" dirty="0">
                 <a:solidFill>
@@ -1324,7 +1075,7 @@
             <a:endParaRPr lang="en-US" sz="950" dirty="0"/>
           </a:p>
           <a:p>
-            <a:pPr algn="l" indent="0" marL="0">
+            <a:pPr marL="0" indent="0" algn="l">
               <a:spcBef>
                 <a:spcPts val="600"/>
               </a:spcBef>
@@ -1339,7 +1090,7 @@
                 <a:ea typeface="Segoe UI" pitchFamily="34" charset="-122"/>
                 <a:cs typeface="Segoe UI" pitchFamily="34" charset="-120"/>
               </a:rPr>
-              <a:t xml:space="preserve">Concretely: </a:t>
+              <a:t>Concretely: </a:t>
             </a:r>
             <a:r>
               <a:rPr lang="en-US" sz="950" dirty="0">
@@ -1401,7 +1152,7 @@
           <a:bodyPr wrap="square" lIns="0" tIns="0" rIns="0" bIns="0" rtlCol="0" anchor="ctr"/>
           <a:lstStyle/>
           <a:p>
-            <a:pPr algn="l" indent="0" marL="0">
+            <a:pPr marL="0" indent="0" algn="l">
               <a:buNone/>
             </a:pPr>
             <a:r>
@@ -1445,13 +1196,20 @@
             <a:prstDash val="solid"/>
           </a:ln>
           <a:effectLst>
-            <a:outerShdw sx="100000" sy="100000" kx="0" ky="0" algn="bl" rotWithShape="0" blurRad="63500" dist="25400" dir="8100000">
+            <a:outerShdw blurRad="63500" dist="25400" dir="8100000" algn="bl" rotWithShape="0">
               <a:srgbClr val="1F3864">
                 <a:alpha val="12000"/>
               </a:srgbClr>
             </a:outerShdw>
           </a:effectLst>
         </p:spPr>
+        <p:txBody>
+          <a:bodyPr/>
+          <a:lstStyle/>
+          <a:p>
+            <a:endParaRPr lang="en-DE"/>
+          </a:p>
+        </p:txBody>
       </p:sp>
       <p:sp>
         <p:nvSpPr>
@@ -1474,7 +1232,7 @@
           <a:bodyPr wrap="square" lIns="0" tIns="0" rIns="0" bIns="0" rtlCol="0" anchor="ctr"/>
           <a:lstStyle/>
           <a:p>
-            <a:pPr algn="l" indent="0" marL="0">
+            <a:pPr marL="0" indent="0" algn="l">
               <a:buNone/>
             </a:pPr>
             <a:r>
@@ -1518,13 +1276,20 @@
             <a:prstDash val="solid"/>
           </a:ln>
           <a:effectLst>
-            <a:outerShdw sx="100000" sy="100000" kx="0" ky="0" algn="bl" rotWithShape="0" blurRad="63500" dist="25400" dir="8100000">
+            <a:outerShdw blurRad="63500" dist="25400" dir="8100000" algn="bl" rotWithShape="0">
               <a:srgbClr val="1F3864">
                 <a:alpha val="12000"/>
               </a:srgbClr>
             </a:outerShdw>
           </a:effectLst>
         </p:spPr>
+        <p:txBody>
+          <a:bodyPr/>
+          <a:lstStyle/>
+          <a:p>
+            <a:endParaRPr lang="en-DE"/>
+          </a:p>
+        </p:txBody>
       </p:sp>
       <p:sp>
         <p:nvSpPr>
@@ -1547,6 +1312,13 @@
           </a:solidFill>
           <a:ln/>
         </p:spPr>
+        <p:txBody>
+          <a:bodyPr/>
+          <a:lstStyle/>
+          <a:p>
+            <a:endParaRPr lang="en-DE"/>
+          </a:p>
+        </p:txBody>
       </p:sp>
       <p:sp>
         <p:nvSpPr>
@@ -1569,7 +1341,7 @@
           <a:bodyPr wrap="square" lIns="0" tIns="0" rIns="0" bIns="0" rtlCol="0" anchor="ctr"/>
           <a:lstStyle/>
           <a:p>
-            <a:pPr algn="ctr" indent="0" marL="0">
+            <a:pPr marL="0" indent="0" algn="ctr">
               <a:buNone/>
             </a:pPr>
             <a:r>
@@ -1583,9 +1355,6 @@
               </a:rPr>
               <a:t>ORCHESTRATOR AGENT</a:t>
             </a:r>
-            <a:pPr algn="ctr" indent="0" marL="0">
-              <a:buNone/>
-            </a:pPr>
             <a:r>
               <a:rPr lang="en-US" sz="1000" dirty="0">
                 <a:solidFill>
@@ -1595,7 +1364,7 @@
                 <a:ea typeface="Segoe UI" pitchFamily="34" charset="-122"/>
                 <a:cs typeface="Segoe UI" pitchFamily="34" charset="-120"/>
               </a:rPr>
-              <a:t xml:space="preserve">    ·    GPT-5.4</a:t>
+              <a:t>    ·    GPT-5.4</a:t>
             </a:r>
             <a:endParaRPr lang="en-US" sz="1000" dirty="0"/>
           </a:p>
@@ -1623,6 +1392,13 @@
             <a:prstDash val="solid"/>
           </a:ln>
         </p:spPr>
+        <p:txBody>
+          <a:bodyPr/>
+          <a:lstStyle/>
+          <a:p>
+            <a:endParaRPr lang="en-DE"/>
+          </a:p>
+        </p:txBody>
       </p:sp>
       <p:sp>
         <p:nvSpPr>
@@ -1645,6 +1421,13 @@
           </a:solidFill>
           <a:ln/>
         </p:spPr>
+        <p:txBody>
+          <a:bodyPr/>
+          <a:lstStyle/>
+          <a:p>
+            <a:endParaRPr lang="en-DE"/>
+          </a:p>
+        </p:txBody>
       </p:sp>
       <p:sp>
         <p:nvSpPr>
@@ -1667,7 +1450,7 @@
           <a:bodyPr wrap="square" lIns="0" tIns="0" rIns="0" bIns="0" rtlCol="0" anchor="ctr"/>
           <a:lstStyle/>
           <a:p>
-            <a:pPr algn="ctr" indent="0" marL="0">
+            <a:pPr marL="0" indent="0" algn="ctr">
               <a:buNone/>
             </a:pPr>
             <a:r>
@@ -1684,7 +1467,7 @@
             <a:endParaRPr lang="en-US" sz="950" dirty="0"/>
           </a:p>
           <a:p>
-            <a:pPr algn="ctr" indent="0" marL="0">
+            <a:pPr marL="0" indent="0" algn="ctr">
               <a:buNone/>
             </a:pPr>
             <a:r>
@@ -1701,7 +1484,7 @@
             <a:endParaRPr lang="en-US" sz="950" dirty="0"/>
           </a:p>
           <a:p>
-            <a:pPr algn="ctr" indent="0" marL="0">
+            <a:pPr marL="0" indent="0" algn="ctr">
               <a:buNone/>
             </a:pPr>
             <a:r>
@@ -1741,6 +1524,13 @@
             <a:prstDash val="solid"/>
           </a:ln>
         </p:spPr>
+        <p:txBody>
+          <a:bodyPr/>
+          <a:lstStyle/>
+          <a:p>
+            <a:endParaRPr lang="en-DE"/>
+          </a:p>
+        </p:txBody>
       </p:sp>
       <p:sp>
         <p:nvSpPr>
@@ -1763,6 +1553,13 @@
           </a:solidFill>
           <a:ln/>
         </p:spPr>
+        <p:txBody>
+          <a:bodyPr/>
+          <a:lstStyle/>
+          <a:p>
+            <a:endParaRPr lang="en-DE"/>
+          </a:p>
+        </p:txBody>
       </p:sp>
       <p:sp>
         <p:nvSpPr>
@@ -1785,7 +1582,7 @@
           <a:bodyPr wrap="square" lIns="0" tIns="0" rIns="0" bIns="0" rtlCol="0" anchor="ctr"/>
           <a:lstStyle/>
           <a:p>
-            <a:pPr algn="ctr" indent="0" marL="0">
+            <a:pPr marL="0" indent="0" algn="ctr">
               <a:buNone/>
             </a:pPr>
             <a:r>
@@ -1802,7 +1599,7 @@
             <a:endParaRPr lang="en-US" sz="950" dirty="0"/>
           </a:p>
           <a:p>
-            <a:pPr algn="ctr" indent="0" marL="0">
+            <a:pPr marL="0" indent="0" algn="ctr">
               <a:buNone/>
             </a:pPr>
             <a:r>
@@ -1819,7 +1616,7 @@
             <a:endParaRPr lang="en-US" sz="950" dirty="0"/>
           </a:p>
           <a:p>
-            <a:pPr algn="ctr" indent="0" marL="0">
+            <a:pPr marL="0" indent="0" algn="ctr">
               <a:buNone/>
             </a:pPr>
             <a:r>
@@ -1859,6 +1656,13 @@
             <a:prstDash val="solid"/>
           </a:ln>
         </p:spPr>
+        <p:txBody>
+          <a:bodyPr/>
+          <a:lstStyle/>
+          <a:p>
+            <a:endParaRPr lang="en-DE"/>
+          </a:p>
+        </p:txBody>
       </p:sp>
       <p:sp>
         <p:nvSpPr>
@@ -1881,6 +1685,13 @@
           </a:solidFill>
           <a:ln/>
         </p:spPr>
+        <p:txBody>
+          <a:bodyPr/>
+          <a:lstStyle/>
+          <a:p>
+            <a:endParaRPr lang="en-DE"/>
+          </a:p>
+        </p:txBody>
       </p:sp>
       <p:sp>
         <p:nvSpPr>
@@ -1903,7 +1714,7 @@
           <a:bodyPr wrap="square" lIns="0" tIns="0" rIns="0" bIns="0" rtlCol="0" anchor="ctr"/>
           <a:lstStyle/>
           <a:p>
-            <a:pPr algn="ctr" indent="0" marL="0">
+            <a:pPr marL="0" indent="0" algn="ctr">
               <a:buNone/>
             </a:pPr>
             <a:r>
@@ -1920,7 +1731,7 @@
             <a:endParaRPr lang="en-US" sz="950" dirty="0"/>
           </a:p>
           <a:p>
-            <a:pPr algn="ctr" indent="0" marL="0">
+            <a:pPr marL="0" indent="0" algn="ctr">
               <a:buNone/>
             </a:pPr>
             <a:r>
@@ -1937,7 +1748,7 @@
             <a:endParaRPr lang="en-US" sz="950" dirty="0"/>
           </a:p>
           <a:p>
-            <a:pPr algn="ctr" indent="0" marL="0">
+            <a:pPr marL="0" indent="0" algn="ctr">
               <a:buNone/>
             </a:pPr>
             <a:r>
@@ -1976,6 +1787,13 @@
           </a:solidFill>
           <a:ln/>
         </p:spPr>
+        <p:txBody>
+          <a:bodyPr/>
+          <a:lstStyle/>
+          <a:p>
+            <a:endParaRPr lang="en-DE"/>
+          </a:p>
+        </p:txBody>
       </p:sp>
       <p:sp>
         <p:nvSpPr>
@@ -1998,7 +1816,7 @@
           <a:bodyPr wrap="square" lIns="0" tIns="0" rIns="0" bIns="0" rtlCol="0" anchor="ctr"/>
           <a:lstStyle/>
           <a:p>
-            <a:pPr algn="ctr" indent="0" marL="0">
+            <a:pPr marL="0" indent="0" algn="ctr">
               <a:buNone/>
             </a:pPr>
             <a:r>
@@ -2037,6 +1855,13 @@
           </a:solidFill>
           <a:ln/>
         </p:spPr>
+        <p:txBody>
+          <a:bodyPr/>
+          <a:lstStyle/>
+          <a:p>
+            <a:endParaRPr lang="en-DE"/>
+          </a:p>
+        </p:txBody>
       </p:sp>
       <p:sp>
         <p:nvSpPr>
@@ -2059,7 +1884,7 @@
           <a:bodyPr wrap="square" lIns="0" tIns="0" rIns="0" bIns="0" rtlCol="0" anchor="ctr"/>
           <a:lstStyle/>
           <a:p>
-            <a:pPr algn="ctr" indent="0" marL="0">
+            <a:pPr marL="0" indent="0" algn="ctr">
               <a:buNone/>
             </a:pPr>
             <a:r>
@@ -2098,7 +1923,7 @@
           <a:bodyPr wrap="square" lIns="0" tIns="0" rIns="0" bIns="0" rtlCol="0" anchor="ctr"/>
           <a:lstStyle/>
           <a:p>
-            <a:pPr algn="ctr" indent="0" marL="0">
+            <a:pPr marL="0" indent="0" algn="ctr">
               <a:buNone/>
             </a:pPr>
             <a:r>
@@ -2125,7 +1950,7 @@
           <p:nvPr/>
         </p:nvPicPr>
         <p:blipFill>
-          <a:blip r:embed="rId5"/>
+          <a:blip r:embed="rId4"/>
           <a:stretch>
             <a:fillRect/>
           </a:stretch>
@@ -2161,7 +1986,7 @@
           <a:bodyPr wrap="square" lIns="0" tIns="0" rIns="0" bIns="0" rtlCol="0" anchor="ctr"/>
           <a:lstStyle/>
           <a:p>
-            <a:pPr algn="l" indent="0" marL="0">
+            <a:pPr marL="0" indent="0" algn="l">
               <a:buNone/>
             </a:pPr>
             <a:r>
@@ -2181,7 +2006,7 @@
       </p:sp>
       <p:graphicFrame>
         <p:nvGraphicFramePr>
-          <p:cNvPr id="2" name="Table 0"/>
+          <p:cNvPr id="33" name="Table 0"/>
           <p:cNvGraphicFramePr>
             <a:graphicFrameLocks noGrp="1"/>
           </p:cNvGraphicFramePr>
@@ -2195,15 +2020,27 @@
         </p:nvGraphicFramePr>
         <p:xfrm>
           <a:off x="6144768" y="1225296"/>
-          <a:ext cx="5742432" cy="914400"/>
+          <a:ext cx="5742432" cy="1399032"/>
         </p:xfrm>
         <a:graphic>
           <a:graphicData uri="http://schemas.openxmlformats.org/drawingml/2006/table">
             <a:tbl>
               <a:tblPr/>
               <a:tblGrid>
-                <a:gridCol w="1371600"/>
-                <a:gridCol w="4370832"/>
+                <a:gridCol w="1371600">
+                  <a:extLst>
+                    <a:ext uri="{9D8B030D-6E8A-4147-A177-3AD203B41FA5}">
+                      <a16:colId xmlns:a16="http://schemas.microsoft.com/office/drawing/2014/main" val="20000"/>
+                    </a:ext>
+                  </a:extLst>
+                </a:gridCol>
+                <a:gridCol w="4370832">
+                  <a:extLst>
+                    <a:ext uri="{9D8B030D-6E8A-4147-A177-3AD203B41FA5}">
+                      <a16:colId xmlns:a16="http://schemas.microsoft.com/office/drawing/2014/main" val="20001"/>
+                    </a:ext>
+                  </a:extLst>
+                </a:gridCol>
               </a:tblGrid>
               <a:tr h="233172">
                 <a:tc>
@@ -2211,7 +2048,7 @@
                     <a:bodyPr/>
                     <a:lstStyle/>
                     <a:p>
-                      <a:pPr indent="0" marL="0">
+                      <a:pPr marL="0" indent="0">
                         <a:buNone/>
                       </a:pPr>
                       <a:r>
@@ -2232,7 +2069,7 @@
                       </a:endParaRPr>
                     </a:p>
                   </a:txBody>
-                  <a:tcPr marL="91440" marR="91440" marT="45720" marB="45720" anchor="ctr">
+                  <a:tcPr anchor="ctr">
                     <a:lnL w="6350" cap="flat" cmpd="sng" algn="ctr">
                       <a:solidFill>
                         <a:srgbClr val="D6DEE8"/>
@@ -2279,7 +2116,7 @@
                     <a:bodyPr/>
                     <a:lstStyle/>
                     <a:p>
-                      <a:pPr indent="0" marL="0">
+                      <a:pPr marL="0" indent="0">
                         <a:buNone/>
                       </a:pPr>
                       <a:r>
@@ -2300,7 +2137,7 @@
                       </a:endParaRPr>
                     </a:p>
                   </a:txBody>
-                  <a:tcPr marL="91440" marR="91440" marT="45720" marB="45720" anchor="ctr">
+                  <a:tcPr anchor="ctr">
                     <a:lnL w="6350" cap="flat" cmpd="sng" algn="ctr">
                       <a:solidFill>
                         <a:srgbClr val="D6DEE8"/>
@@ -2342,6 +2179,11 @@
                     </a:solidFill>
                   </a:tcPr>
                 </a:tc>
+                <a:extLst>
+                  <a:ext uri="{0D108BD9-81ED-4DB2-BD59-A6C34878D82A}">
+                    <a16:rowId xmlns:a16="http://schemas.microsoft.com/office/drawing/2014/main" val="10000"/>
+                  </a:ext>
+                </a:extLst>
               </a:tr>
               <a:tr h="233172">
                 <a:tc>
@@ -2349,7 +2191,7 @@
                     <a:bodyPr/>
                     <a:lstStyle/>
                     <a:p>
-                      <a:pPr indent="0" marL="0">
+                      <a:pPr marL="0" indent="0">
                         <a:buNone/>
                       </a:pPr>
                       <a:r>
@@ -2370,7 +2212,7 @@
                       </a:endParaRPr>
                     </a:p>
                   </a:txBody>
-                  <a:tcPr marL="91440" marR="91440" marT="45720" marB="45720" anchor="ctr">
+                  <a:tcPr anchor="ctr">
                     <a:lnL w="6350" cap="flat" cmpd="sng" algn="ctr">
                       <a:solidFill>
                         <a:srgbClr val="D6DEE8"/>
@@ -2417,7 +2259,7 @@
                     <a:bodyPr/>
                     <a:lstStyle/>
                     <a:p>
-                      <a:pPr indent="0" marL="0">
+                      <a:pPr marL="0" indent="0">
                         <a:buNone/>
                       </a:pPr>
                       <a:r>
@@ -2438,7 +2280,7 @@
                       </a:endParaRPr>
                     </a:p>
                   </a:txBody>
-                  <a:tcPr marL="91440" marR="91440" marT="45720" marB="45720" anchor="ctr">
+                  <a:tcPr anchor="ctr">
                     <a:lnL w="6350" cap="flat" cmpd="sng" algn="ctr">
                       <a:solidFill>
                         <a:srgbClr val="D6DEE8"/>
@@ -2480,6 +2322,11 @@
                     </a:solidFill>
                   </a:tcPr>
                 </a:tc>
+                <a:extLst>
+                  <a:ext uri="{0D108BD9-81ED-4DB2-BD59-A6C34878D82A}">
+                    <a16:rowId xmlns:a16="http://schemas.microsoft.com/office/drawing/2014/main" val="10001"/>
+                  </a:ext>
+                </a:extLst>
               </a:tr>
               <a:tr h="233172">
                 <a:tc>
@@ -2487,7 +2334,7 @@
                     <a:bodyPr/>
                     <a:lstStyle/>
                     <a:p>
-                      <a:pPr indent="0" marL="0">
+                      <a:pPr marL="0" indent="0">
                         <a:buNone/>
                       </a:pPr>
                       <a:r>
@@ -2508,7 +2355,7 @@
                       </a:endParaRPr>
                     </a:p>
                   </a:txBody>
-                  <a:tcPr marL="91440" marR="91440" marT="45720" marB="45720" anchor="ctr">
+                  <a:tcPr anchor="ctr">
                     <a:lnL w="6350" cap="flat" cmpd="sng" algn="ctr">
                       <a:solidFill>
                         <a:srgbClr val="D6DEE8"/>
@@ -2555,7 +2402,7 @@
                     <a:bodyPr/>
                     <a:lstStyle/>
                     <a:p>
-                      <a:pPr indent="0" marL="0">
+                      <a:pPr marL="0" indent="0">
                         <a:buNone/>
                       </a:pPr>
                       <a:r>
@@ -2576,7 +2423,7 @@
                       </a:endParaRPr>
                     </a:p>
                   </a:txBody>
-                  <a:tcPr marL="91440" marR="91440" marT="45720" marB="45720" anchor="ctr">
+                  <a:tcPr anchor="ctr">
                     <a:lnL w="6350" cap="flat" cmpd="sng" algn="ctr">
                       <a:solidFill>
                         <a:srgbClr val="D6DEE8"/>
@@ -2618,6 +2465,11 @@
                     </a:solidFill>
                   </a:tcPr>
                 </a:tc>
+                <a:extLst>
+                  <a:ext uri="{0D108BD9-81ED-4DB2-BD59-A6C34878D82A}">
+                    <a16:rowId xmlns:a16="http://schemas.microsoft.com/office/drawing/2014/main" val="10002"/>
+                  </a:ext>
+                </a:extLst>
               </a:tr>
               <a:tr h="233172">
                 <a:tc>
@@ -2625,7 +2477,7 @@
                     <a:bodyPr/>
                     <a:lstStyle/>
                     <a:p>
-                      <a:pPr indent="0" marL="0">
+                      <a:pPr marL="0" indent="0">
                         <a:buNone/>
                       </a:pPr>
                       <a:r>
@@ -2646,7 +2498,7 @@
                       </a:endParaRPr>
                     </a:p>
                   </a:txBody>
-                  <a:tcPr marL="91440" marR="91440" marT="45720" marB="45720" anchor="ctr">
+                  <a:tcPr anchor="ctr">
                     <a:lnL w="6350" cap="flat" cmpd="sng" algn="ctr">
                       <a:solidFill>
                         <a:srgbClr val="D6DEE8"/>
@@ -2693,7 +2545,7 @@
                     <a:bodyPr/>
                     <a:lstStyle/>
                     <a:p>
-                      <a:pPr indent="0" marL="0">
+                      <a:pPr marL="0" indent="0">
                         <a:buNone/>
                       </a:pPr>
                       <a:r>
@@ -2714,7 +2566,7 @@
                       </a:endParaRPr>
                     </a:p>
                   </a:txBody>
-                  <a:tcPr marL="91440" marR="91440" marT="45720" marB="45720" anchor="ctr">
+                  <a:tcPr anchor="ctr">
                     <a:lnL w="6350" cap="flat" cmpd="sng" algn="ctr">
                       <a:solidFill>
                         <a:srgbClr val="D6DEE8"/>
@@ -2756,6 +2608,11 @@
                     </a:solidFill>
                   </a:tcPr>
                 </a:tc>
+                <a:extLst>
+                  <a:ext uri="{0D108BD9-81ED-4DB2-BD59-A6C34878D82A}">
+                    <a16:rowId xmlns:a16="http://schemas.microsoft.com/office/drawing/2014/main" val="10003"/>
+                  </a:ext>
+                </a:extLst>
               </a:tr>
               <a:tr h="233172">
                 <a:tc>
@@ -2763,7 +2620,7 @@
                     <a:bodyPr/>
                     <a:lstStyle/>
                     <a:p>
-                      <a:pPr indent="0" marL="0">
+                      <a:pPr marL="0" indent="0">
                         <a:buNone/>
                       </a:pPr>
                       <a:r>
@@ -2784,7 +2641,7 @@
                       </a:endParaRPr>
                     </a:p>
                   </a:txBody>
-                  <a:tcPr marL="91440" marR="91440" marT="45720" marB="45720" anchor="ctr">
+                  <a:tcPr anchor="ctr">
                     <a:lnL w="6350" cap="flat" cmpd="sng" algn="ctr">
                       <a:solidFill>
                         <a:srgbClr val="D6DEE8"/>
@@ -2831,7 +2688,7 @@
                     <a:bodyPr/>
                     <a:lstStyle/>
                     <a:p>
-                      <a:pPr indent="0" marL="0">
+                      <a:pPr marL="0" indent="0">
                         <a:buNone/>
                       </a:pPr>
                       <a:r>
@@ -2852,7 +2709,7 @@
                       </a:endParaRPr>
                     </a:p>
                   </a:txBody>
-                  <a:tcPr marL="91440" marR="91440" marT="45720" marB="45720" anchor="ctr">
+                  <a:tcPr anchor="ctr">
                     <a:lnL w="6350" cap="flat" cmpd="sng" algn="ctr">
                       <a:solidFill>
                         <a:srgbClr val="D6DEE8"/>
@@ -2894,6 +2751,11 @@
                     </a:solidFill>
                   </a:tcPr>
                 </a:tc>
+                <a:extLst>
+                  <a:ext uri="{0D108BD9-81ED-4DB2-BD59-A6C34878D82A}">
+                    <a16:rowId xmlns:a16="http://schemas.microsoft.com/office/drawing/2014/main" val="10004"/>
+                  </a:ext>
+                </a:extLst>
               </a:tr>
               <a:tr h="233172">
                 <a:tc>
@@ -2901,7 +2763,7 @@
                     <a:bodyPr/>
                     <a:lstStyle/>
                     <a:p>
-                      <a:pPr indent="0" marL="0">
+                      <a:pPr marL="0" indent="0">
                         <a:buNone/>
                       </a:pPr>
                       <a:r>
@@ -2922,7 +2784,7 @@
                       </a:endParaRPr>
                     </a:p>
                   </a:txBody>
-                  <a:tcPr marL="91440" marR="91440" marT="45720" marB="45720" anchor="ctr">
+                  <a:tcPr anchor="ctr">
                     <a:lnL w="6350" cap="flat" cmpd="sng" algn="ctr">
                       <a:solidFill>
                         <a:srgbClr val="D6DEE8"/>
@@ -2969,7 +2831,7 @@
                     <a:bodyPr/>
                     <a:lstStyle/>
                     <a:p>
-                      <a:pPr indent="0" marL="0">
+                      <a:pPr marL="0" indent="0">
                         <a:buNone/>
                       </a:pPr>
                       <a:r>
@@ -2990,7 +2852,7 @@
                       </a:endParaRPr>
                     </a:p>
                   </a:txBody>
-                  <a:tcPr marL="91440" marR="91440" marT="45720" marB="45720" anchor="ctr">
+                  <a:tcPr anchor="ctr">
                     <a:lnL w="6350" cap="flat" cmpd="sng" algn="ctr">
                       <a:solidFill>
                         <a:srgbClr val="D6DEE8"/>
@@ -3032,6 +2894,11 @@
                     </a:solidFill>
                   </a:tcPr>
                 </a:tc>
+                <a:extLst>
+                  <a:ext uri="{0D108BD9-81ED-4DB2-BD59-A6C34878D82A}">
+                    <a16:rowId xmlns:a16="http://schemas.microsoft.com/office/drawing/2014/main" val="10005"/>
+                  </a:ext>
+                </a:extLst>
               </a:tr>
             </a:tbl>
           </a:graphicData>
@@ -3046,7 +2913,7 @@
           <p:nvPr/>
         </p:nvPicPr>
         <p:blipFill>
-          <a:blip r:embed="rId6"/>
+          <a:blip r:embed="rId4"/>
           <a:stretch>
             <a:fillRect/>
           </a:stretch>
@@ -3082,7 +2949,7 @@
           <a:bodyPr wrap="square" lIns="0" tIns="0" rIns="0" bIns="0" rtlCol="0" anchor="ctr"/>
           <a:lstStyle/>
           <a:p>
-            <a:pPr algn="l" indent="0" marL="0">
+            <a:pPr marL="0" indent="0" algn="l">
               <a:buNone/>
             </a:pPr>
             <a:r>
@@ -3121,7 +2988,7 @@
           <a:bodyPr wrap="square" lIns="0" tIns="0" rIns="0" bIns="0" rtlCol="0" anchor="ctr"/>
           <a:lstStyle/>
           <a:p>
-            <a:pPr algn="r" indent="0" marL="0">
+            <a:pPr marL="0" indent="0" algn="r">
               <a:buNone/>
             </a:pPr>
             <a:r>
@@ -3133,39 +3000,8 @@
                 <a:ea typeface="Segoe UI" pitchFamily="34" charset="-122"/>
                 <a:cs typeface="Segoe UI" pitchFamily="34" charset="-120"/>
               </a:rPr>
-              <a:t xml:space="preserve">Agnostic </a:t>
+              <a:t>Agnostic </a:t>
             </a:r>
-            <a:pPr algn="r" indent="0" marL="0">
-              <a:buNone/>
-            </a:pPr>
-            <a:r>
-              <a:rPr lang="en-US" sz="850" b="1" dirty="0">
-                <a:solidFill>
-                  <a:srgbClr val="F4C430"/>
-                </a:solidFill>
-                <a:latin typeface="Segoe UI" pitchFamily="34" charset="0"/>
-                <a:ea typeface="Segoe UI" pitchFamily="34" charset="-122"/>
-                <a:cs typeface="Segoe UI" pitchFamily="34" charset="-120"/>
-              </a:rPr>
-              <a:t>HERE</a:t>
-            </a:r>
-            <a:pPr algn="r" indent="0" marL="0">
-              <a:buNone/>
-            </a:pPr>
-            <a:r>
-              <a:rPr lang="en-US" sz="850" dirty="0">
-                <a:solidFill>
-                  <a:srgbClr val="FFFFFF"/>
-                </a:solidFill>
-                <a:latin typeface="Segoe UI" pitchFamily="34" charset="0"/>
-                <a:ea typeface="Segoe UI" pitchFamily="34" charset="-122"/>
-                <a:cs typeface="Segoe UI" pitchFamily="34" charset="-120"/>
-              </a:rPr>
-              <a:t xml:space="preserve"> / FSI-Legal </a:t>
-            </a:r>
-            <a:pPr algn="r" indent="0" marL="0">
-              <a:buNone/>
-            </a:pPr>
             <a:r>
               <a:rPr lang="en-US" sz="850" b="1" dirty="0">
                 <a:solidFill>
@@ -3207,13 +3043,20 @@
             <a:prstDash val="solid"/>
           </a:ln>
           <a:effectLst>
-            <a:outerShdw sx="100000" sy="100000" kx="0" ky="0" algn="bl" rotWithShape="0" blurRad="63500" dist="25400" dir="8100000">
+            <a:outerShdw blurRad="63500" dist="25400" dir="8100000" algn="bl" rotWithShape="0">
               <a:srgbClr val="1F3864">
                 <a:alpha val="12000"/>
               </a:srgbClr>
             </a:outerShdw>
           </a:effectLst>
         </p:spPr>
+        <p:txBody>
+          <a:bodyPr/>
+          <a:lstStyle/>
+          <a:p>
+            <a:endParaRPr lang="en-DE"/>
+          </a:p>
+        </p:txBody>
       </p:sp>
       <p:sp>
         <p:nvSpPr>
@@ -3236,7 +3079,7 @@
           <a:bodyPr wrap="square" lIns="0" tIns="0" rIns="0" bIns="0" rtlCol="0" anchor="t"/>
           <a:lstStyle/>
           <a:p>
-            <a:pPr algn="l" indent="0" marL="0">
+            <a:pPr marL="0" indent="0" algn="l">
               <a:buNone/>
             </a:pPr>
             <a:r>
@@ -3253,7 +3096,7 @@
             <a:endParaRPr lang="en-US" sz="820" dirty="0"/>
           </a:p>
           <a:p>
-            <a:pPr algn="l" indent="0" marL="0">
+            <a:pPr marL="0" indent="0" algn="l">
               <a:spcBef>
                 <a:spcPts val="200"/>
               </a:spcBef>
@@ -3279,12 +3122,12 @@
                 <a:ea typeface="Segoe UI" pitchFamily="34" charset="-122"/>
                 <a:cs typeface="Segoe UI" pitchFamily="34" charset="-120"/>
               </a:rPr>
-              <a:t>moving from copilots to autonomous, reasoning agents — value in speed, risk and compliance, on Azure AI Foundry.</a:t>
+              <a:t>moving from copilots to autonomous, reasoning agents — value in speed, risk and compliance, on Microsoft Foundry.</a:t>
             </a:r>
             <a:endParaRPr lang="en-US" sz="820" dirty="0"/>
           </a:p>
           <a:p>
-            <a:pPr algn="l" indent="0" marL="0">
+            <a:pPr marL="0" indent="0" algn="l">
               <a:spcBef>
                 <a:spcPts val="200"/>
               </a:spcBef>
@@ -3315,7 +3158,7 @@
             <a:endParaRPr lang="en-US" sz="820" dirty="0"/>
           </a:p>
           <a:p>
-            <a:pPr algn="l" indent="0" marL="0">
+            <a:pPr marL="0" indent="0" algn="l">
               <a:spcBef>
                 <a:spcPts val="200"/>
               </a:spcBef>
@@ -3341,7 +3184,7 @@
                 <a:ea typeface="Segoe UI" pitchFamily="34" charset="-122"/>
                 <a:cs typeface="Segoe UI" pitchFamily="34" charset="-120"/>
               </a:rPr>
-              <a:t>build the agents, run the GenAIOps loop (tracing, evaluation, safety), and publish via MCP to Microsoft 365 Copilot &amp; Teams — capped with a live demo.</a:t>
+              <a:t>build the agents, run the GenAIOps loop (tracing, evaluation, safety), and publish to Microsoft 365 Copilot &amp; Teams — capped with a live demo.</a:t>
             </a:r>
             <a:endParaRPr lang="en-US" sz="820" dirty="0"/>
           </a:p>
@@ -3356,7 +3199,7 @@
           <p:nvPr/>
         </p:nvPicPr>
         <p:blipFill>
-          <a:blip r:embed="rId7"/>
+          <a:blip r:embed="rId4"/>
           <a:stretch>
             <a:fillRect/>
           </a:stretch>
@@ -3392,7 +3235,7 @@
           <a:bodyPr wrap="square" lIns="0" tIns="0" rIns="0" bIns="0" rtlCol="0" anchor="ctr"/>
           <a:lstStyle/>
           <a:p>
-            <a:pPr algn="l" indent="0" marL="0">
+            <a:pPr marL="0" indent="0" algn="l">
               <a:buNone/>
             </a:pPr>
             <a:r>
@@ -3431,7 +3274,7 @@
           <a:bodyPr wrap="square" lIns="0" tIns="0" rIns="0" bIns="0" rtlCol="0" anchor="ctr"/>
           <a:lstStyle/>
           <a:p>
-            <a:pPr algn="r" indent="0" marL="0">
+            <a:pPr marL="0" indent="0" algn="r">
               <a:buNone/>
             </a:pPr>
             <a:r>
@@ -3443,11 +3286,8 @@
                 <a:ea typeface="Segoe UI" pitchFamily="34" charset="-122"/>
                 <a:cs typeface="Segoe UI" pitchFamily="34" charset="-120"/>
               </a:rPr>
-              <a:t xml:space="preserve">GitHub Repo </a:t>
+              <a:t>GitHub Repo </a:t>
             </a:r>
-            <a:pPr algn="r" indent="0" marL="0">
-              <a:buNone/>
-            </a:pPr>
             <a:r>
               <a:rPr lang="en-US" sz="850" b="1" u="sng" dirty="0">
                 <a:solidFill>
@@ -3456,7 +3296,7 @@
                 <a:latin typeface="Segoe UI" pitchFamily="34" charset="0"/>
                 <a:ea typeface="Segoe UI" pitchFamily="34" charset="-122"/>
                 <a:cs typeface="Segoe UI" pitchFamily="34" charset="-120"/>
-                <a:hlinkClick r:id="rId8" invalidUrl="" action="" tgtFrame="" tooltip="" history="1" highlightClick="0" endSnd="0">
+                <a:hlinkClick r:id="rId5">
                   <a:extLst>
                     <a:ext uri="{A12FA001-AC4F-418D-AE19-62706E023703}">
                       <ahyp:hlinkClr xmlns:ahyp="http://schemas.microsoft.com/office/drawing/2018/hyperlinkcolor" val="tx"/>
@@ -3466,9 +3306,6 @@
               </a:rPr>
               <a:t>HERE</a:t>
             </a:r>
-            <a:pPr algn="r" indent="0" marL="0">
-              <a:buNone/>
-            </a:pPr>
             <a:r>
               <a:rPr lang="en-US" sz="850" dirty="0">
                 <a:solidFill>
@@ -3478,11 +3315,8 @@
                 <a:ea typeface="Segoe UI" pitchFamily="34" charset="-122"/>
                 <a:cs typeface="Segoe UI" pitchFamily="34" charset="-120"/>
               </a:rPr>
-              <a:t xml:space="preserve"> / Train the Trainer video </a:t>
+              <a:t> / Train the Trainer video </a:t>
             </a:r>
-            <a:pPr algn="r" indent="0" marL="0">
-              <a:buNone/>
-            </a:pPr>
             <a:r>
               <a:rPr lang="en-US" sz="850" b="1" dirty="0">
                 <a:solidFill>
@@ -3500,7 +3334,7 @@
       </p:sp>
       <p:graphicFrame>
         <p:nvGraphicFramePr>
-          <p:cNvPr id="3" name="Table 1"/>
+          <p:cNvPr id="42" name="Table 1"/>
           <p:cNvGraphicFramePr>
             <a:graphicFrameLocks noGrp="1"/>
           </p:cNvGraphicFramePr>
@@ -3514,15 +3348,27 @@
         </p:nvGraphicFramePr>
         <p:xfrm>
           <a:off x="6144768" y="4443984"/>
-          <a:ext cx="5742432" cy="914400"/>
+          <a:ext cx="5742432" cy="1600200"/>
         </p:xfrm>
         <a:graphic>
           <a:graphicData uri="http://schemas.openxmlformats.org/drawingml/2006/table">
             <a:tbl>
               <a:tblPr/>
               <a:tblGrid>
-                <a:gridCol w="4919472"/>
-                <a:gridCol w="822960"/>
+                <a:gridCol w="4919472">
+                  <a:extLst>
+                    <a:ext uri="{9D8B030D-6E8A-4147-A177-3AD203B41FA5}">
+                      <a16:colId xmlns:a16="http://schemas.microsoft.com/office/drawing/2014/main" val="20000"/>
+                    </a:ext>
+                  </a:extLst>
+                </a:gridCol>
+                <a:gridCol w="822960">
+                  <a:extLst>
+                    <a:ext uri="{9D8B030D-6E8A-4147-A177-3AD203B41FA5}">
+                      <a16:colId xmlns:a16="http://schemas.microsoft.com/office/drawing/2014/main" val="20001"/>
+                    </a:ext>
+                  </a:extLst>
+                </a:gridCol>
               </a:tblGrid>
               <a:tr h="228600">
                 <a:tc>
@@ -3530,7 +3376,7 @@
                     <a:bodyPr/>
                     <a:lstStyle/>
                     <a:p>
-                      <a:pPr indent="0" marL="0">
+                      <a:pPr marL="0" indent="0">
                         <a:buNone/>
                       </a:pPr>
                       <a:r>
@@ -3551,7 +3397,7 @@
                       </a:endParaRPr>
                     </a:p>
                   </a:txBody>
-                  <a:tcPr marL="91440" marR="91440" marT="45720" marB="45720" anchor="ctr">
+                  <a:tcPr anchor="ctr">
                     <a:lnL w="6350" cap="flat" cmpd="sng" algn="ctr">
                       <a:solidFill>
                         <a:srgbClr val="D6DEE8"/>
@@ -3598,7 +3444,7 @@
                     <a:bodyPr/>
                     <a:lstStyle/>
                     <a:p>
-                      <a:pPr algn="r" indent="0" marL="0">
+                      <a:pPr marL="0" indent="0" algn="r">
                         <a:buNone/>
                       </a:pPr>
                       <a:r>
@@ -3619,7 +3465,7 @@
                       </a:endParaRPr>
                     </a:p>
                   </a:txBody>
-                  <a:tcPr marL="91440" marR="91440" marT="45720" marB="45720" anchor="ctr">
+                  <a:tcPr anchor="ctr">
                     <a:lnL w="6350" cap="flat" cmpd="sng" algn="ctr">
                       <a:solidFill>
                         <a:srgbClr val="D6DEE8"/>
@@ -3661,6 +3507,11 @@
                     </a:solidFill>
                   </a:tcPr>
                 </a:tc>
+                <a:extLst>
+                  <a:ext uri="{0D108BD9-81ED-4DB2-BD59-A6C34878D82A}">
+                    <a16:rowId xmlns:a16="http://schemas.microsoft.com/office/drawing/2014/main" val="10000"/>
+                  </a:ext>
+                </a:extLst>
               </a:tr>
               <a:tr h="228600">
                 <a:tc>
@@ -3668,7 +3519,7 @@
                     <a:bodyPr/>
                     <a:lstStyle/>
                     <a:p>
-                      <a:pPr indent="0" marL="0">
+                      <a:pPr marL="0" indent="0">
                         <a:buNone/>
                       </a:pPr>
                       <a:r>
@@ -3689,7 +3540,7 @@
                       </a:endParaRPr>
                     </a:p>
                   </a:txBody>
-                  <a:tcPr marL="91440" marR="91440" marT="45720" marB="45720" anchor="ctr">
+                  <a:tcPr anchor="ctr">
                     <a:lnL w="6350" cap="flat" cmpd="sng" algn="ctr">
                       <a:solidFill>
                         <a:srgbClr val="D6DEE8"/>
@@ -3736,7 +3587,7 @@
                     <a:bodyPr/>
                     <a:lstStyle/>
                     <a:p>
-                      <a:pPr algn="r" indent="0" marL="0">
+                      <a:pPr marL="0" indent="0" algn="r">
                         <a:buNone/>
                       </a:pPr>
                       <a:r>
@@ -3757,7 +3608,7 @@
                       </a:endParaRPr>
                     </a:p>
                   </a:txBody>
-                  <a:tcPr marL="91440" marR="91440" marT="45720" marB="45720" anchor="ctr">
+                  <a:tcPr anchor="ctr">
                     <a:lnL w="6350" cap="flat" cmpd="sng" algn="ctr">
                       <a:solidFill>
                         <a:srgbClr val="D6DEE8"/>
@@ -3799,6 +3650,11 @@
                     </a:solidFill>
                   </a:tcPr>
                 </a:tc>
+                <a:extLst>
+                  <a:ext uri="{0D108BD9-81ED-4DB2-BD59-A6C34878D82A}">
+                    <a16:rowId xmlns:a16="http://schemas.microsoft.com/office/drawing/2014/main" val="10001"/>
+                  </a:ext>
+                </a:extLst>
               </a:tr>
               <a:tr h="228600">
                 <a:tc>
@@ -3806,7 +3662,7 @@
                     <a:bodyPr/>
                     <a:lstStyle/>
                     <a:p>
-                      <a:pPr indent="0" marL="0">
+                      <a:pPr marL="0" indent="0">
                         <a:buNone/>
                       </a:pPr>
                       <a:r>
@@ -3827,7 +3683,7 @@
                       </a:endParaRPr>
                     </a:p>
                   </a:txBody>
-                  <a:tcPr marL="91440" marR="91440" marT="45720" marB="45720" anchor="ctr">
+                  <a:tcPr anchor="ctr">
                     <a:lnL w="6350" cap="flat" cmpd="sng" algn="ctr">
                       <a:solidFill>
                         <a:srgbClr val="D6DEE8"/>
@@ -3874,7 +3730,7 @@
                     <a:bodyPr/>
                     <a:lstStyle/>
                     <a:p>
-                      <a:pPr algn="r" indent="0" marL="0">
+                      <a:pPr marL="0" indent="0" algn="r">
                         <a:buNone/>
                       </a:pPr>
                       <a:r>
@@ -3895,7 +3751,7 @@
                       </a:endParaRPr>
                     </a:p>
                   </a:txBody>
-                  <a:tcPr marL="91440" marR="91440" marT="45720" marB="45720" anchor="ctr">
+                  <a:tcPr anchor="ctr">
                     <a:lnL w="6350" cap="flat" cmpd="sng" algn="ctr">
                       <a:solidFill>
                         <a:srgbClr val="D6DEE8"/>
@@ -3937,6 +3793,11 @@
                     </a:solidFill>
                   </a:tcPr>
                 </a:tc>
+                <a:extLst>
+                  <a:ext uri="{0D108BD9-81ED-4DB2-BD59-A6C34878D82A}">
+                    <a16:rowId xmlns:a16="http://schemas.microsoft.com/office/drawing/2014/main" val="10002"/>
+                  </a:ext>
+                </a:extLst>
               </a:tr>
               <a:tr h="228600">
                 <a:tc>
@@ -3944,7 +3805,7 @@
                     <a:bodyPr/>
                     <a:lstStyle/>
                     <a:p>
-                      <a:pPr indent="0" marL="0">
+                      <a:pPr marL="0" indent="0">
                         <a:buNone/>
                       </a:pPr>
                       <a:r>
@@ -3965,7 +3826,7 @@
                       </a:endParaRPr>
                     </a:p>
                   </a:txBody>
-                  <a:tcPr marL="91440" marR="91440" marT="45720" marB="45720" anchor="ctr">
+                  <a:tcPr anchor="ctr">
                     <a:lnL w="6350" cap="flat" cmpd="sng" algn="ctr">
                       <a:solidFill>
                         <a:srgbClr val="D6DEE8"/>
@@ -4012,7 +3873,7 @@
                     <a:bodyPr/>
                     <a:lstStyle/>
                     <a:p>
-                      <a:pPr algn="r" indent="0" marL="0">
+                      <a:pPr marL="0" indent="0" algn="r">
                         <a:buNone/>
                       </a:pPr>
                       <a:r>
@@ -4033,7 +3894,7 @@
                       </a:endParaRPr>
                     </a:p>
                   </a:txBody>
-                  <a:tcPr marL="91440" marR="91440" marT="45720" marB="45720" anchor="ctr">
+                  <a:tcPr anchor="ctr">
                     <a:lnL w="6350" cap="flat" cmpd="sng" algn="ctr">
                       <a:solidFill>
                         <a:srgbClr val="D6DEE8"/>
@@ -4075,6 +3936,11 @@
                     </a:solidFill>
                   </a:tcPr>
                 </a:tc>
+                <a:extLst>
+                  <a:ext uri="{0D108BD9-81ED-4DB2-BD59-A6C34878D82A}">
+                    <a16:rowId xmlns:a16="http://schemas.microsoft.com/office/drawing/2014/main" val="10003"/>
+                  </a:ext>
+                </a:extLst>
               </a:tr>
               <a:tr h="228600">
                 <a:tc>
@@ -4082,7 +3948,7 @@
                     <a:bodyPr/>
                     <a:lstStyle/>
                     <a:p>
-                      <a:pPr indent="0" marL="0">
+                      <a:pPr marL="0" indent="0">
                         <a:buNone/>
                       </a:pPr>
                       <a:r>
@@ -4103,7 +3969,7 @@
                       </a:endParaRPr>
                     </a:p>
                   </a:txBody>
-                  <a:tcPr marL="91440" marR="91440" marT="45720" marB="45720" anchor="ctr">
+                  <a:tcPr anchor="ctr">
                     <a:lnL w="6350" cap="flat" cmpd="sng" algn="ctr">
                       <a:solidFill>
                         <a:srgbClr val="D6DEE8"/>
@@ -4150,7 +4016,7 @@
                     <a:bodyPr/>
                     <a:lstStyle/>
                     <a:p>
-                      <a:pPr algn="r" indent="0" marL="0">
+                      <a:pPr marL="0" indent="0" algn="r">
                         <a:buNone/>
                       </a:pPr>
                       <a:r>
@@ -4171,7 +4037,7 @@
                       </a:endParaRPr>
                     </a:p>
                   </a:txBody>
-                  <a:tcPr marL="91440" marR="91440" marT="45720" marB="45720" anchor="ctr">
+                  <a:tcPr anchor="ctr">
                     <a:lnL w="6350" cap="flat" cmpd="sng" algn="ctr">
                       <a:solidFill>
                         <a:srgbClr val="D6DEE8"/>
@@ -4213,6 +4079,11 @@
                     </a:solidFill>
                   </a:tcPr>
                 </a:tc>
+                <a:extLst>
+                  <a:ext uri="{0D108BD9-81ED-4DB2-BD59-A6C34878D82A}">
+                    <a16:rowId xmlns:a16="http://schemas.microsoft.com/office/drawing/2014/main" val="10004"/>
+                  </a:ext>
+                </a:extLst>
               </a:tr>
               <a:tr h="228600">
                 <a:tc>
@@ -4220,7 +4091,7 @@
                     <a:bodyPr/>
                     <a:lstStyle/>
                     <a:p>
-                      <a:pPr indent="0" marL="0">
+                      <a:pPr marL="0" indent="0">
                         <a:buNone/>
                       </a:pPr>
                       <a:r>
@@ -4241,7 +4112,7 @@
                       </a:endParaRPr>
                     </a:p>
                   </a:txBody>
-                  <a:tcPr marL="91440" marR="91440" marT="45720" marB="45720" anchor="ctr">
+                  <a:tcPr anchor="ctr">
                     <a:lnL w="6350" cap="flat" cmpd="sng" algn="ctr">
                       <a:solidFill>
                         <a:srgbClr val="D6DEE8"/>
@@ -4288,7 +4159,7 @@
                     <a:bodyPr/>
                     <a:lstStyle/>
                     <a:p>
-                      <a:pPr algn="r" indent="0" marL="0">
+                      <a:pPr marL="0" indent="0" algn="r">
                         <a:buNone/>
                       </a:pPr>
                       <a:r>
@@ -4309,7 +4180,7 @@
                       </a:endParaRPr>
                     </a:p>
                   </a:txBody>
-                  <a:tcPr marL="91440" marR="91440" marT="45720" marB="45720" anchor="ctr">
+                  <a:tcPr anchor="ctr">
                     <a:lnL w="6350" cap="flat" cmpd="sng" algn="ctr">
                       <a:solidFill>
                         <a:srgbClr val="D6DEE8"/>
@@ -4351,6 +4222,11 @@
                     </a:solidFill>
                   </a:tcPr>
                 </a:tc>
+                <a:extLst>
+                  <a:ext uri="{0D108BD9-81ED-4DB2-BD59-A6C34878D82A}">
+                    <a16:rowId xmlns:a16="http://schemas.microsoft.com/office/drawing/2014/main" val="10005"/>
+                  </a:ext>
+                </a:extLst>
               </a:tr>
               <a:tr h="228600">
                 <a:tc>
@@ -4358,7 +4234,7 @@
                     <a:bodyPr/>
                     <a:lstStyle/>
                     <a:p>
-                      <a:pPr indent="0" marL="0">
+                      <a:pPr marL="0" indent="0">
                         <a:buNone/>
                       </a:pPr>
                       <a:r>
@@ -4370,11 +4246,8 @@
                           <a:ea typeface="Segoe UI" pitchFamily="34" charset="-122"/>
                           <a:cs typeface="Segoe UI" pitchFamily="34" charset="-120"/>
                         </a:rPr>
-                        <a:t xml:space="preserve">5   Safety, Red-Teaming &amp; Continuous Eval   </a:t>
+                        <a:t>5   Safety, Red-Teaming &amp; Continuous Eval   </a:t>
                       </a:r>
-                      <a:pPr indent="0" marL="0">
-                        <a:buNone/>
-                      </a:pPr>
                       <a:r>
                         <a:rPr lang="en-US" sz="900" b="1" dirty="0">
                           <a:solidFill>
@@ -4393,7 +4266,7 @@
                       </a:endParaRPr>
                     </a:p>
                   </a:txBody>
-                  <a:tcPr marL="91440" marR="91440" marT="45720" marB="45720" anchor="ctr">
+                  <a:tcPr anchor="ctr">
                     <a:lnL w="6350" cap="flat" cmpd="sng" algn="ctr">
                       <a:solidFill>
                         <a:srgbClr val="D6DEE8"/>
@@ -4440,7 +4313,7 @@
                     <a:bodyPr/>
                     <a:lstStyle/>
                     <a:p>
-                      <a:pPr algn="r" indent="0" marL="0">
+                      <a:pPr marL="0" indent="0" algn="r">
                         <a:buNone/>
                       </a:pPr>
                       <a:r>
@@ -4461,7 +4334,7 @@
                       </a:endParaRPr>
                     </a:p>
                   </a:txBody>
-                  <a:tcPr marL="91440" marR="91440" marT="45720" marB="45720" anchor="ctr">
+                  <a:tcPr anchor="ctr">
                     <a:lnL w="6350" cap="flat" cmpd="sng" algn="ctr">
                       <a:solidFill>
                         <a:srgbClr val="D6DEE8"/>
@@ -4503,6 +4376,11 @@
                     </a:solidFill>
                   </a:tcPr>
                 </a:tc>
+                <a:extLst>
+                  <a:ext uri="{0D108BD9-81ED-4DB2-BD59-A6C34878D82A}">
+                    <a16:rowId xmlns:a16="http://schemas.microsoft.com/office/drawing/2014/main" val="10006"/>
+                  </a:ext>
+                </a:extLst>
               </a:tr>
             </a:tbl>
           </a:graphicData>
@@ -4517,7 +4395,7 @@
           <p:nvPr/>
         </p:nvPicPr>
         <p:blipFill>
-          <a:blip r:embed="rId9"/>
+          <a:blip r:embed="rId4"/>
           <a:stretch>
             <a:fillRect/>
           </a:stretch>
@@ -4553,7 +4431,7 @@
           <a:bodyPr wrap="square" lIns="0" tIns="0" rIns="0" bIns="0" rtlCol="0" anchor="ctr"/>
           <a:lstStyle/>
           <a:p>
-            <a:pPr algn="l" indent="0" marL="0">
+            <a:pPr marL="0" indent="0" algn="l">
               <a:buNone/>
             </a:pPr>
             <a:r>
@@ -4592,7 +4470,7 @@
           <a:bodyPr wrap="square" lIns="0" tIns="0" rIns="0" bIns="0" rtlCol="0" anchor="ctr"/>
           <a:lstStyle/>
           <a:p>
-            <a:pPr algn="r" indent="0" marL="0">
+            <a:pPr marL="0" indent="0" algn="r">
               <a:buNone/>
             </a:pPr>
             <a:r>
@@ -4911,4 +4789,325 @@
     </a:ext>
   </a:extLst>
 </a:theme>
+</file>
+
+<file path=ppt/theme/theme2.xml><?xml version="1.0" encoding="utf-8"?>
+<a:theme xmlns:a="http://schemas.openxmlformats.org/drawingml/2006/main" name="Office Theme">
+  <a:themeElements>
+    <a:clrScheme name="Office">
+      <a:dk1>
+        <a:sysClr val="windowText" lastClr="000000"/>
+      </a:dk1>
+      <a:lt1>
+        <a:sysClr val="window" lastClr="FFFFFF"/>
+      </a:lt1>
+      <a:dk2>
+        <a:srgbClr val="0E2841"/>
+      </a:dk2>
+      <a:lt2>
+        <a:srgbClr val="E8E8E8"/>
+      </a:lt2>
+      <a:accent1>
+        <a:srgbClr val="156082"/>
+      </a:accent1>
+      <a:accent2>
+        <a:srgbClr val="E97132"/>
+      </a:accent2>
+      <a:accent3>
+        <a:srgbClr val="196B24"/>
+      </a:accent3>
+      <a:accent4>
+        <a:srgbClr val="0F9ED5"/>
+      </a:accent4>
+      <a:accent5>
+        <a:srgbClr val="A02B93"/>
+      </a:accent5>
+      <a:accent6>
+        <a:srgbClr val="4EA72E"/>
+      </a:accent6>
+      <a:hlink>
+        <a:srgbClr val="467886"/>
+      </a:hlink>
+      <a:folHlink>
+        <a:srgbClr val="96607D"/>
+      </a:folHlink>
+    </a:clrScheme>
+    <a:fontScheme name="Office">
+      <a:majorFont>
+        <a:latin typeface="Aptos Display" panose="02110004020202020204"/>
+        <a:ea typeface=""/>
+        <a:cs typeface=""/>
+        <a:font script="Jpan" typeface="游ゴシック Light"/>
+        <a:font script="Hang" typeface="맑은 고딕"/>
+        <a:font script="Hans" typeface="等线 Light"/>
+        <a:font script="Hant" typeface="新細明體"/>
+        <a:font script="Arab" typeface="Times New Roman"/>
+        <a:font script="Hebr" typeface="Times New Roman"/>
+        <a:font script="Thai" typeface="Angsana New"/>
+        <a:font script="Ethi" typeface="Nyala"/>
+        <a:font script="Beng" typeface="Vrinda"/>
+        <a:font script="Gujr" typeface="Shruti"/>
+        <a:font script="Khmr" typeface="MoolBoran"/>
+        <a:font script="Knda" typeface="Tunga"/>
+        <a:font script="Guru" typeface="Raavi"/>
+        <a:font script="Cans" typeface="Euphemia"/>
+        <a:font script="Cher" typeface="Plantagenet Cherokee"/>
+        <a:font script="Yiii" typeface="Microsoft Yi Baiti"/>
+        <a:font script="Tibt" typeface="Microsoft Himalaya"/>
+        <a:font script="Thaa" typeface="MV Boli"/>
+        <a:font script="Deva" typeface="Mangal"/>
+        <a:font script="Telu" typeface="Gautami"/>
+        <a:font script="Taml" typeface="Latha"/>
+        <a:font script="Syrc" typeface="Estrangelo Edessa"/>
+        <a:font script="Orya" typeface="Kalinga"/>
+        <a:font script="Mlym" typeface="Kartika"/>
+        <a:font script="Laoo" typeface="DokChampa"/>
+        <a:font script="Sinh" typeface="Iskoola Pota"/>
+        <a:font script="Mong" typeface="Mongolian Baiti"/>
+        <a:font script="Viet" typeface="Times New Roman"/>
+        <a:font script="Uigh" typeface="Microsoft Uighur"/>
+        <a:font script="Geor" typeface="Sylfaen"/>
+        <a:font script="Armn" typeface="Arial"/>
+        <a:font script="Bugi" typeface="Leelawadee UI"/>
+        <a:font script="Bopo" typeface="Microsoft JhengHei"/>
+        <a:font script="Java" typeface="Javanese Text"/>
+        <a:font script="Lisu" typeface="Segoe UI"/>
+        <a:font script="Mymr" typeface="Myanmar Text"/>
+        <a:font script="Nkoo" typeface="Ebrima"/>
+        <a:font script="Olck" typeface="Nirmala UI"/>
+        <a:font script="Osma" typeface="Ebrima"/>
+        <a:font script="Phag" typeface="Phagspa"/>
+        <a:font script="Syrn" typeface="Estrangelo Edessa"/>
+        <a:font script="Syrj" typeface="Estrangelo Edessa"/>
+        <a:font script="Syre" typeface="Estrangelo Edessa"/>
+        <a:font script="Sora" typeface="Nirmala UI"/>
+        <a:font script="Tale" typeface="Microsoft Tai Le"/>
+        <a:font script="Talu" typeface="Microsoft New Tai Lue"/>
+        <a:font script="Tfng" typeface="Ebrima"/>
+      </a:majorFont>
+      <a:minorFont>
+        <a:latin typeface="Aptos" panose="02110004020202020204"/>
+        <a:ea typeface=""/>
+        <a:cs typeface=""/>
+        <a:font script="Jpan" typeface="游ゴシック"/>
+        <a:font script="Hang" typeface="맑은 고딕"/>
+        <a:font script="Hans" typeface="等线"/>
+        <a:font script="Hant" typeface="新細明體"/>
+        <a:font script="Arab" typeface="Arial"/>
+        <a:font script="Hebr" typeface="Arial"/>
+        <a:font script="Thai" typeface="Cordia New"/>
+        <a:font script="Ethi" typeface="Nyala"/>
+        <a:font script="Beng" typeface="Vrinda"/>
+        <a:font script="Gujr" typeface="Shruti"/>
+        <a:font script="Khmr" typeface="DaunPenh"/>
+        <a:font script="Knda" typeface="Tunga"/>
+        <a:font script="Guru" typeface="Raavi"/>
+        <a:font script="Cans" typeface="Euphemia"/>
+        <a:font script="Cher" typeface="Plantagenet Cherokee"/>
+        <a:font script="Yiii" typeface="Microsoft Yi Baiti"/>
+        <a:font script="Tibt" typeface="Microsoft Himalaya"/>
+        <a:font script="Thaa" typeface="MV Boli"/>
+        <a:font script="Deva" typeface="Mangal"/>
+        <a:font script="Telu" typeface="Gautami"/>
+        <a:font script="Taml" typeface="Latha"/>
+        <a:font script="Syrc" typeface="Estrangelo Edessa"/>
+        <a:font script="Orya" typeface="Kalinga"/>
+        <a:font script="Mlym" typeface="Kartika"/>
+        <a:font script="Laoo" typeface="DokChampa"/>
+        <a:font script="Sinh" typeface="Iskoola Pota"/>
+        <a:font script="Mong" typeface="Mongolian Baiti"/>
+        <a:font script="Viet" typeface="Arial"/>
+        <a:font script="Uigh" typeface="Microsoft Uighur"/>
+        <a:font script="Geor" typeface="Sylfaen"/>
+        <a:font script="Armn" typeface="Arial"/>
+        <a:font script="Bugi" typeface="Leelawadee UI"/>
+        <a:font script="Bopo" typeface="Microsoft JhengHei"/>
+        <a:font script="Java" typeface="Javanese Text"/>
+        <a:font script="Lisu" typeface="Segoe UI"/>
+        <a:font script="Mymr" typeface="Myanmar Text"/>
+        <a:font script="Nkoo" typeface="Ebrima"/>
+        <a:font script="Olck" typeface="Nirmala UI"/>
+        <a:font script="Osma" typeface="Ebrima"/>
+        <a:font script="Phag" typeface="Phagspa"/>
+        <a:font script="Syrn" typeface="Estrangelo Edessa"/>
+        <a:font script="Syrj" typeface="Estrangelo Edessa"/>
+        <a:font script="Syre" typeface="Estrangelo Edessa"/>
+        <a:font script="Sora" typeface="Nirmala UI"/>
+        <a:font script="Tale" typeface="Microsoft Tai Le"/>
+        <a:font script="Talu" typeface="Microsoft New Tai Lue"/>
+        <a:font script="Tfng" typeface="Ebrima"/>
+      </a:minorFont>
+    </a:fontScheme>
+    <a:fmtScheme name="Office">
+      <a:fillStyleLst>
+        <a:solidFill>
+          <a:schemeClr val="phClr"/>
+        </a:solidFill>
+        <a:gradFill rotWithShape="1">
+          <a:gsLst>
+            <a:gs pos="0">
+              <a:schemeClr val="phClr">
+                <a:lumMod val="110000"/>
+                <a:satMod val="105000"/>
+                <a:tint val="67000"/>
+              </a:schemeClr>
+            </a:gs>
+            <a:gs pos="50000">
+              <a:schemeClr val="phClr">
+                <a:lumMod val="105000"/>
+                <a:satMod val="103000"/>
+                <a:tint val="73000"/>
+              </a:schemeClr>
+            </a:gs>
+            <a:gs pos="100000">
+              <a:schemeClr val="phClr">
+                <a:lumMod val="105000"/>
+                <a:satMod val="109000"/>
+                <a:tint val="81000"/>
+              </a:schemeClr>
+            </a:gs>
+          </a:gsLst>
+          <a:lin ang="5400000" scaled="0"/>
+        </a:gradFill>
+        <a:gradFill rotWithShape="1">
+          <a:gsLst>
+            <a:gs pos="0">
+              <a:schemeClr val="phClr">
+                <a:satMod val="103000"/>
+                <a:lumMod val="102000"/>
+                <a:tint val="94000"/>
+              </a:schemeClr>
+            </a:gs>
+            <a:gs pos="50000">
+              <a:schemeClr val="phClr">
+                <a:satMod val="110000"/>
+                <a:lumMod val="100000"/>
+                <a:shade val="100000"/>
+              </a:schemeClr>
+            </a:gs>
+            <a:gs pos="100000">
+              <a:schemeClr val="phClr">
+                <a:lumMod val="99000"/>
+                <a:satMod val="120000"/>
+                <a:shade val="78000"/>
+              </a:schemeClr>
+            </a:gs>
+          </a:gsLst>
+          <a:lin ang="5400000" scaled="0"/>
+        </a:gradFill>
+      </a:fillStyleLst>
+      <a:lnStyleLst>
+        <a:ln w="12700" cap="flat" cmpd="sng" algn="ctr">
+          <a:solidFill>
+            <a:schemeClr val="phClr"/>
+          </a:solidFill>
+          <a:prstDash val="solid"/>
+          <a:miter lim="800000"/>
+        </a:ln>
+        <a:ln w="19050" cap="flat" cmpd="sng" algn="ctr">
+          <a:solidFill>
+            <a:schemeClr val="phClr"/>
+          </a:solidFill>
+          <a:prstDash val="solid"/>
+          <a:miter lim="800000"/>
+        </a:ln>
+        <a:ln w="25400" cap="flat" cmpd="sng" algn="ctr">
+          <a:solidFill>
+            <a:schemeClr val="phClr"/>
+          </a:solidFill>
+          <a:prstDash val="solid"/>
+          <a:miter lim="800000"/>
+        </a:ln>
+      </a:lnStyleLst>
+      <a:effectStyleLst>
+        <a:effectStyle>
+          <a:effectLst/>
+        </a:effectStyle>
+        <a:effectStyle>
+          <a:effectLst/>
+        </a:effectStyle>
+        <a:effectStyle>
+          <a:effectLst>
+            <a:outerShdw blurRad="57150" dist="19050" dir="5400000" algn="ctr" rotWithShape="0">
+              <a:srgbClr val="000000">
+                <a:alpha val="63000"/>
+              </a:srgbClr>
+            </a:outerShdw>
+          </a:effectLst>
+        </a:effectStyle>
+      </a:effectStyleLst>
+      <a:bgFillStyleLst>
+        <a:solidFill>
+          <a:schemeClr val="phClr"/>
+        </a:solidFill>
+        <a:solidFill>
+          <a:schemeClr val="phClr">
+            <a:tint val="95000"/>
+            <a:satMod val="170000"/>
+          </a:schemeClr>
+        </a:solidFill>
+        <a:gradFill rotWithShape="1">
+          <a:gsLst>
+            <a:gs pos="0">
+              <a:schemeClr val="phClr">
+                <a:tint val="93000"/>
+                <a:satMod val="150000"/>
+                <a:shade val="98000"/>
+                <a:lumMod val="102000"/>
+              </a:schemeClr>
+            </a:gs>
+            <a:gs pos="50000">
+              <a:schemeClr val="phClr">
+                <a:tint val="98000"/>
+                <a:satMod val="130000"/>
+                <a:shade val="90000"/>
+                <a:lumMod val="103000"/>
+              </a:schemeClr>
+            </a:gs>
+            <a:gs pos="100000">
+              <a:schemeClr val="phClr">
+                <a:shade val="63000"/>
+                <a:satMod val="120000"/>
+              </a:schemeClr>
+            </a:gs>
+          </a:gsLst>
+          <a:lin ang="5400000" scaled="0"/>
+        </a:gradFill>
+      </a:bgFillStyleLst>
+    </a:fmtScheme>
+  </a:themeElements>
+  <a:objectDefaults>
+    <a:lnDef>
+      <a:spPr/>
+      <a:bodyPr/>
+      <a:lstStyle/>
+      <a:style>
+        <a:lnRef idx="2">
+          <a:schemeClr val="accent1"/>
+        </a:lnRef>
+        <a:fillRef idx="0">
+          <a:schemeClr val="accent1"/>
+        </a:fillRef>
+        <a:effectRef idx="1">
+          <a:schemeClr val="accent1"/>
+        </a:effectRef>
+        <a:fontRef idx="minor">
+          <a:schemeClr val="tx1"/>
+        </a:fontRef>
+      </a:style>
+    </a:lnDef>
+  </a:objectDefaults>
+  <a:extraClrSchemeLst/>
+  <a:extLst>
+    <a:ext uri="{05A4C25C-085E-4340-85A3-A5531E510DB2}">
+      <thm15:themeFamily xmlns:thm15="http://schemas.microsoft.com/office/thememl/2012/main" name="Office Theme" id="{2E142A2C-CD16-42D6-873A-C26D2A0506FA}" vid="{1BDDFF52-6CD6-40A5-AB3C-68EB2F1E4D0A}"/>
+    </a:ext>
+  </a:extLst>
+</a:theme>
+</file>
+
+<file path=docMetadata/LabelInfo.xml><?xml version="1.0" encoding="utf-8"?>
+<clbl:labelList xmlns:clbl="http://schemas.microsoft.com/office/2020/mipLabelMetadata">
+  <clbl:label id="{f42aa342-8706-4288-bd11-ebb85995028c}" enabled="1" method="Standard" siteId="{72f988bf-86f1-41af-91ab-2d7cd011db47}" contentBits="0" removed="0"/>
+</clbl:labelList>
 </file>
</xml_diff>

<commit_message>
docs(marketing): add audience/extensibility note to Use case box
Follow the sibling Agentic AI Hacks decks by adding a "Beyond FSI &
Legal" line to the Use case box: the agentic pattern extends to any
contract-heavy function (procurement, sales, HR), so attendees leave
with a reusable template. Body dropped to 8.8pt and paragraph gaps
tightened so all five paragraphs fit; no geometry changed.

Co-authored-by: Copilot App <223556219+Copilot@users.noreply.github.com>
Copilot-Session: 2fc86db1-1f76-4b83-b234-329556a5f335
</commit_message>
<xml_diff>
--- a/docs/marketing/CLM-Microhack-BOM.pptx
+++ b/docs/marketing/CLM-Microhack-BOM.pptx
@@ -4,12 +4,12 @@
   <p:sldMasterIdLst>
     <p:sldMasterId id="2147483648" r:id="rId1"/>
   </p:sldMasterIdLst>
+  <p:sldIdLst>
+    <p:sldId id="256" r:id="rId2"/>
+  </p:sldIdLst>
   <p:notesMasterIdLst>
     <p:notesMasterId r:id="rId3"/>
   </p:notesMasterIdLst>
-  <p:sldIdLst>
-    <p:sldId id="256" r:id="rId2"/>
-  </p:sldIdLst>
   <p:sldSz cx="12192000" cy="6858000"/>
   <p:notesSz cx="6858000" cy="12192000"/>
   <p:defaultTextStyle>
@@ -104,11 +104,6 @@
       </a:defRPr>
     </a:lvl9pPr>
   </p:defaultTextStyle>
-  <p:extLst>
-    <p:ext uri="{EFAFB233-063F-42B5-8137-9DF3F51BA10A}">
-      <p15:sldGuideLst xmlns:p15="http://schemas.microsoft.com/office/powerpoint/2012/main"/>
-    </p:ext>
-  </p:extLst>
 </p:presentation>
 </file>
 
@@ -134,10 +129,234 @@
           <a:chExt cx="0" cy="0"/>
         </a:xfrm>
       </p:grpSpPr>
+      <p:sp>
+        <p:nvSpPr>
+          <p:cNvPr id="2" name="Header Placeholder 1"/>
+          <p:cNvSpPr>
+            <a:spLocks noGrp="1"/>
+          </p:cNvSpPr>
+          <p:nvPr>
+            <p:ph type="hdr" sz="quarter"/>
+          </p:nvPr>
+        </p:nvSpPr>
+        <p:spPr>
+          <a:xfrm>
+            <a:off x="0" y="0"/>
+            <a:ext cx="2971800" cy="458788"/>
+          </a:xfrm>
+          <a:prstGeom prst="rect">
+            <a:avLst/>
+          </a:prstGeom>
+        </p:spPr>
+        <p:txBody>
+          <a:bodyPr vert="horz" lIns="91440" tIns="45720" rIns="91440" bIns="45720" rtlCol="0"/>
+          <a:lstStyle>
+            <a:lvl1pPr algn="l">
+              <a:defRPr sz="1200"/>
+            </a:lvl1pPr>
+          </a:lstStyle>
+          <a:p>
+            <a:endParaRPr lang="en-US"/>
+          </a:p>
+        </p:txBody>
+      </p:sp>
+      <p:sp>
+        <p:nvSpPr>
+          <p:cNvPr id="3" name="Date Placeholder 2"/>
+          <p:cNvSpPr>
+            <a:spLocks noGrp="1"/>
+          </p:cNvSpPr>
+          <p:nvPr>
+            <p:ph type="dt" idx="1"/>
+          </p:nvPr>
+        </p:nvSpPr>
+        <p:spPr>
+          <a:xfrm>
+            <a:off x="3884613" y="0"/>
+            <a:ext cx="2971800" cy="458788"/>
+          </a:xfrm>
+          <a:prstGeom prst="rect">
+            <a:avLst/>
+          </a:prstGeom>
+        </p:spPr>
+        <p:txBody>
+          <a:bodyPr vert="horz" lIns="91440" tIns="45720" rIns="91440" bIns="45720" rtlCol="0"/>
+          <a:lstStyle>
+            <a:lvl1pPr algn="r">
+              <a:defRPr sz="1200"/>
+            </a:lvl1pPr>
+          </a:lstStyle>
+          <a:p>
+            <a:fld id="{5282F153-3F37-0F45-9E97-73ACFA13230C}" type="datetimeFigureOut">
+              <a:rPr lang="en-US"/>
+              <a:t>7/23/19</a:t>
+            </a:fld>
+            <a:endParaRPr lang="en-US"/>
+          </a:p>
+        </p:txBody>
+      </p:sp>
+      <p:sp>
+        <p:nvSpPr>
+          <p:cNvPr id="4" name="Slide Image Placeholder 3"/>
+          <p:cNvSpPr>
+            <a:spLocks noGrp="1" noRot="1" noChangeAspect="1"/>
+          </p:cNvSpPr>
+          <p:nvPr>
+            <p:ph type="sldImg" idx="2"/>
+          </p:nvPr>
+        </p:nvSpPr>
+        <p:spPr>
+          <a:xfrm>
+            <a:off x="685800" y="1143000"/>
+            <a:ext cx="5486400" cy="3086100"/>
+          </a:xfrm>
+          <a:prstGeom prst="rect">
+            <a:avLst/>
+          </a:prstGeom>
+          <a:noFill/>
+          <a:ln w="12700">
+            <a:solidFill>
+              <a:prstClr val="black"/>
+            </a:solidFill>
+          </a:ln>
+        </p:spPr>
+        <p:txBody>
+          <a:bodyPr vert="horz" lIns="91440" tIns="45720" rIns="91440" bIns="45720" rtlCol="0" anchor="ctr"/>
+          <a:lstStyle/>
+          <a:p>
+            <a:endParaRPr lang="en-US"/>
+          </a:p>
+        </p:txBody>
+      </p:sp>
+      <p:sp>
+        <p:nvSpPr>
+          <p:cNvPr id="5" name="Notes Placeholder 4"/>
+          <p:cNvSpPr>
+            <a:spLocks noGrp="1"/>
+          </p:cNvSpPr>
+          <p:nvPr>
+            <p:ph type="body" sz="quarter" idx="3"/>
+          </p:nvPr>
+        </p:nvSpPr>
+        <p:spPr>
+          <a:xfrm>
+            <a:off x="685800" y="4400550"/>
+            <a:ext cx="5486400" cy="3600450"/>
+          </a:xfrm>
+          <a:prstGeom prst="rect">
+            <a:avLst/>
+          </a:prstGeom>
+        </p:spPr>
+        <p:txBody>
+          <a:bodyPr vert="horz" lIns="91440" tIns="45720" rIns="91440" bIns="45720" rtlCol="0"/>
+          <a:lstStyle/>
+          <a:p>
+            <a:pPr lvl="0"/>
+            <a:r>
+              <a:rPr lang="en-US"/>
+              <a:t>Click to edit Master text styles</a:t>
+            </a:r>
+          </a:p>
+          <a:p>
+            <a:pPr lvl="1"/>
+            <a:r>
+              <a:rPr lang="en-US"/>
+              <a:t>Second level</a:t>
+            </a:r>
+          </a:p>
+          <a:p>
+            <a:pPr lvl="2"/>
+            <a:r>
+              <a:rPr lang="en-US"/>
+              <a:t>Third level</a:t>
+            </a:r>
+          </a:p>
+          <a:p>
+            <a:pPr lvl="3"/>
+            <a:r>
+              <a:rPr lang="en-US"/>
+              <a:t>Fourth level</a:t>
+            </a:r>
+          </a:p>
+          <a:p>
+            <a:pPr lvl="4"/>
+            <a:r>
+              <a:rPr lang="en-US"/>
+              <a:t>Fifth level</a:t>
+            </a:r>
+          </a:p>
+        </p:txBody>
+      </p:sp>
+      <p:sp>
+        <p:nvSpPr>
+          <p:cNvPr id="6" name="Footer Placeholder 5"/>
+          <p:cNvSpPr>
+            <a:spLocks noGrp="1"/>
+          </p:cNvSpPr>
+          <p:nvPr>
+            <p:ph type="ftr" sz="quarter" idx="4"/>
+          </p:nvPr>
+        </p:nvSpPr>
+        <p:spPr>
+          <a:xfrm>
+            <a:off x="0" y="8685213"/>
+            <a:ext cx="2971800" cy="458787"/>
+          </a:xfrm>
+          <a:prstGeom prst="rect">
+            <a:avLst/>
+          </a:prstGeom>
+        </p:spPr>
+        <p:txBody>
+          <a:bodyPr vert="horz" lIns="91440" tIns="45720" rIns="91440" bIns="45720" rtlCol="0" anchor="b"/>
+          <a:lstStyle>
+            <a:lvl1pPr algn="l">
+              <a:defRPr sz="1200"/>
+            </a:lvl1pPr>
+          </a:lstStyle>
+          <a:p>
+            <a:endParaRPr lang="en-US"/>
+          </a:p>
+        </p:txBody>
+      </p:sp>
+      <p:sp>
+        <p:nvSpPr>
+          <p:cNvPr id="7" name="Slide Number Placeholder 6"/>
+          <p:cNvSpPr>
+            <a:spLocks noGrp="1"/>
+          </p:cNvSpPr>
+          <p:nvPr>
+            <p:ph type="sldNum" sz="quarter" idx="5"/>
+          </p:nvPr>
+        </p:nvSpPr>
+        <p:spPr>
+          <a:xfrm>
+            <a:off x="3884613" y="8685213"/>
+            <a:ext cx="2971800" cy="458787"/>
+          </a:xfrm>
+          <a:prstGeom prst="rect">
+            <a:avLst/>
+          </a:prstGeom>
+        </p:spPr>
+        <p:txBody>
+          <a:bodyPr vert="horz" lIns="91440" tIns="45720" rIns="91440" bIns="45720" rtlCol="0" anchor="b"/>
+          <a:lstStyle>
+            <a:lvl1pPr algn="r">
+              <a:defRPr sz="1200"/>
+            </a:lvl1pPr>
+          </a:lstStyle>
+          <a:p>
+            <a:fld id="{CE5E9CC1-C706-0F49-92D6-E571CC5EEA8F}" type="slidenum">
+              <a:rPr lang="en-US"/>
+              <a:t>‹#›</a:t>
+            </a:fld>
+            <a:endParaRPr lang="en-US"/>
+          </a:p>
+        </p:txBody>
+      </p:sp>
     </p:spTree>
     <p:extLst>
       <p:ext uri="{BB962C8B-B14F-4D97-AF65-F5344CB8AC3E}">
-        <p14:creationId xmlns:p14="http://schemas.microsoft.com/office/powerpoint/2010/main" val="567719757"/>
+        <p14:creationId xmlns:p14="http://schemas.microsoft.com/office/powerpoint/2010/main" val="1024086991"/>
       </p:ext>
     </p:extLst>
   </p:cSld>
@@ -281,6 +500,10 @@
           <a:bodyPr/>
           <a:lstStyle/>
           <a:p>
+            <a:r>
+              <a:rPr lang="en-US" dirty="0"/>
+              <a:t/>
+            </a:r>
             <a:endParaRPr lang="en-US" dirty="0"/>
           </a:p>
         </p:txBody>
@@ -354,11 +577,6 @@
 <file path=ppt/slideMasters/slideMaster1.xml><?xml version="1.0" encoding="utf-8"?>
 <p:sldMaster xmlns:a="http://schemas.openxmlformats.org/drawingml/2006/main" xmlns:r="http://schemas.openxmlformats.org/officeDocument/2006/relationships" xmlns:p="http://schemas.openxmlformats.org/presentationml/2006/main">
   <p:cSld>
-    <p:bg>
-      <p:bgRef idx="1001">
-        <a:schemeClr val="bg1"/>
-      </p:bgRef>
-    </p:bg>
     <p:spTree>
       <p:nvGrpSpPr>
         <p:cNvPr id="1" name=""/>
@@ -639,7 +857,7 @@
     <p:bg>
       <p:bgPr>
         <a:blipFill dpi="0" rotWithShape="1">
-          <a:blip r:embed="rId3">
+          <a:blip r:embed="rId1">
             <a:lum/>
           </a:blip>
           <a:srcRect/>
@@ -685,7 +903,7 @@
           <a:bodyPr wrap="square" lIns="0" tIns="0" rIns="0" bIns="0" rtlCol="0" anchor="ctr"/>
           <a:lstStyle/>
           <a:p>
-            <a:pPr marL="0" indent="0" algn="l">
+            <a:pPr algn="l" indent="0" marL="0">
               <a:buNone/>
             </a:pPr>
             <a:r>
@@ -699,6 +917,9 @@
               </a:rPr>
               <a:t>Agentic AI Hacks</a:t>
             </a:r>
+            <a:pPr algn="l" indent="0" marL="0">
+              <a:buNone/>
+            </a:pPr>
             <a:r>
               <a:rPr lang="en-US" sz="2700" b="1" dirty="0">
                 <a:solidFill>
@@ -708,8 +929,11 @@
                 <a:ea typeface="Segoe UI" pitchFamily="34" charset="-122"/>
                 <a:cs typeface="Segoe UI" pitchFamily="34" charset="-120"/>
               </a:rPr>
-              <a:t>  |  </a:t>
-            </a:r>
+              <a:t xml:space="preserve">  |  </a:t>
+            </a:r>
+            <a:pPr algn="l" indent="0" marL="0">
+              <a:buNone/>
+            </a:pPr>
             <a:r>
               <a:rPr lang="en-US" sz="2700" b="1" dirty="0">
                 <a:solidFill>
@@ -734,7 +958,7 @@
           <p:nvPr/>
         </p:nvPicPr>
         <p:blipFill>
-          <a:blip r:embed="rId4"/>
+          <a:blip r:embed="rId2"/>
           <a:stretch>
             <a:fillRect/>
           </a:stretch>
@@ -770,7 +994,7 @@
           <a:bodyPr wrap="square" lIns="0" tIns="0" rIns="0" bIns="0" rtlCol="0" anchor="ctr"/>
           <a:lstStyle/>
           <a:p>
-            <a:pPr marL="0" indent="0" algn="l">
+            <a:pPr algn="l" indent="0" marL="0">
               <a:buNone/>
             </a:pPr>
             <a:r>
@@ -809,7 +1033,7 @@
           <a:bodyPr wrap="square" lIns="0" tIns="0" rIns="0" bIns="0" rtlCol="0" anchor="ctr"/>
           <a:lstStyle/>
           <a:p>
-            <a:pPr marL="0" indent="0" algn="r">
+            <a:pPr algn="r" indent="0" marL="0">
               <a:buNone/>
             </a:pPr>
             <a:r>
@@ -821,8 +1045,11 @@
                 <a:ea typeface="Segoe UI" pitchFamily="34" charset="-122"/>
                 <a:cs typeface="Segoe UI" pitchFamily="34" charset="-120"/>
               </a:rPr>
-              <a:t>Reg Page Copy </a:t>
-            </a:r>
+              <a:t xml:space="preserve">Reg Page Copy </a:t>
+            </a:r>
+            <a:pPr algn="r" indent="0" marL="0">
+              <a:buNone/>
+            </a:pPr>
             <a:r>
               <a:rPr lang="en-US" sz="850" b="1" dirty="0">
                 <a:solidFill>
@@ -834,6 +1061,9 @@
               </a:rPr>
               <a:t>HERE</a:t>
             </a:r>
+            <a:pPr algn="r" indent="0" marL="0">
+              <a:buNone/>
+            </a:pPr>
             <a:r>
               <a:rPr lang="en-US" sz="850" dirty="0">
                 <a:solidFill>
@@ -843,8 +1073,11 @@
                 <a:ea typeface="Segoe UI" pitchFamily="34" charset="-122"/>
                 <a:cs typeface="Segoe UI" pitchFamily="34" charset="-120"/>
               </a:rPr>
-              <a:t> / Invitation Copy </a:t>
-            </a:r>
+              <a:t xml:space="preserve"> / Invitation Copy </a:t>
+            </a:r>
+            <a:pPr algn="r" indent="0" marL="0">
+              <a:buNone/>
+            </a:pPr>
             <a:r>
               <a:rPr lang="en-US" sz="850" b="1" dirty="0">
                 <a:solidFill>
@@ -856,6 +1089,9 @@
               </a:rPr>
               <a:t>HERE</a:t>
             </a:r>
+            <a:pPr algn="r" indent="0" marL="0">
+              <a:buNone/>
+            </a:pPr>
             <a:r>
               <a:rPr lang="en-US" sz="850" dirty="0">
                 <a:solidFill>
@@ -865,8 +1101,11 @@
                 <a:ea typeface="Segoe UI" pitchFamily="34" charset="-122"/>
                 <a:cs typeface="Segoe UI" pitchFamily="34" charset="-120"/>
               </a:rPr>
-              <a:t> / Marketing BOM </a:t>
-            </a:r>
+              <a:t xml:space="preserve"> / Marketing BOM </a:t>
+            </a:r>
+            <a:pPr algn="r" indent="0" marL="0">
+              <a:buNone/>
+            </a:pPr>
             <a:r>
               <a:rPr lang="en-US" sz="850" b="1" dirty="0">
                 <a:solidFill>
@@ -891,7 +1130,7 @@
           <p:nvPr/>
         </p:nvPicPr>
         <p:blipFill>
-          <a:blip r:embed="rId4"/>
+          <a:blip r:embed="rId3"/>
           <a:stretch>
             <a:fillRect/>
           </a:stretch>
@@ -927,7 +1166,7 @@
           <a:bodyPr wrap="square" lIns="0" tIns="0" rIns="0" bIns="0" rtlCol="0" anchor="ctr"/>
           <a:lstStyle/>
           <a:p>
-            <a:pPr marL="0" indent="0" algn="l">
+            <a:pPr algn="l" indent="0" marL="0">
               <a:buNone/>
             </a:pPr>
             <a:r>
@@ -971,20 +1210,13 @@
             <a:prstDash val="solid"/>
           </a:ln>
           <a:effectLst>
-            <a:outerShdw blurRad="63500" dist="25400" dir="8100000" algn="bl" rotWithShape="0">
+            <a:outerShdw sx="100000" sy="100000" kx="0" ky="0" algn="bl" rotWithShape="0" blurRad="63500" dist="25400" dir="8100000">
               <a:srgbClr val="1F3864">
                 <a:alpha val="12000"/>
               </a:srgbClr>
             </a:outerShdw>
           </a:effectLst>
         </p:spPr>
-        <p:txBody>
-          <a:bodyPr/>
-          <a:lstStyle/>
-          <a:p>
-            <a:endParaRPr lang="en-DE"/>
-          </a:p>
-        </p:txBody>
       </p:sp>
       <p:sp>
         <p:nvSpPr>
@@ -1007,14 +1239,11 @@
           <a:bodyPr wrap="square" lIns="0" tIns="0" rIns="0" bIns="0" rtlCol="0" anchor="t"/>
           <a:lstStyle/>
           <a:p>
-            <a:pPr marL="0" indent="0" algn="l">
-              <a:spcAft>
-                <a:spcPts val="600"/>
-              </a:spcAft>
+            <a:pPr algn="l" indent="0" marL="0">
               <a:buNone/>
             </a:pPr>
             <a:r>
-              <a:rPr lang="en-US" sz="950" dirty="0">
+              <a:rPr lang="en-US" sz="880" dirty="0">
                 <a:solidFill>
                   <a:srgbClr val="2B2B2B"/>
                 </a:solidFill>
@@ -1024,65 +1253,37 @@
               </a:rPr>
               <a:t>Enterprises sign hundreds of contracts a month. Legal &amp; Procurement drown in intake, clause review and renewals — ~17-day turnaround and ~11% of auto-renewals missed.</a:t>
             </a:r>
-            <a:endParaRPr lang="en-US" sz="950" dirty="0"/>
+            <a:endParaRPr lang="en-US" sz="880" dirty="0"/>
           </a:p>
           <a:p>
-            <a:pPr marL="0" indent="0" algn="l">
-              <a:spcAft>
-                <a:spcPts val="600"/>
-              </a:spcAft>
-              <a:buNone/>
-            </a:pPr>
-            <a:r>
-              <a:rPr lang="en-US" sz="950" dirty="0">
-                <a:solidFill>
-                  <a:srgbClr val="2B2B2B"/>
-                </a:solidFill>
-                <a:latin typeface="Segoe UI" pitchFamily="34" charset="0"/>
-                <a:ea typeface="Segoe UI" pitchFamily="34" charset="-122"/>
-                <a:cs typeface="Segoe UI" pitchFamily="34" charset="-120"/>
-              </a:rPr>
-              <a:t>Traditional CLM is scattered across SharePoint, email and legacy systems; comparing a counterparty draft to the enterprise standard is slow and manual.</a:t>
-            </a:r>
-            <a:endParaRPr lang="en-US" sz="950" dirty="0"/>
-          </a:p>
-          <a:p>
-            <a:pPr marL="0" indent="0" algn="l">
-              <a:buNone/>
-            </a:pPr>
-            <a:r>
-              <a:rPr lang="en-US" sz="950" b="1" dirty="0">
-                <a:solidFill>
-                  <a:srgbClr val="1F6FB4"/>
-                </a:solidFill>
-                <a:latin typeface="Segoe UI" pitchFamily="34" charset="0"/>
-                <a:ea typeface="Segoe UI" pitchFamily="34" charset="-122"/>
-                <a:cs typeface="Segoe UI" pitchFamily="34" charset="-120"/>
-              </a:rPr>
-              <a:t>Agentic CLM </a:t>
-            </a:r>
-            <a:r>
-              <a:rPr lang="en-US" sz="950" dirty="0">
-                <a:solidFill>
-                  <a:srgbClr val="2B2B2B"/>
-                </a:solidFill>
-                <a:latin typeface="Segoe UI" pitchFamily="34" charset="0"/>
-                <a:ea typeface="Segoe UI" pitchFamily="34" charset="-122"/>
-                <a:cs typeface="Segoe UI" pitchFamily="34" charset="-120"/>
-              </a:rPr>
-              <a:t>puts an orchestrator + grounded specialist agents on top: draft from approved templates, extract and risk-score clauses, answer cited questions, and proactively alert on renewals — with human sign-off and full tracing.</a:t>
-            </a:r>
-            <a:endParaRPr lang="en-US" sz="950" dirty="0"/>
-          </a:p>
-          <a:p>
-            <a:pPr marL="0" indent="0" algn="l">
+            <a:pPr algn="l" indent="0" marL="0">
               <a:spcBef>
-                <a:spcPts val="600"/>
+                <a:spcPts val="400"/>
               </a:spcBef>
               <a:buNone/>
             </a:pPr>
             <a:r>
-              <a:rPr lang="en-US" sz="950" b="1" dirty="0">
+              <a:rPr lang="en-US" sz="880" dirty="0">
+                <a:solidFill>
+                  <a:srgbClr val="2B2B2B"/>
+                </a:solidFill>
+                <a:latin typeface="Segoe UI" pitchFamily="34" charset="0"/>
+                <a:ea typeface="Segoe UI" pitchFamily="34" charset="-122"/>
+                <a:cs typeface="Segoe UI" pitchFamily="34" charset="-120"/>
+              </a:rPr>
+              <a:t>Traditional CLM is scattered across SharePoint, email and legacy systems; comparing a counterparty draft to the enterprise standard is slow and manual.</a:t>
+            </a:r>
+            <a:endParaRPr lang="en-US" sz="880" dirty="0"/>
+          </a:p>
+          <a:p>
+            <a:pPr algn="l" indent="0" marL="0">
+              <a:spcBef>
+                <a:spcPts val="400"/>
+              </a:spcBef>
+              <a:buNone/>
+            </a:pPr>
+            <a:r>
+              <a:rPr lang="en-US" sz="880" b="1" dirty="0">
                 <a:solidFill>
                   <a:srgbClr val="1F6FB4"/>
                 </a:solidFill>
@@ -1090,10 +1291,10 @@
                 <a:ea typeface="Segoe UI" pitchFamily="34" charset="-122"/>
                 <a:cs typeface="Segoe UI" pitchFamily="34" charset="-120"/>
               </a:rPr>
-              <a:t>Concretely: </a:t>
-            </a:r>
-            <a:r>
-              <a:rPr lang="en-US" sz="950" dirty="0">
+              <a:t xml:space="preserve">Agentic CLM </a:t>
+            </a:r>
+            <a:r>
+              <a:rPr lang="en-US" sz="880" dirty="0">
                 <a:solidFill>
                   <a:srgbClr val="2B2B2B"/>
                 </a:solidFill>
@@ -1101,9 +1302,71 @@
                 <a:ea typeface="Segoe UI" pitchFamily="34" charset="-122"/>
                 <a:cs typeface="Segoe UI" pitchFamily="34" charset="-120"/>
               </a:rPr>
+              <a:t>puts an orchestrator + grounded specialist agents on top: draft from approved templates, extract and risk-score clauses, answer cited questions, and proactively alert on renewals — with human sign-off and full tracing.</a:t>
+            </a:r>
+            <a:endParaRPr lang="en-US" sz="880" dirty="0"/>
+          </a:p>
+          <a:p>
+            <a:pPr algn="l" indent="0" marL="0">
+              <a:spcBef>
+                <a:spcPts val="400"/>
+              </a:spcBef>
+              <a:buNone/>
+            </a:pPr>
+            <a:r>
+              <a:rPr lang="en-US" sz="880" b="1" dirty="0">
+                <a:solidFill>
+                  <a:srgbClr val="1F6FB4"/>
+                </a:solidFill>
+                <a:latin typeface="Segoe UI" pitchFamily="34" charset="0"/>
+                <a:ea typeface="Segoe UI" pitchFamily="34" charset="-122"/>
+                <a:cs typeface="Segoe UI" pitchFamily="34" charset="-120"/>
+              </a:rPr>
+              <a:t xml:space="preserve">Concretely: </a:t>
+            </a:r>
+            <a:r>
+              <a:rPr lang="en-US" sz="880" dirty="0">
+                <a:solidFill>
+                  <a:srgbClr val="2B2B2B"/>
+                </a:solidFill>
+                <a:latin typeface="Segoe UI" pitchFamily="34" charset="0"/>
+                <a:ea typeface="Segoe UI" pitchFamily="34" charset="-122"/>
+                <a:cs typeface="Segoe UI" pitchFamily="34" charset="-120"/>
+              </a:rPr>
               <a:t>cited template drafts, risk-scored clauses, and human-approved renewal alerts.</a:t>
             </a:r>
-            <a:endParaRPr lang="en-US" sz="950" dirty="0"/>
+            <a:endParaRPr lang="en-US" sz="880" dirty="0"/>
+          </a:p>
+          <a:p>
+            <a:pPr algn="l" indent="0" marL="0">
+              <a:spcBef>
+                <a:spcPts val="400"/>
+              </a:spcBef>
+              <a:buNone/>
+            </a:pPr>
+            <a:r>
+              <a:rPr lang="en-US" sz="880" b="1" dirty="0">
+                <a:solidFill>
+                  <a:srgbClr val="1F6FB4"/>
+                </a:solidFill>
+                <a:latin typeface="Segoe UI" pitchFamily="34" charset="0"/>
+                <a:ea typeface="Segoe UI" pitchFamily="34" charset="-122"/>
+                <a:cs typeface="Segoe UI" pitchFamily="34" charset="-120"/>
+              </a:rPr>
+              <a:t xml:space="preserve">Beyond FSI &amp; Legal: </a:t>
+            </a:r>
+            <a:r>
+              <a:rPr lang="en-US" sz="880" dirty="0">
+                <a:solidFill>
+                  <a:srgbClr val="2B2B2B"/>
+                </a:solidFill>
+                <a:latin typeface="Segoe UI" pitchFamily="34" charset="0"/>
+                <a:ea typeface="Segoe UI" pitchFamily="34" charset="-122"/>
+                <a:cs typeface="Segoe UI" pitchFamily="34" charset="-120"/>
+              </a:rPr>
+              <a:t>the agentic pattern extends to any contract-heavy function — procurement, sales, HR — so attendees leave with a template they can reuse in their own industry.</a:t>
+            </a:r>
+            <a:endParaRPr lang="en-US" sz="880" dirty="0"/>
           </a:p>
         </p:txBody>
       </p:sp>
@@ -1152,7 +1415,7 @@
           <a:bodyPr wrap="square" lIns="0" tIns="0" rIns="0" bIns="0" rtlCol="0" anchor="ctr"/>
           <a:lstStyle/>
           <a:p>
-            <a:pPr marL="0" indent="0" algn="l">
+            <a:pPr algn="l" indent="0" marL="0">
               <a:buNone/>
             </a:pPr>
             <a:r>
@@ -1196,20 +1459,13 @@
             <a:prstDash val="solid"/>
           </a:ln>
           <a:effectLst>
-            <a:outerShdw blurRad="63500" dist="25400" dir="8100000" algn="bl" rotWithShape="0">
+            <a:outerShdw sx="100000" sy="100000" kx="0" ky="0" algn="bl" rotWithShape="0" blurRad="63500" dist="25400" dir="8100000">
               <a:srgbClr val="1F3864">
                 <a:alpha val="12000"/>
               </a:srgbClr>
             </a:outerShdw>
           </a:effectLst>
         </p:spPr>
-        <p:txBody>
-          <a:bodyPr/>
-          <a:lstStyle/>
-          <a:p>
-            <a:endParaRPr lang="en-DE"/>
-          </a:p>
-        </p:txBody>
       </p:sp>
       <p:sp>
         <p:nvSpPr>
@@ -1232,7 +1488,7 @@
           <a:bodyPr wrap="square" lIns="0" tIns="0" rIns="0" bIns="0" rtlCol="0" anchor="ctr"/>
           <a:lstStyle/>
           <a:p>
-            <a:pPr marL="0" indent="0" algn="l">
+            <a:pPr algn="l" indent="0" marL="0">
               <a:buNone/>
             </a:pPr>
             <a:r>
@@ -1276,20 +1532,13 @@
             <a:prstDash val="solid"/>
           </a:ln>
           <a:effectLst>
-            <a:outerShdw blurRad="63500" dist="25400" dir="8100000" algn="bl" rotWithShape="0">
+            <a:outerShdw sx="100000" sy="100000" kx="0" ky="0" algn="bl" rotWithShape="0" blurRad="63500" dist="25400" dir="8100000">
               <a:srgbClr val="1F3864">
                 <a:alpha val="12000"/>
               </a:srgbClr>
             </a:outerShdw>
           </a:effectLst>
         </p:spPr>
-        <p:txBody>
-          <a:bodyPr/>
-          <a:lstStyle/>
-          <a:p>
-            <a:endParaRPr lang="en-DE"/>
-          </a:p>
-        </p:txBody>
       </p:sp>
       <p:sp>
         <p:nvSpPr>
@@ -1312,13 +1561,6 @@
           </a:solidFill>
           <a:ln/>
         </p:spPr>
-        <p:txBody>
-          <a:bodyPr/>
-          <a:lstStyle/>
-          <a:p>
-            <a:endParaRPr lang="en-DE"/>
-          </a:p>
-        </p:txBody>
       </p:sp>
       <p:sp>
         <p:nvSpPr>
@@ -1341,7 +1583,7 @@
           <a:bodyPr wrap="square" lIns="0" tIns="0" rIns="0" bIns="0" rtlCol="0" anchor="ctr"/>
           <a:lstStyle/>
           <a:p>
-            <a:pPr marL="0" indent="0" algn="ctr">
+            <a:pPr algn="ctr" indent="0" marL="0">
               <a:buNone/>
             </a:pPr>
             <a:r>
@@ -1355,6 +1597,9 @@
               </a:rPr>
               <a:t>ORCHESTRATOR AGENT</a:t>
             </a:r>
+            <a:pPr algn="ctr" indent="0" marL="0">
+              <a:buNone/>
+            </a:pPr>
             <a:r>
               <a:rPr lang="en-US" sz="1000" dirty="0">
                 <a:solidFill>
@@ -1364,7 +1609,7 @@
                 <a:ea typeface="Segoe UI" pitchFamily="34" charset="-122"/>
                 <a:cs typeface="Segoe UI" pitchFamily="34" charset="-120"/>
               </a:rPr>
-              <a:t>    ·    GPT-5.4</a:t>
+              <a:t xml:space="preserve">    ·    GPT-5.4</a:t>
             </a:r>
             <a:endParaRPr lang="en-US" sz="1000" dirty="0"/>
           </a:p>
@@ -1392,13 +1637,6 @@
             <a:prstDash val="solid"/>
           </a:ln>
         </p:spPr>
-        <p:txBody>
-          <a:bodyPr/>
-          <a:lstStyle/>
-          <a:p>
-            <a:endParaRPr lang="en-DE"/>
-          </a:p>
-        </p:txBody>
       </p:sp>
       <p:sp>
         <p:nvSpPr>
@@ -1421,13 +1659,6 @@
           </a:solidFill>
           <a:ln/>
         </p:spPr>
-        <p:txBody>
-          <a:bodyPr/>
-          <a:lstStyle/>
-          <a:p>
-            <a:endParaRPr lang="en-DE"/>
-          </a:p>
-        </p:txBody>
       </p:sp>
       <p:sp>
         <p:nvSpPr>
@@ -1450,7 +1681,7 @@
           <a:bodyPr wrap="square" lIns="0" tIns="0" rIns="0" bIns="0" rtlCol="0" anchor="ctr"/>
           <a:lstStyle/>
           <a:p>
-            <a:pPr marL="0" indent="0" algn="ctr">
+            <a:pPr algn="ctr" indent="0" marL="0">
               <a:buNone/>
             </a:pPr>
             <a:r>
@@ -1467,7 +1698,7 @@
             <a:endParaRPr lang="en-US" sz="950" dirty="0"/>
           </a:p>
           <a:p>
-            <a:pPr marL="0" indent="0" algn="ctr">
+            <a:pPr algn="ctr" indent="0" marL="0">
               <a:buNone/>
             </a:pPr>
             <a:r>
@@ -1484,7 +1715,7 @@
             <a:endParaRPr lang="en-US" sz="950" dirty="0"/>
           </a:p>
           <a:p>
-            <a:pPr marL="0" indent="0" algn="ctr">
+            <a:pPr algn="ctr" indent="0" marL="0">
               <a:buNone/>
             </a:pPr>
             <a:r>
@@ -1524,13 +1755,6 @@
             <a:prstDash val="solid"/>
           </a:ln>
         </p:spPr>
-        <p:txBody>
-          <a:bodyPr/>
-          <a:lstStyle/>
-          <a:p>
-            <a:endParaRPr lang="en-DE"/>
-          </a:p>
-        </p:txBody>
       </p:sp>
       <p:sp>
         <p:nvSpPr>
@@ -1553,13 +1777,6 @@
           </a:solidFill>
           <a:ln/>
         </p:spPr>
-        <p:txBody>
-          <a:bodyPr/>
-          <a:lstStyle/>
-          <a:p>
-            <a:endParaRPr lang="en-DE"/>
-          </a:p>
-        </p:txBody>
       </p:sp>
       <p:sp>
         <p:nvSpPr>
@@ -1582,7 +1799,7 @@
           <a:bodyPr wrap="square" lIns="0" tIns="0" rIns="0" bIns="0" rtlCol="0" anchor="ctr"/>
           <a:lstStyle/>
           <a:p>
-            <a:pPr marL="0" indent="0" algn="ctr">
+            <a:pPr algn="ctr" indent="0" marL="0">
               <a:buNone/>
             </a:pPr>
             <a:r>
@@ -1599,7 +1816,7 @@
             <a:endParaRPr lang="en-US" sz="950" dirty="0"/>
           </a:p>
           <a:p>
-            <a:pPr marL="0" indent="0" algn="ctr">
+            <a:pPr algn="ctr" indent="0" marL="0">
               <a:buNone/>
             </a:pPr>
             <a:r>
@@ -1616,7 +1833,7 @@
             <a:endParaRPr lang="en-US" sz="950" dirty="0"/>
           </a:p>
           <a:p>
-            <a:pPr marL="0" indent="0" algn="ctr">
+            <a:pPr algn="ctr" indent="0" marL="0">
               <a:buNone/>
             </a:pPr>
             <a:r>
@@ -1656,13 +1873,6 @@
             <a:prstDash val="solid"/>
           </a:ln>
         </p:spPr>
-        <p:txBody>
-          <a:bodyPr/>
-          <a:lstStyle/>
-          <a:p>
-            <a:endParaRPr lang="en-DE"/>
-          </a:p>
-        </p:txBody>
       </p:sp>
       <p:sp>
         <p:nvSpPr>
@@ -1685,13 +1895,6 @@
           </a:solidFill>
           <a:ln/>
         </p:spPr>
-        <p:txBody>
-          <a:bodyPr/>
-          <a:lstStyle/>
-          <a:p>
-            <a:endParaRPr lang="en-DE"/>
-          </a:p>
-        </p:txBody>
       </p:sp>
       <p:sp>
         <p:nvSpPr>
@@ -1714,7 +1917,7 @@
           <a:bodyPr wrap="square" lIns="0" tIns="0" rIns="0" bIns="0" rtlCol="0" anchor="ctr"/>
           <a:lstStyle/>
           <a:p>
-            <a:pPr marL="0" indent="0" algn="ctr">
+            <a:pPr algn="ctr" indent="0" marL="0">
               <a:buNone/>
             </a:pPr>
             <a:r>
@@ -1731,7 +1934,7 @@
             <a:endParaRPr lang="en-US" sz="950" dirty="0"/>
           </a:p>
           <a:p>
-            <a:pPr marL="0" indent="0" algn="ctr">
+            <a:pPr algn="ctr" indent="0" marL="0">
               <a:buNone/>
             </a:pPr>
             <a:r>
@@ -1748,7 +1951,7 @@
             <a:endParaRPr lang="en-US" sz="950" dirty="0"/>
           </a:p>
           <a:p>
-            <a:pPr marL="0" indent="0" algn="ctr">
+            <a:pPr algn="ctr" indent="0" marL="0">
               <a:buNone/>
             </a:pPr>
             <a:r>
@@ -1787,13 +1990,6 @@
           </a:solidFill>
           <a:ln/>
         </p:spPr>
-        <p:txBody>
-          <a:bodyPr/>
-          <a:lstStyle/>
-          <a:p>
-            <a:endParaRPr lang="en-DE"/>
-          </a:p>
-        </p:txBody>
       </p:sp>
       <p:sp>
         <p:nvSpPr>
@@ -1816,7 +2012,7 @@
           <a:bodyPr wrap="square" lIns="0" tIns="0" rIns="0" bIns="0" rtlCol="0" anchor="ctr"/>
           <a:lstStyle/>
           <a:p>
-            <a:pPr marL="0" indent="0" algn="ctr">
+            <a:pPr algn="ctr" indent="0" marL="0">
               <a:buNone/>
             </a:pPr>
             <a:r>
@@ -1855,13 +2051,6 @@
           </a:solidFill>
           <a:ln/>
         </p:spPr>
-        <p:txBody>
-          <a:bodyPr/>
-          <a:lstStyle/>
-          <a:p>
-            <a:endParaRPr lang="en-DE"/>
-          </a:p>
-        </p:txBody>
       </p:sp>
       <p:sp>
         <p:nvSpPr>
@@ -1884,7 +2073,7 @@
           <a:bodyPr wrap="square" lIns="0" tIns="0" rIns="0" bIns="0" rtlCol="0" anchor="ctr"/>
           <a:lstStyle/>
           <a:p>
-            <a:pPr marL="0" indent="0" algn="ctr">
+            <a:pPr algn="ctr" indent="0" marL="0">
               <a:buNone/>
             </a:pPr>
             <a:r>
@@ -1923,7 +2112,7 @@
           <a:bodyPr wrap="square" lIns="0" tIns="0" rIns="0" bIns="0" rtlCol="0" anchor="ctr"/>
           <a:lstStyle/>
           <a:p>
-            <a:pPr marL="0" indent="0" algn="ctr">
+            <a:pPr algn="ctr" indent="0" marL="0">
               <a:buNone/>
             </a:pPr>
             <a:r>
@@ -1950,7 +2139,7 @@
           <p:nvPr/>
         </p:nvPicPr>
         <p:blipFill>
-          <a:blip r:embed="rId4"/>
+          <a:blip r:embed="rId5"/>
           <a:stretch>
             <a:fillRect/>
           </a:stretch>
@@ -1986,7 +2175,7 @@
           <a:bodyPr wrap="square" lIns="0" tIns="0" rIns="0" bIns="0" rtlCol="0" anchor="ctr"/>
           <a:lstStyle/>
           <a:p>
-            <a:pPr marL="0" indent="0" algn="l">
+            <a:pPr algn="l" indent="0" marL="0">
               <a:buNone/>
             </a:pPr>
             <a:r>
@@ -2006,7 +2195,7 @@
       </p:sp>
       <p:graphicFrame>
         <p:nvGraphicFramePr>
-          <p:cNvPr id="33" name="Table 0"/>
+          <p:cNvPr id="2" name="Table 0"/>
           <p:cNvGraphicFramePr>
             <a:graphicFrameLocks noGrp="1"/>
           </p:cNvGraphicFramePr>
@@ -2020,27 +2209,15 @@
         </p:nvGraphicFramePr>
         <p:xfrm>
           <a:off x="6144768" y="1225296"/>
-          <a:ext cx="5742432" cy="1399032"/>
+          <a:ext cx="5742432" cy="914400"/>
         </p:xfrm>
         <a:graphic>
           <a:graphicData uri="http://schemas.openxmlformats.org/drawingml/2006/table">
             <a:tbl>
               <a:tblPr/>
               <a:tblGrid>
-                <a:gridCol w="1371600">
-                  <a:extLst>
-                    <a:ext uri="{9D8B030D-6E8A-4147-A177-3AD203B41FA5}">
-                      <a16:colId xmlns:a16="http://schemas.microsoft.com/office/drawing/2014/main" val="20000"/>
-                    </a:ext>
-                  </a:extLst>
-                </a:gridCol>
-                <a:gridCol w="4370832">
-                  <a:extLst>
-                    <a:ext uri="{9D8B030D-6E8A-4147-A177-3AD203B41FA5}">
-                      <a16:colId xmlns:a16="http://schemas.microsoft.com/office/drawing/2014/main" val="20001"/>
-                    </a:ext>
-                  </a:extLst>
-                </a:gridCol>
+                <a:gridCol w="1371600"/>
+                <a:gridCol w="4370832"/>
               </a:tblGrid>
               <a:tr h="233172">
                 <a:tc>
@@ -2048,7 +2225,7 @@
                     <a:bodyPr/>
                     <a:lstStyle/>
                     <a:p>
-                      <a:pPr marL="0" indent="0">
+                      <a:pPr indent="0" marL="0">
                         <a:buNone/>
                       </a:pPr>
                       <a:r>
@@ -2069,7 +2246,7 @@
                       </a:endParaRPr>
                     </a:p>
                   </a:txBody>
-                  <a:tcPr anchor="ctr">
+                  <a:tcPr marL="91440" marR="91440" marT="45720" marB="45720" anchor="ctr">
                     <a:lnL w="6350" cap="flat" cmpd="sng" algn="ctr">
                       <a:solidFill>
                         <a:srgbClr val="D6DEE8"/>
@@ -2116,7 +2293,7 @@
                     <a:bodyPr/>
                     <a:lstStyle/>
                     <a:p>
-                      <a:pPr marL="0" indent="0">
+                      <a:pPr indent="0" marL="0">
                         <a:buNone/>
                       </a:pPr>
                       <a:r>
@@ -2137,7 +2314,7 @@
                       </a:endParaRPr>
                     </a:p>
                   </a:txBody>
-                  <a:tcPr anchor="ctr">
+                  <a:tcPr marL="91440" marR="91440" marT="45720" marB="45720" anchor="ctr">
                     <a:lnL w="6350" cap="flat" cmpd="sng" algn="ctr">
                       <a:solidFill>
                         <a:srgbClr val="D6DEE8"/>
@@ -2179,11 +2356,6 @@
                     </a:solidFill>
                   </a:tcPr>
                 </a:tc>
-                <a:extLst>
-                  <a:ext uri="{0D108BD9-81ED-4DB2-BD59-A6C34878D82A}">
-                    <a16:rowId xmlns:a16="http://schemas.microsoft.com/office/drawing/2014/main" val="10000"/>
-                  </a:ext>
-                </a:extLst>
               </a:tr>
               <a:tr h="233172">
                 <a:tc>
@@ -2191,7 +2363,7 @@
                     <a:bodyPr/>
                     <a:lstStyle/>
                     <a:p>
-                      <a:pPr marL="0" indent="0">
+                      <a:pPr indent="0" marL="0">
                         <a:buNone/>
                       </a:pPr>
                       <a:r>
@@ -2212,7 +2384,7 @@
                       </a:endParaRPr>
                     </a:p>
                   </a:txBody>
-                  <a:tcPr anchor="ctr">
+                  <a:tcPr marL="91440" marR="91440" marT="45720" marB="45720" anchor="ctr">
                     <a:lnL w="6350" cap="flat" cmpd="sng" algn="ctr">
                       <a:solidFill>
                         <a:srgbClr val="D6DEE8"/>
@@ -2259,7 +2431,7 @@
                     <a:bodyPr/>
                     <a:lstStyle/>
                     <a:p>
-                      <a:pPr marL="0" indent="0">
+                      <a:pPr indent="0" marL="0">
                         <a:buNone/>
                       </a:pPr>
                       <a:r>
@@ -2280,7 +2452,7 @@
                       </a:endParaRPr>
                     </a:p>
                   </a:txBody>
-                  <a:tcPr anchor="ctr">
+                  <a:tcPr marL="91440" marR="91440" marT="45720" marB="45720" anchor="ctr">
                     <a:lnL w="6350" cap="flat" cmpd="sng" algn="ctr">
                       <a:solidFill>
                         <a:srgbClr val="D6DEE8"/>
@@ -2322,11 +2494,6 @@
                     </a:solidFill>
                   </a:tcPr>
                 </a:tc>
-                <a:extLst>
-                  <a:ext uri="{0D108BD9-81ED-4DB2-BD59-A6C34878D82A}">
-                    <a16:rowId xmlns:a16="http://schemas.microsoft.com/office/drawing/2014/main" val="10001"/>
-                  </a:ext>
-                </a:extLst>
               </a:tr>
               <a:tr h="233172">
                 <a:tc>
@@ -2334,7 +2501,7 @@
                     <a:bodyPr/>
                     <a:lstStyle/>
                     <a:p>
-                      <a:pPr marL="0" indent="0">
+                      <a:pPr indent="0" marL="0">
                         <a:buNone/>
                       </a:pPr>
                       <a:r>
@@ -2355,7 +2522,7 @@
                       </a:endParaRPr>
                     </a:p>
                   </a:txBody>
-                  <a:tcPr anchor="ctr">
+                  <a:tcPr marL="91440" marR="91440" marT="45720" marB="45720" anchor="ctr">
                     <a:lnL w="6350" cap="flat" cmpd="sng" algn="ctr">
                       <a:solidFill>
                         <a:srgbClr val="D6DEE8"/>
@@ -2402,7 +2569,7 @@
                     <a:bodyPr/>
                     <a:lstStyle/>
                     <a:p>
-                      <a:pPr marL="0" indent="0">
+                      <a:pPr indent="0" marL="0">
                         <a:buNone/>
                       </a:pPr>
                       <a:r>
@@ -2423,7 +2590,7 @@
                       </a:endParaRPr>
                     </a:p>
                   </a:txBody>
-                  <a:tcPr anchor="ctr">
+                  <a:tcPr marL="91440" marR="91440" marT="45720" marB="45720" anchor="ctr">
                     <a:lnL w="6350" cap="flat" cmpd="sng" algn="ctr">
                       <a:solidFill>
                         <a:srgbClr val="D6DEE8"/>
@@ -2465,11 +2632,6 @@
                     </a:solidFill>
                   </a:tcPr>
                 </a:tc>
-                <a:extLst>
-                  <a:ext uri="{0D108BD9-81ED-4DB2-BD59-A6C34878D82A}">
-                    <a16:rowId xmlns:a16="http://schemas.microsoft.com/office/drawing/2014/main" val="10002"/>
-                  </a:ext>
-                </a:extLst>
               </a:tr>
               <a:tr h="233172">
                 <a:tc>
@@ -2477,7 +2639,7 @@
                     <a:bodyPr/>
                     <a:lstStyle/>
                     <a:p>
-                      <a:pPr marL="0" indent="0">
+                      <a:pPr indent="0" marL="0">
                         <a:buNone/>
                       </a:pPr>
                       <a:r>
@@ -2498,7 +2660,7 @@
                       </a:endParaRPr>
                     </a:p>
                   </a:txBody>
-                  <a:tcPr anchor="ctr">
+                  <a:tcPr marL="91440" marR="91440" marT="45720" marB="45720" anchor="ctr">
                     <a:lnL w="6350" cap="flat" cmpd="sng" algn="ctr">
                       <a:solidFill>
                         <a:srgbClr val="D6DEE8"/>
@@ -2545,7 +2707,7 @@
                     <a:bodyPr/>
                     <a:lstStyle/>
                     <a:p>
-                      <a:pPr marL="0" indent="0">
+                      <a:pPr indent="0" marL="0">
                         <a:buNone/>
                       </a:pPr>
                       <a:r>
@@ -2566,7 +2728,7 @@
                       </a:endParaRPr>
                     </a:p>
                   </a:txBody>
-                  <a:tcPr anchor="ctr">
+                  <a:tcPr marL="91440" marR="91440" marT="45720" marB="45720" anchor="ctr">
                     <a:lnL w="6350" cap="flat" cmpd="sng" algn="ctr">
                       <a:solidFill>
                         <a:srgbClr val="D6DEE8"/>
@@ -2608,11 +2770,6 @@
                     </a:solidFill>
                   </a:tcPr>
                 </a:tc>
-                <a:extLst>
-                  <a:ext uri="{0D108BD9-81ED-4DB2-BD59-A6C34878D82A}">
-                    <a16:rowId xmlns:a16="http://schemas.microsoft.com/office/drawing/2014/main" val="10003"/>
-                  </a:ext>
-                </a:extLst>
               </a:tr>
               <a:tr h="233172">
                 <a:tc>
@@ -2620,7 +2777,7 @@
                     <a:bodyPr/>
                     <a:lstStyle/>
                     <a:p>
-                      <a:pPr marL="0" indent="0">
+                      <a:pPr indent="0" marL="0">
                         <a:buNone/>
                       </a:pPr>
                       <a:r>
@@ -2641,7 +2798,7 @@
                       </a:endParaRPr>
                     </a:p>
                   </a:txBody>
-                  <a:tcPr anchor="ctr">
+                  <a:tcPr marL="91440" marR="91440" marT="45720" marB="45720" anchor="ctr">
                     <a:lnL w="6350" cap="flat" cmpd="sng" algn="ctr">
                       <a:solidFill>
                         <a:srgbClr val="D6DEE8"/>
@@ -2688,7 +2845,7 @@
                     <a:bodyPr/>
                     <a:lstStyle/>
                     <a:p>
-                      <a:pPr marL="0" indent="0">
+                      <a:pPr indent="0" marL="0">
                         <a:buNone/>
                       </a:pPr>
                       <a:r>
@@ -2709,7 +2866,7 @@
                       </a:endParaRPr>
                     </a:p>
                   </a:txBody>
-                  <a:tcPr anchor="ctr">
+                  <a:tcPr marL="91440" marR="91440" marT="45720" marB="45720" anchor="ctr">
                     <a:lnL w="6350" cap="flat" cmpd="sng" algn="ctr">
                       <a:solidFill>
                         <a:srgbClr val="D6DEE8"/>
@@ -2751,11 +2908,6 @@
                     </a:solidFill>
                   </a:tcPr>
                 </a:tc>
-                <a:extLst>
-                  <a:ext uri="{0D108BD9-81ED-4DB2-BD59-A6C34878D82A}">
-                    <a16:rowId xmlns:a16="http://schemas.microsoft.com/office/drawing/2014/main" val="10004"/>
-                  </a:ext>
-                </a:extLst>
               </a:tr>
               <a:tr h="233172">
                 <a:tc>
@@ -2763,7 +2915,7 @@
                     <a:bodyPr/>
                     <a:lstStyle/>
                     <a:p>
-                      <a:pPr marL="0" indent="0">
+                      <a:pPr indent="0" marL="0">
                         <a:buNone/>
                       </a:pPr>
                       <a:r>
@@ -2784,7 +2936,7 @@
                       </a:endParaRPr>
                     </a:p>
                   </a:txBody>
-                  <a:tcPr anchor="ctr">
+                  <a:tcPr marL="91440" marR="91440" marT="45720" marB="45720" anchor="ctr">
                     <a:lnL w="6350" cap="flat" cmpd="sng" algn="ctr">
                       <a:solidFill>
                         <a:srgbClr val="D6DEE8"/>
@@ -2831,7 +2983,7 @@
                     <a:bodyPr/>
                     <a:lstStyle/>
                     <a:p>
-                      <a:pPr marL="0" indent="0">
+                      <a:pPr indent="0" marL="0">
                         <a:buNone/>
                       </a:pPr>
                       <a:r>
@@ -2852,7 +3004,7 @@
                       </a:endParaRPr>
                     </a:p>
                   </a:txBody>
-                  <a:tcPr anchor="ctr">
+                  <a:tcPr marL="91440" marR="91440" marT="45720" marB="45720" anchor="ctr">
                     <a:lnL w="6350" cap="flat" cmpd="sng" algn="ctr">
                       <a:solidFill>
                         <a:srgbClr val="D6DEE8"/>
@@ -2894,11 +3046,6 @@
                     </a:solidFill>
                   </a:tcPr>
                 </a:tc>
-                <a:extLst>
-                  <a:ext uri="{0D108BD9-81ED-4DB2-BD59-A6C34878D82A}">
-                    <a16:rowId xmlns:a16="http://schemas.microsoft.com/office/drawing/2014/main" val="10005"/>
-                  </a:ext>
-                </a:extLst>
               </a:tr>
             </a:tbl>
           </a:graphicData>
@@ -2913,7 +3060,7 @@
           <p:nvPr/>
         </p:nvPicPr>
         <p:blipFill>
-          <a:blip r:embed="rId4"/>
+          <a:blip r:embed="rId6"/>
           <a:stretch>
             <a:fillRect/>
           </a:stretch>
@@ -2949,7 +3096,7 @@
           <a:bodyPr wrap="square" lIns="0" tIns="0" rIns="0" bIns="0" rtlCol="0" anchor="ctr"/>
           <a:lstStyle/>
           <a:p>
-            <a:pPr marL="0" indent="0" algn="l">
+            <a:pPr algn="l" indent="0" marL="0">
               <a:buNone/>
             </a:pPr>
             <a:r>
@@ -2988,7 +3135,7 @@
           <a:bodyPr wrap="square" lIns="0" tIns="0" rIns="0" bIns="0" rtlCol="0" anchor="ctr"/>
           <a:lstStyle/>
           <a:p>
-            <a:pPr marL="0" indent="0" algn="r">
+            <a:pPr algn="r" indent="0" marL="0">
               <a:buNone/>
             </a:pPr>
             <a:r>
@@ -3000,8 +3147,39 @@
                 <a:ea typeface="Segoe UI" pitchFamily="34" charset="-122"/>
                 <a:cs typeface="Segoe UI" pitchFamily="34" charset="-120"/>
               </a:rPr>
-              <a:t>Agnostic </a:t>
-            </a:r>
+              <a:t xml:space="preserve">Agnostic </a:t>
+            </a:r>
+            <a:pPr algn="r" indent="0" marL="0">
+              <a:buNone/>
+            </a:pPr>
+            <a:r>
+              <a:rPr lang="en-US" sz="850" b="1" dirty="0">
+                <a:solidFill>
+                  <a:srgbClr val="F4C430"/>
+                </a:solidFill>
+                <a:latin typeface="Segoe UI" pitchFamily="34" charset="0"/>
+                <a:ea typeface="Segoe UI" pitchFamily="34" charset="-122"/>
+                <a:cs typeface="Segoe UI" pitchFamily="34" charset="-120"/>
+              </a:rPr>
+              <a:t>HERE</a:t>
+            </a:r>
+            <a:pPr algn="r" indent="0" marL="0">
+              <a:buNone/>
+            </a:pPr>
+            <a:r>
+              <a:rPr lang="en-US" sz="850" dirty="0">
+                <a:solidFill>
+                  <a:srgbClr val="FFFFFF"/>
+                </a:solidFill>
+                <a:latin typeface="Segoe UI" pitchFamily="34" charset="0"/>
+                <a:ea typeface="Segoe UI" pitchFamily="34" charset="-122"/>
+                <a:cs typeface="Segoe UI" pitchFamily="34" charset="-120"/>
+              </a:rPr>
+              <a:t xml:space="preserve"> / FSI-Legal </a:t>
+            </a:r>
+            <a:pPr algn="r" indent="0" marL="0">
+              <a:buNone/>
+            </a:pPr>
             <a:r>
               <a:rPr lang="en-US" sz="850" b="1" dirty="0">
                 <a:solidFill>
@@ -3043,20 +3221,13 @@
             <a:prstDash val="solid"/>
           </a:ln>
           <a:effectLst>
-            <a:outerShdw blurRad="63500" dist="25400" dir="8100000" algn="bl" rotWithShape="0">
+            <a:outerShdw sx="100000" sy="100000" kx="0" ky="0" algn="bl" rotWithShape="0" blurRad="63500" dist="25400" dir="8100000">
               <a:srgbClr val="1F3864">
                 <a:alpha val="12000"/>
               </a:srgbClr>
             </a:outerShdw>
           </a:effectLst>
         </p:spPr>
-        <p:txBody>
-          <a:bodyPr/>
-          <a:lstStyle/>
-          <a:p>
-            <a:endParaRPr lang="en-DE"/>
-          </a:p>
-        </p:txBody>
       </p:sp>
       <p:sp>
         <p:nvSpPr>
@@ -3079,7 +3250,7 @@
           <a:bodyPr wrap="square" lIns="0" tIns="0" rIns="0" bIns="0" rtlCol="0" anchor="t"/>
           <a:lstStyle/>
           <a:p>
-            <a:pPr marL="0" indent="0" algn="l">
+            <a:pPr algn="l" indent="0" marL="0">
               <a:buNone/>
             </a:pPr>
             <a:r>
@@ -3096,7 +3267,7 @@
             <a:endParaRPr lang="en-US" sz="820" dirty="0"/>
           </a:p>
           <a:p>
-            <a:pPr marL="0" indent="0" algn="l">
+            <a:pPr algn="l" indent="0" marL="0">
               <a:spcBef>
                 <a:spcPts val="200"/>
               </a:spcBef>
@@ -3122,12 +3293,12 @@
                 <a:ea typeface="Segoe UI" pitchFamily="34" charset="-122"/>
                 <a:cs typeface="Segoe UI" pitchFamily="34" charset="-120"/>
               </a:rPr>
-              <a:t>moving from copilots to autonomous, reasoning agents — value in speed, risk and compliance, on Microsoft Foundry.</a:t>
+              <a:t>moving from copilots to autonomous, reasoning agents — value in speed, risk and compliance, on Azure AI Foundry.</a:t>
             </a:r>
             <a:endParaRPr lang="en-US" sz="820" dirty="0"/>
           </a:p>
           <a:p>
-            <a:pPr marL="0" indent="0" algn="l">
+            <a:pPr algn="l" indent="0" marL="0">
               <a:spcBef>
                 <a:spcPts val="200"/>
               </a:spcBef>
@@ -3158,7 +3329,7 @@
             <a:endParaRPr lang="en-US" sz="820" dirty="0"/>
           </a:p>
           <a:p>
-            <a:pPr marL="0" indent="0" algn="l">
+            <a:pPr algn="l" indent="0" marL="0">
               <a:spcBef>
                 <a:spcPts val="200"/>
               </a:spcBef>
@@ -3184,7 +3355,7 @@
                 <a:ea typeface="Segoe UI" pitchFamily="34" charset="-122"/>
                 <a:cs typeface="Segoe UI" pitchFamily="34" charset="-120"/>
               </a:rPr>
-              <a:t>build the agents, run the GenAIOps loop (tracing, evaluation, safety), and publish to Microsoft 365 Copilot &amp; Teams — capped with a live demo.</a:t>
+              <a:t>build the agents, run the GenAIOps loop (tracing, evaluation, safety), and publish via MCP to Microsoft 365 Copilot &amp; Teams — capped with a live demo.</a:t>
             </a:r>
             <a:endParaRPr lang="en-US" sz="820" dirty="0"/>
           </a:p>
@@ -3199,7 +3370,7 @@
           <p:nvPr/>
         </p:nvPicPr>
         <p:blipFill>
-          <a:blip r:embed="rId4"/>
+          <a:blip r:embed="rId7"/>
           <a:stretch>
             <a:fillRect/>
           </a:stretch>
@@ -3235,7 +3406,7 @@
           <a:bodyPr wrap="square" lIns="0" tIns="0" rIns="0" bIns="0" rtlCol="0" anchor="ctr"/>
           <a:lstStyle/>
           <a:p>
-            <a:pPr marL="0" indent="0" algn="l">
+            <a:pPr algn="l" indent="0" marL="0">
               <a:buNone/>
             </a:pPr>
             <a:r>
@@ -3274,7 +3445,7 @@
           <a:bodyPr wrap="square" lIns="0" tIns="0" rIns="0" bIns="0" rtlCol="0" anchor="ctr"/>
           <a:lstStyle/>
           <a:p>
-            <a:pPr marL="0" indent="0" algn="r">
+            <a:pPr algn="r" indent="0" marL="0">
               <a:buNone/>
             </a:pPr>
             <a:r>
@@ -3286,8 +3457,11 @@
                 <a:ea typeface="Segoe UI" pitchFamily="34" charset="-122"/>
                 <a:cs typeface="Segoe UI" pitchFamily="34" charset="-120"/>
               </a:rPr>
-              <a:t>GitHub Repo </a:t>
-            </a:r>
+              <a:t xml:space="preserve">GitHub Repo </a:t>
+            </a:r>
+            <a:pPr algn="r" indent="0" marL="0">
+              <a:buNone/>
+            </a:pPr>
             <a:r>
               <a:rPr lang="en-US" sz="850" b="1" u="sng" dirty="0">
                 <a:solidFill>
@@ -3296,7 +3470,7 @@
                 <a:latin typeface="Segoe UI" pitchFamily="34" charset="0"/>
                 <a:ea typeface="Segoe UI" pitchFamily="34" charset="-122"/>
                 <a:cs typeface="Segoe UI" pitchFamily="34" charset="-120"/>
-                <a:hlinkClick r:id="rId5">
+                <a:hlinkClick r:id="rId8" invalidUrl="" action="" tgtFrame="" tooltip="" history="1" highlightClick="0" endSnd="0">
                   <a:extLst>
                     <a:ext uri="{A12FA001-AC4F-418D-AE19-62706E023703}">
                       <ahyp:hlinkClr xmlns:ahyp="http://schemas.microsoft.com/office/drawing/2018/hyperlinkcolor" val="tx"/>
@@ -3306,6 +3480,9 @@
               </a:rPr>
               <a:t>HERE</a:t>
             </a:r>
+            <a:pPr algn="r" indent="0" marL="0">
+              <a:buNone/>
+            </a:pPr>
             <a:r>
               <a:rPr lang="en-US" sz="850" dirty="0">
                 <a:solidFill>
@@ -3315,8 +3492,11 @@
                 <a:ea typeface="Segoe UI" pitchFamily="34" charset="-122"/>
                 <a:cs typeface="Segoe UI" pitchFamily="34" charset="-120"/>
               </a:rPr>
-              <a:t> / Train the Trainer video </a:t>
-            </a:r>
+              <a:t xml:space="preserve"> / Train the Trainer video </a:t>
+            </a:r>
+            <a:pPr algn="r" indent="0" marL="0">
+              <a:buNone/>
+            </a:pPr>
             <a:r>
               <a:rPr lang="en-US" sz="850" b="1" dirty="0">
                 <a:solidFill>
@@ -3334,7 +3514,7 @@
       </p:sp>
       <p:graphicFrame>
         <p:nvGraphicFramePr>
-          <p:cNvPr id="42" name="Table 1"/>
+          <p:cNvPr id="3" name="Table 1"/>
           <p:cNvGraphicFramePr>
             <a:graphicFrameLocks noGrp="1"/>
           </p:cNvGraphicFramePr>
@@ -3348,27 +3528,15 @@
         </p:nvGraphicFramePr>
         <p:xfrm>
           <a:off x="6144768" y="4443984"/>
-          <a:ext cx="5742432" cy="1600200"/>
+          <a:ext cx="5742432" cy="914400"/>
         </p:xfrm>
         <a:graphic>
           <a:graphicData uri="http://schemas.openxmlformats.org/drawingml/2006/table">
             <a:tbl>
               <a:tblPr/>
               <a:tblGrid>
-                <a:gridCol w="4919472">
-                  <a:extLst>
-                    <a:ext uri="{9D8B030D-6E8A-4147-A177-3AD203B41FA5}">
-                      <a16:colId xmlns:a16="http://schemas.microsoft.com/office/drawing/2014/main" val="20000"/>
-                    </a:ext>
-                  </a:extLst>
-                </a:gridCol>
-                <a:gridCol w="822960">
-                  <a:extLst>
-                    <a:ext uri="{9D8B030D-6E8A-4147-A177-3AD203B41FA5}">
-                      <a16:colId xmlns:a16="http://schemas.microsoft.com/office/drawing/2014/main" val="20001"/>
-                    </a:ext>
-                  </a:extLst>
-                </a:gridCol>
+                <a:gridCol w="4919472"/>
+                <a:gridCol w="822960"/>
               </a:tblGrid>
               <a:tr h="228600">
                 <a:tc>
@@ -3376,7 +3544,7 @@
                     <a:bodyPr/>
                     <a:lstStyle/>
                     <a:p>
-                      <a:pPr marL="0" indent="0">
+                      <a:pPr indent="0" marL="0">
                         <a:buNone/>
                       </a:pPr>
                       <a:r>
@@ -3397,7 +3565,7 @@
                       </a:endParaRPr>
                     </a:p>
                   </a:txBody>
-                  <a:tcPr anchor="ctr">
+                  <a:tcPr marL="91440" marR="91440" marT="45720" marB="45720" anchor="ctr">
                     <a:lnL w="6350" cap="flat" cmpd="sng" algn="ctr">
                       <a:solidFill>
                         <a:srgbClr val="D6DEE8"/>
@@ -3444,7 +3612,7 @@
                     <a:bodyPr/>
                     <a:lstStyle/>
                     <a:p>
-                      <a:pPr marL="0" indent="0" algn="r">
+                      <a:pPr algn="r" indent="0" marL="0">
                         <a:buNone/>
                       </a:pPr>
                       <a:r>
@@ -3465,7 +3633,7 @@
                       </a:endParaRPr>
                     </a:p>
                   </a:txBody>
-                  <a:tcPr anchor="ctr">
+                  <a:tcPr marL="91440" marR="91440" marT="45720" marB="45720" anchor="ctr">
                     <a:lnL w="6350" cap="flat" cmpd="sng" algn="ctr">
                       <a:solidFill>
                         <a:srgbClr val="D6DEE8"/>
@@ -3507,11 +3675,6 @@
                     </a:solidFill>
                   </a:tcPr>
                 </a:tc>
-                <a:extLst>
-                  <a:ext uri="{0D108BD9-81ED-4DB2-BD59-A6C34878D82A}">
-                    <a16:rowId xmlns:a16="http://schemas.microsoft.com/office/drawing/2014/main" val="10000"/>
-                  </a:ext>
-                </a:extLst>
               </a:tr>
               <a:tr h="228600">
                 <a:tc>
@@ -3519,7 +3682,7 @@
                     <a:bodyPr/>
                     <a:lstStyle/>
                     <a:p>
-                      <a:pPr marL="0" indent="0">
+                      <a:pPr indent="0" marL="0">
                         <a:buNone/>
                       </a:pPr>
                       <a:r>
@@ -3540,7 +3703,7 @@
                       </a:endParaRPr>
                     </a:p>
                   </a:txBody>
-                  <a:tcPr anchor="ctr">
+                  <a:tcPr marL="91440" marR="91440" marT="45720" marB="45720" anchor="ctr">
                     <a:lnL w="6350" cap="flat" cmpd="sng" algn="ctr">
                       <a:solidFill>
                         <a:srgbClr val="D6DEE8"/>
@@ -3587,7 +3750,7 @@
                     <a:bodyPr/>
                     <a:lstStyle/>
                     <a:p>
-                      <a:pPr marL="0" indent="0" algn="r">
+                      <a:pPr algn="r" indent="0" marL="0">
                         <a:buNone/>
                       </a:pPr>
                       <a:r>
@@ -3608,7 +3771,7 @@
                       </a:endParaRPr>
                     </a:p>
                   </a:txBody>
-                  <a:tcPr anchor="ctr">
+                  <a:tcPr marL="91440" marR="91440" marT="45720" marB="45720" anchor="ctr">
                     <a:lnL w="6350" cap="flat" cmpd="sng" algn="ctr">
                       <a:solidFill>
                         <a:srgbClr val="D6DEE8"/>
@@ -3650,11 +3813,6 @@
                     </a:solidFill>
                   </a:tcPr>
                 </a:tc>
-                <a:extLst>
-                  <a:ext uri="{0D108BD9-81ED-4DB2-BD59-A6C34878D82A}">
-                    <a16:rowId xmlns:a16="http://schemas.microsoft.com/office/drawing/2014/main" val="10001"/>
-                  </a:ext>
-                </a:extLst>
               </a:tr>
               <a:tr h="228600">
                 <a:tc>
@@ -3662,7 +3820,7 @@
                     <a:bodyPr/>
                     <a:lstStyle/>
                     <a:p>
-                      <a:pPr marL="0" indent="0">
+                      <a:pPr indent="0" marL="0">
                         <a:buNone/>
                       </a:pPr>
                       <a:r>
@@ -3683,7 +3841,7 @@
                       </a:endParaRPr>
                     </a:p>
                   </a:txBody>
-                  <a:tcPr anchor="ctr">
+                  <a:tcPr marL="91440" marR="91440" marT="45720" marB="45720" anchor="ctr">
                     <a:lnL w="6350" cap="flat" cmpd="sng" algn="ctr">
                       <a:solidFill>
                         <a:srgbClr val="D6DEE8"/>
@@ -3730,7 +3888,7 @@
                     <a:bodyPr/>
                     <a:lstStyle/>
                     <a:p>
-                      <a:pPr marL="0" indent="0" algn="r">
+                      <a:pPr algn="r" indent="0" marL="0">
                         <a:buNone/>
                       </a:pPr>
                       <a:r>
@@ -3751,7 +3909,7 @@
                       </a:endParaRPr>
                     </a:p>
                   </a:txBody>
-                  <a:tcPr anchor="ctr">
+                  <a:tcPr marL="91440" marR="91440" marT="45720" marB="45720" anchor="ctr">
                     <a:lnL w="6350" cap="flat" cmpd="sng" algn="ctr">
                       <a:solidFill>
                         <a:srgbClr val="D6DEE8"/>
@@ -3793,11 +3951,6 @@
                     </a:solidFill>
                   </a:tcPr>
                 </a:tc>
-                <a:extLst>
-                  <a:ext uri="{0D108BD9-81ED-4DB2-BD59-A6C34878D82A}">
-                    <a16:rowId xmlns:a16="http://schemas.microsoft.com/office/drawing/2014/main" val="10002"/>
-                  </a:ext>
-                </a:extLst>
               </a:tr>
               <a:tr h="228600">
                 <a:tc>
@@ -3805,7 +3958,7 @@
                     <a:bodyPr/>
                     <a:lstStyle/>
                     <a:p>
-                      <a:pPr marL="0" indent="0">
+                      <a:pPr indent="0" marL="0">
                         <a:buNone/>
                       </a:pPr>
                       <a:r>
@@ -3826,7 +3979,7 @@
                       </a:endParaRPr>
                     </a:p>
                   </a:txBody>
-                  <a:tcPr anchor="ctr">
+                  <a:tcPr marL="91440" marR="91440" marT="45720" marB="45720" anchor="ctr">
                     <a:lnL w="6350" cap="flat" cmpd="sng" algn="ctr">
                       <a:solidFill>
                         <a:srgbClr val="D6DEE8"/>
@@ -3873,7 +4026,7 @@
                     <a:bodyPr/>
                     <a:lstStyle/>
                     <a:p>
-                      <a:pPr marL="0" indent="0" algn="r">
+                      <a:pPr algn="r" indent="0" marL="0">
                         <a:buNone/>
                       </a:pPr>
                       <a:r>
@@ -3894,7 +4047,7 @@
                       </a:endParaRPr>
                     </a:p>
                   </a:txBody>
-                  <a:tcPr anchor="ctr">
+                  <a:tcPr marL="91440" marR="91440" marT="45720" marB="45720" anchor="ctr">
                     <a:lnL w="6350" cap="flat" cmpd="sng" algn="ctr">
                       <a:solidFill>
                         <a:srgbClr val="D6DEE8"/>
@@ -3936,11 +4089,6 @@
                     </a:solidFill>
                   </a:tcPr>
                 </a:tc>
-                <a:extLst>
-                  <a:ext uri="{0D108BD9-81ED-4DB2-BD59-A6C34878D82A}">
-                    <a16:rowId xmlns:a16="http://schemas.microsoft.com/office/drawing/2014/main" val="10003"/>
-                  </a:ext>
-                </a:extLst>
               </a:tr>
               <a:tr h="228600">
                 <a:tc>
@@ -3948,7 +4096,7 @@
                     <a:bodyPr/>
                     <a:lstStyle/>
                     <a:p>
-                      <a:pPr marL="0" indent="0">
+                      <a:pPr indent="0" marL="0">
                         <a:buNone/>
                       </a:pPr>
                       <a:r>
@@ -3969,7 +4117,7 @@
                       </a:endParaRPr>
                     </a:p>
                   </a:txBody>
-                  <a:tcPr anchor="ctr">
+                  <a:tcPr marL="91440" marR="91440" marT="45720" marB="45720" anchor="ctr">
                     <a:lnL w="6350" cap="flat" cmpd="sng" algn="ctr">
                       <a:solidFill>
                         <a:srgbClr val="D6DEE8"/>
@@ -4016,7 +4164,7 @@
                     <a:bodyPr/>
                     <a:lstStyle/>
                     <a:p>
-                      <a:pPr marL="0" indent="0" algn="r">
+                      <a:pPr algn="r" indent="0" marL="0">
                         <a:buNone/>
                       </a:pPr>
                       <a:r>
@@ -4037,7 +4185,7 @@
                       </a:endParaRPr>
                     </a:p>
                   </a:txBody>
-                  <a:tcPr anchor="ctr">
+                  <a:tcPr marL="91440" marR="91440" marT="45720" marB="45720" anchor="ctr">
                     <a:lnL w="6350" cap="flat" cmpd="sng" algn="ctr">
                       <a:solidFill>
                         <a:srgbClr val="D6DEE8"/>
@@ -4079,11 +4227,6 @@
                     </a:solidFill>
                   </a:tcPr>
                 </a:tc>
-                <a:extLst>
-                  <a:ext uri="{0D108BD9-81ED-4DB2-BD59-A6C34878D82A}">
-                    <a16:rowId xmlns:a16="http://schemas.microsoft.com/office/drawing/2014/main" val="10004"/>
-                  </a:ext>
-                </a:extLst>
               </a:tr>
               <a:tr h="228600">
                 <a:tc>
@@ -4091,7 +4234,7 @@
                     <a:bodyPr/>
                     <a:lstStyle/>
                     <a:p>
-                      <a:pPr marL="0" indent="0">
+                      <a:pPr indent="0" marL="0">
                         <a:buNone/>
                       </a:pPr>
                       <a:r>
@@ -4112,7 +4255,7 @@
                       </a:endParaRPr>
                     </a:p>
                   </a:txBody>
-                  <a:tcPr anchor="ctr">
+                  <a:tcPr marL="91440" marR="91440" marT="45720" marB="45720" anchor="ctr">
                     <a:lnL w="6350" cap="flat" cmpd="sng" algn="ctr">
                       <a:solidFill>
                         <a:srgbClr val="D6DEE8"/>
@@ -4159,7 +4302,7 @@
                     <a:bodyPr/>
                     <a:lstStyle/>
                     <a:p>
-                      <a:pPr marL="0" indent="0" algn="r">
+                      <a:pPr algn="r" indent="0" marL="0">
                         <a:buNone/>
                       </a:pPr>
                       <a:r>
@@ -4180,7 +4323,7 @@
                       </a:endParaRPr>
                     </a:p>
                   </a:txBody>
-                  <a:tcPr anchor="ctr">
+                  <a:tcPr marL="91440" marR="91440" marT="45720" marB="45720" anchor="ctr">
                     <a:lnL w="6350" cap="flat" cmpd="sng" algn="ctr">
                       <a:solidFill>
                         <a:srgbClr val="D6DEE8"/>
@@ -4222,11 +4365,6 @@
                     </a:solidFill>
                   </a:tcPr>
                 </a:tc>
-                <a:extLst>
-                  <a:ext uri="{0D108BD9-81ED-4DB2-BD59-A6C34878D82A}">
-                    <a16:rowId xmlns:a16="http://schemas.microsoft.com/office/drawing/2014/main" val="10005"/>
-                  </a:ext>
-                </a:extLst>
               </a:tr>
               <a:tr h="228600">
                 <a:tc>
@@ -4234,7 +4372,7 @@
                     <a:bodyPr/>
                     <a:lstStyle/>
                     <a:p>
-                      <a:pPr marL="0" indent="0">
+                      <a:pPr indent="0" marL="0">
                         <a:buNone/>
                       </a:pPr>
                       <a:r>
@@ -4246,8 +4384,11 @@
                           <a:ea typeface="Segoe UI" pitchFamily="34" charset="-122"/>
                           <a:cs typeface="Segoe UI" pitchFamily="34" charset="-120"/>
                         </a:rPr>
-                        <a:t>5   Safety, Red-Teaming &amp; Continuous Eval   </a:t>
+                        <a:t xml:space="preserve">5   Safety, Red-Teaming &amp; Continuous Eval   </a:t>
                       </a:r>
+                      <a:pPr indent="0" marL="0">
+                        <a:buNone/>
+                      </a:pPr>
                       <a:r>
                         <a:rPr lang="en-US" sz="900" b="1" dirty="0">
                           <a:solidFill>
@@ -4266,7 +4407,7 @@
                       </a:endParaRPr>
                     </a:p>
                   </a:txBody>
-                  <a:tcPr anchor="ctr">
+                  <a:tcPr marL="91440" marR="91440" marT="45720" marB="45720" anchor="ctr">
                     <a:lnL w="6350" cap="flat" cmpd="sng" algn="ctr">
                       <a:solidFill>
                         <a:srgbClr val="D6DEE8"/>
@@ -4313,7 +4454,7 @@
                     <a:bodyPr/>
                     <a:lstStyle/>
                     <a:p>
-                      <a:pPr marL="0" indent="0" algn="r">
+                      <a:pPr algn="r" indent="0" marL="0">
                         <a:buNone/>
                       </a:pPr>
                       <a:r>
@@ -4334,7 +4475,7 @@
                       </a:endParaRPr>
                     </a:p>
                   </a:txBody>
-                  <a:tcPr anchor="ctr">
+                  <a:tcPr marL="91440" marR="91440" marT="45720" marB="45720" anchor="ctr">
                     <a:lnL w="6350" cap="flat" cmpd="sng" algn="ctr">
                       <a:solidFill>
                         <a:srgbClr val="D6DEE8"/>
@@ -4376,11 +4517,6 @@
                     </a:solidFill>
                   </a:tcPr>
                 </a:tc>
-                <a:extLst>
-                  <a:ext uri="{0D108BD9-81ED-4DB2-BD59-A6C34878D82A}">
-                    <a16:rowId xmlns:a16="http://schemas.microsoft.com/office/drawing/2014/main" val="10006"/>
-                  </a:ext>
-                </a:extLst>
               </a:tr>
             </a:tbl>
           </a:graphicData>
@@ -4395,7 +4531,7 @@
           <p:nvPr/>
         </p:nvPicPr>
         <p:blipFill>
-          <a:blip r:embed="rId4"/>
+          <a:blip r:embed="rId9"/>
           <a:stretch>
             <a:fillRect/>
           </a:stretch>
@@ -4431,7 +4567,7 @@
           <a:bodyPr wrap="square" lIns="0" tIns="0" rIns="0" bIns="0" rtlCol="0" anchor="ctr"/>
           <a:lstStyle/>
           <a:p>
-            <a:pPr marL="0" indent="0" algn="l">
+            <a:pPr algn="l" indent="0" marL="0">
               <a:buNone/>
             </a:pPr>
             <a:r>
@@ -4470,7 +4606,7 @@
           <a:bodyPr wrap="square" lIns="0" tIns="0" rIns="0" bIns="0" rtlCol="0" anchor="ctr"/>
           <a:lstStyle/>
           <a:p>
-            <a:pPr marL="0" indent="0" algn="r">
+            <a:pPr algn="r" indent="0" marL="0">
               <a:buNone/>
             </a:pPr>
             <a:r>
@@ -4789,325 +4925,4 @@
     </a:ext>
   </a:extLst>
 </a:theme>
-</file>
-
-<file path=ppt/theme/theme2.xml><?xml version="1.0" encoding="utf-8"?>
-<a:theme xmlns:a="http://schemas.openxmlformats.org/drawingml/2006/main" name="Office Theme">
-  <a:themeElements>
-    <a:clrScheme name="Office">
-      <a:dk1>
-        <a:sysClr val="windowText" lastClr="000000"/>
-      </a:dk1>
-      <a:lt1>
-        <a:sysClr val="window" lastClr="FFFFFF"/>
-      </a:lt1>
-      <a:dk2>
-        <a:srgbClr val="0E2841"/>
-      </a:dk2>
-      <a:lt2>
-        <a:srgbClr val="E8E8E8"/>
-      </a:lt2>
-      <a:accent1>
-        <a:srgbClr val="156082"/>
-      </a:accent1>
-      <a:accent2>
-        <a:srgbClr val="E97132"/>
-      </a:accent2>
-      <a:accent3>
-        <a:srgbClr val="196B24"/>
-      </a:accent3>
-      <a:accent4>
-        <a:srgbClr val="0F9ED5"/>
-      </a:accent4>
-      <a:accent5>
-        <a:srgbClr val="A02B93"/>
-      </a:accent5>
-      <a:accent6>
-        <a:srgbClr val="4EA72E"/>
-      </a:accent6>
-      <a:hlink>
-        <a:srgbClr val="467886"/>
-      </a:hlink>
-      <a:folHlink>
-        <a:srgbClr val="96607D"/>
-      </a:folHlink>
-    </a:clrScheme>
-    <a:fontScheme name="Office">
-      <a:majorFont>
-        <a:latin typeface="Aptos Display" panose="02110004020202020204"/>
-        <a:ea typeface=""/>
-        <a:cs typeface=""/>
-        <a:font script="Jpan" typeface="游ゴシック Light"/>
-        <a:font script="Hang" typeface="맑은 고딕"/>
-        <a:font script="Hans" typeface="等线 Light"/>
-        <a:font script="Hant" typeface="新細明體"/>
-        <a:font script="Arab" typeface="Times New Roman"/>
-        <a:font script="Hebr" typeface="Times New Roman"/>
-        <a:font script="Thai" typeface="Angsana New"/>
-        <a:font script="Ethi" typeface="Nyala"/>
-        <a:font script="Beng" typeface="Vrinda"/>
-        <a:font script="Gujr" typeface="Shruti"/>
-        <a:font script="Khmr" typeface="MoolBoran"/>
-        <a:font script="Knda" typeface="Tunga"/>
-        <a:font script="Guru" typeface="Raavi"/>
-        <a:font script="Cans" typeface="Euphemia"/>
-        <a:font script="Cher" typeface="Plantagenet Cherokee"/>
-        <a:font script="Yiii" typeface="Microsoft Yi Baiti"/>
-        <a:font script="Tibt" typeface="Microsoft Himalaya"/>
-        <a:font script="Thaa" typeface="MV Boli"/>
-        <a:font script="Deva" typeface="Mangal"/>
-        <a:font script="Telu" typeface="Gautami"/>
-        <a:font script="Taml" typeface="Latha"/>
-        <a:font script="Syrc" typeface="Estrangelo Edessa"/>
-        <a:font script="Orya" typeface="Kalinga"/>
-        <a:font script="Mlym" typeface="Kartika"/>
-        <a:font script="Laoo" typeface="DokChampa"/>
-        <a:font script="Sinh" typeface="Iskoola Pota"/>
-        <a:font script="Mong" typeface="Mongolian Baiti"/>
-        <a:font script="Viet" typeface="Times New Roman"/>
-        <a:font script="Uigh" typeface="Microsoft Uighur"/>
-        <a:font script="Geor" typeface="Sylfaen"/>
-        <a:font script="Armn" typeface="Arial"/>
-        <a:font script="Bugi" typeface="Leelawadee UI"/>
-        <a:font script="Bopo" typeface="Microsoft JhengHei"/>
-        <a:font script="Java" typeface="Javanese Text"/>
-        <a:font script="Lisu" typeface="Segoe UI"/>
-        <a:font script="Mymr" typeface="Myanmar Text"/>
-        <a:font script="Nkoo" typeface="Ebrima"/>
-        <a:font script="Olck" typeface="Nirmala UI"/>
-        <a:font script="Osma" typeface="Ebrima"/>
-        <a:font script="Phag" typeface="Phagspa"/>
-        <a:font script="Syrn" typeface="Estrangelo Edessa"/>
-        <a:font script="Syrj" typeface="Estrangelo Edessa"/>
-        <a:font script="Syre" typeface="Estrangelo Edessa"/>
-        <a:font script="Sora" typeface="Nirmala UI"/>
-        <a:font script="Tale" typeface="Microsoft Tai Le"/>
-        <a:font script="Talu" typeface="Microsoft New Tai Lue"/>
-        <a:font script="Tfng" typeface="Ebrima"/>
-      </a:majorFont>
-      <a:minorFont>
-        <a:latin typeface="Aptos" panose="02110004020202020204"/>
-        <a:ea typeface=""/>
-        <a:cs typeface=""/>
-        <a:font script="Jpan" typeface="游ゴシック"/>
-        <a:font script="Hang" typeface="맑은 고딕"/>
-        <a:font script="Hans" typeface="等线"/>
-        <a:font script="Hant" typeface="新細明體"/>
-        <a:font script="Arab" typeface="Arial"/>
-        <a:font script="Hebr" typeface="Arial"/>
-        <a:font script="Thai" typeface="Cordia New"/>
-        <a:font script="Ethi" typeface="Nyala"/>
-        <a:font script="Beng" typeface="Vrinda"/>
-        <a:font script="Gujr" typeface="Shruti"/>
-        <a:font script="Khmr" typeface="DaunPenh"/>
-        <a:font script="Knda" typeface="Tunga"/>
-        <a:font script="Guru" typeface="Raavi"/>
-        <a:font script="Cans" typeface="Euphemia"/>
-        <a:font script="Cher" typeface="Plantagenet Cherokee"/>
-        <a:font script="Yiii" typeface="Microsoft Yi Baiti"/>
-        <a:font script="Tibt" typeface="Microsoft Himalaya"/>
-        <a:font script="Thaa" typeface="MV Boli"/>
-        <a:font script="Deva" typeface="Mangal"/>
-        <a:font script="Telu" typeface="Gautami"/>
-        <a:font script="Taml" typeface="Latha"/>
-        <a:font script="Syrc" typeface="Estrangelo Edessa"/>
-        <a:font script="Orya" typeface="Kalinga"/>
-        <a:font script="Mlym" typeface="Kartika"/>
-        <a:font script="Laoo" typeface="DokChampa"/>
-        <a:font script="Sinh" typeface="Iskoola Pota"/>
-        <a:font script="Mong" typeface="Mongolian Baiti"/>
-        <a:font script="Viet" typeface="Arial"/>
-        <a:font script="Uigh" typeface="Microsoft Uighur"/>
-        <a:font script="Geor" typeface="Sylfaen"/>
-        <a:font script="Armn" typeface="Arial"/>
-        <a:font script="Bugi" typeface="Leelawadee UI"/>
-        <a:font script="Bopo" typeface="Microsoft JhengHei"/>
-        <a:font script="Java" typeface="Javanese Text"/>
-        <a:font script="Lisu" typeface="Segoe UI"/>
-        <a:font script="Mymr" typeface="Myanmar Text"/>
-        <a:font script="Nkoo" typeface="Ebrima"/>
-        <a:font script="Olck" typeface="Nirmala UI"/>
-        <a:font script="Osma" typeface="Ebrima"/>
-        <a:font script="Phag" typeface="Phagspa"/>
-        <a:font script="Syrn" typeface="Estrangelo Edessa"/>
-        <a:font script="Syrj" typeface="Estrangelo Edessa"/>
-        <a:font script="Syre" typeface="Estrangelo Edessa"/>
-        <a:font script="Sora" typeface="Nirmala UI"/>
-        <a:font script="Tale" typeface="Microsoft Tai Le"/>
-        <a:font script="Talu" typeface="Microsoft New Tai Lue"/>
-        <a:font script="Tfng" typeface="Ebrima"/>
-      </a:minorFont>
-    </a:fontScheme>
-    <a:fmtScheme name="Office">
-      <a:fillStyleLst>
-        <a:solidFill>
-          <a:schemeClr val="phClr"/>
-        </a:solidFill>
-        <a:gradFill rotWithShape="1">
-          <a:gsLst>
-            <a:gs pos="0">
-              <a:schemeClr val="phClr">
-                <a:lumMod val="110000"/>
-                <a:satMod val="105000"/>
-                <a:tint val="67000"/>
-              </a:schemeClr>
-            </a:gs>
-            <a:gs pos="50000">
-              <a:schemeClr val="phClr">
-                <a:lumMod val="105000"/>
-                <a:satMod val="103000"/>
-                <a:tint val="73000"/>
-              </a:schemeClr>
-            </a:gs>
-            <a:gs pos="100000">
-              <a:schemeClr val="phClr">
-                <a:lumMod val="105000"/>
-                <a:satMod val="109000"/>
-                <a:tint val="81000"/>
-              </a:schemeClr>
-            </a:gs>
-          </a:gsLst>
-          <a:lin ang="5400000" scaled="0"/>
-        </a:gradFill>
-        <a:gradFill rotWithShape="1">
-          <a:gsLst>
-            <a:gs pos="0">
-              <a:schemeClr val="phClr">
-                <a:satMod val="103000"/>
-                <a:lumMod val="102000"/>
-                <a:tint val="94000"/>
-              </a:schemeClr>
-            </a:gs>
-            <a:gs pos="50000">
-              <a:schemeClr val="phClr">
-                <a:satMod val="110000"/>
-                <a:lumMod val="100000"/>
-                <a:shade val="100000"/>
-              </a:schemeClr>
-            </a:gs>
-            <a:gs pos="100000">
-              <a:schemeClr val="phClr">
-                <a:lumMod val="99000"/>
-                <a:satMod val="120000"/>
-                <a:shade val="78000"/>
-              </a:schemeClr>
-            </a:gs>
-          </a:gsLst>
-          <a:lin ang="5400000" scaled="0"/>
-        </a:gradFill>
-      </a:fillStyleLst>
-      <a:lnStyleLst>
-        <a:ln w="12700" cap="flat" cmpd="sng" algn="ctr">
-          <a:solidFill>
-            <a:schemeClr val="phClr"/>
-          </a:solidFill>
-          <a:prstDash val="solid"/>
-          <a:miter lim="800000"/>
-        </a:ln>
-        <a:ln w="19050" cap="flat" cmpd="sng" algn="ctr">
-          <a:solidFill>
-            <a:schemeClr val="phClr"/>
-          </a:solidFill>
-          <a:prstDash val="solid"/>
-          <a:miter lim="800000"/>
-        </a:ln>
-        <a:ln w="25400" cap="flat" cmpd="sng" algn="ctr">
-          <a:solidFill>
-            <a:schemeClr val="phClr"/>
-          </a:solidFill>
-          <a:prstDash val="solid"/>
-          <a:miter lim="800000"/>
-        </a:ln>
-      </a:lnStyleLst>
-      <a:effectStyleLst>
-        <a:effectStyle>
-          <a:effectLst/>
-        </a:effectStyle>
-        <a:effectStyle>
-          <a:effectLst/>
-        </a:effectStyle>
-        <a:effectStyle>
-          <a:effectLst>
-            <a:outerShdw blurRad="57150" dist="19050" dir="5400000" algn="ctr" rotWithShape="0">
-              <a:srgbClr val="000000">
-                <a:alpha val="63000"/>
-              </a:srgbClr>
-            </a:outerShdw>
-          </a:effectLst>
-        </a:effectStyle>
-      </a:effectStyleLst>
-      <a:bgFillStyleLst>
-        <a:solidFill>
-          <a:schemeClr val="phClr"/>
-        </a:solidFill>
-        <a:solidFill>
-          <a:schemeClr val="phClr">
-            <a:tint val="95000"/>
-            <a:satMod val="170000"/>
-          </a:schemeClr>
-        </a:solidFill>
-        <a:gradFill rotWithShape="1">
-          <a:gsLst>
-            <a:gs pos="0">
-              <a:schemeClr val="phClr">
-                <a:tint val="93000"/>
-                <a:satMod val="150000"/>
-                <a:shade val="98000"/>
-                <a:lumMod val="102000"/>
-              </a:schemeClr>
-            </a:gs>
-            <a:gs pos="50000">
-              <a:schemeClr val="phClr">
-                <a:tint val="98000"/>
-                <a:satMod val="130000"/>
-                <a:shade val="90000"/>
-                <a:lumMod val="103000"/>
-              </a:schemeClr>
-            </a:gs>
-            <a:gs pos="100000">
-              <a:schemeClr val="phClr">
-                <a:shade val="63000"/>
-                <a:satMod val="120000"/>
-              </a:schemeClr>
-            </a:gs>
-          </a:gsLst>
-          <a:lin ang="5400000" scaled="0"/>
-        </a:gradFill>
-      </a:bgFillStyleLst>
-    </a:fmtScheme>
-  </a:themeElements>
-  <a:objectDefaults>
-    <a:lnDef>
-      <a:spPr/>
-      <a:bodyPr/>
-      <a:lstStyle/>
-      <a:style>
-        <a:lnRef idx="2">
-          <a:schemeClr val="accent1"/>
-        </a:lnRef>
-        <a:fillRef idx="0">
-          <a:schemeClr val="accent1"/>
-        </a:fillRef>
-        <a:effectRef idx="1">
-          <a:schemeClr val="accent1"/>
-        </a:effectRef>
-        <a:fontRef idx="minor">
-          <a:schemeClr val="tx1"/>
-        </a:fontRef>
-      </a:style>
-    </a:lnDef>
-  </a:objectDefaults>
-  <a:extraClrSchemeLst/>
-  <a:extLst>
-    <a:ext uri="{05A4C25C-085E-4340-85A3-A5531E510DB2}">
-      <thm15:themeFamily xmlns:thm15="http://schemas.microsoft.com/office/thememl/2012/main" name="Office Theme" id="{2E142A2C-CD16-42D6-873A-C26D2A0506FA}" vid="{1BDDFF52-6CD6-40A5-AB3C-68EB2F1E4D0A}"/>
-    </a:ext>
-  </a:extLst>
-</a:theme>
-</file>
-
-<file path=docMetadata/LabelInfo.xml><?xml version="1.0" encoding="utf-8"?>
-<clbl:labelList xmlns:clbl="http://schemas.microsoft.com/office/2020/mipLabelMetadata">
-  <clbl:label id="{f42aa342-8706-4288-bd11-ebb85995028c}" enabled="1" method="Standard" siteId="{72f988bf-86f1-41af-91ab-2d7cd011db47}" contentBits="0" removed="0"/>
-</clbl:labelList>
 </file>
</xml_diff>

<commit_message>
docs(marketing): reframe Use case as cross-industry with real impact metrics
Reposition the CLM use case as cross-industry (not FSI/Legal), per the
X-Industry 1-pager. Use case box now opens industry-neutral, cites real
impact figures (~30-50% faster request-to-signature, ~15-30% less outside
counsel & rework, ~2-5% less revenue leakage) and closes with a
Cross-industry note. Tech Talk deck label changed from Agnostic/FSI-Legal
to a single Cross-industry deck link. Body set to 8.5pt to fit; no
geometry changed.

Co-authored-by: Copilot App <223556219+Copilot@users.noreply.github.com>
Copilot-Session: 2fc86db1-1f76-4b83-b234-329556a5f335
</commit_message>
<xml_diff>
--- a/docs/marketing/CLM-Microhack-BOM.pptx
+++ b/docs/marketing/CLM-Microhack-BOM.pptx
@@ -4,12 +4,12 @@
   <p:sldMasterIdLst>
     <p:sldMasterId id="2147483648" r:id="rId1"/>
   </p:sldMasterIdLst>
+  <p:sldIdLst>
+    <p:sldId id="256" r:id="rId2"/>
+  </p:sldIdLst>
   <p:notesMasterIdLst>
     <p:notesMasterId r:id="rId3"/>
   </p:notesMasterIdLst>
-  <p:sldIdLst>
-    <p:sldId id="256" r:id="rId2"/>
-  </p:sldIdLst>
   <p:sldSz cx="12192000" cy="6858000"/>
   <p:notesSz cx="6858000" cy="12192000"/>
   <p:defaultTextStyle>
@@ -104,11 +104,6 @@
       </a:defRPr>
     </a:lvl9pPr>
   </p:defaultTextStyle>
-  <p:extLst>
-    <p:ext uri="{EFAFB233-063F-42B5-8137-9DF3F51BA10A}">
-      <p15:sldGuideLst xmlns:p15="http://schemas.microsoft.com/office/powerpoint/2012/main"/>
-    </p:ext>
-  </p:extLst>
 </p:presentation>
 </file>
 
@@ -134,10 +129,234 @@
           <a:chExt cx="0" cy="0"/>
         </a:xfrm>
       </p:grpSpPr>
+      <p:sp>
+        <p:nvSpPr>
+          <p:cNvPr id="2" name="Header Placeholder 1"/>
+          <p:cNvSpPr>
+            <a:spLocks noGrp="1"/>
+          </p:cNvSpPr>
+          <p:nvPr>
+            <p:ph type="hdr" sz="quarter"/>
+          </p:nvPr>
+        </p:nvSpPr>
+        <p:spPr>
+          <a:xfrm>
+            <a:off x="0" y="0"/>
+            <a:ext cx="2971800" cy="458788"/>
+          </a:xfrm>
+          <a:prstGeom prst="rect">
+            <a:avLst/>
+          </a:prstGeom>
+        </p:spPr>
+        <p:txBody>
+          <a:bodyPr vert="horz" lIns="91440" tIns="45720" rIns="91440" bIns="45720" rtlCol="0"/>
+          <a:lstStyle>
+            <a:lvl1pPr algn="l">
+              <a:defRPr sz="1200"/>
+            </a:lvl1pPr>
+          </a:lstStyle>
+          <a:p>
+            <a:endParaRPr lang="en-US"/>
+          </a:p>
+        </p:txBody>
+      </p:sp>
+      <p:sp>
+        <p:nvSpPr>
+          <p:cNvPr id="3" name="Date Placeholder 2"/>
+          <p:cNvSpPr>
+            <a:spLocks noGrp="1"/>
+          </p:cNvSpPr>
+          <p:nvPr>
+            <p:ph type="dt" idx="1"/>
+          </p:nvPr>
+        </p:nvSpPr>
+        <p:spPr>
+          <a:xfrm>
+            <a:off x="3884613" y="0"/>
+            <a:ext cx="2971800" cy="458788"/>
+          </a:xfrm>
+          <a:prstGeom prst="rect">
+            <a:avLst/>
+          </a:prstGeom>
+        </p:spPr>
+        <p:txBody>
+          <a:bodyPr vert="horz" lIns="91440" tIns="45720" rIns="91440" bIns="45720" rtlCol="0"/>
+          <a:lstStyle>
+            <a:lvl1pPr algn="r">
+              <a:defRPr sz="1200"/>
+            </a:lvl1pPr>
+          </a:lstStyle>
+          <a:p>
+            <a:fld id="{5282F153-3F37-0F45-9E97-73ACFA13230C}" type="datetimeFigureOut">
+              <a:rPr lang="en-US"/>
+              <a:t>7/23/19</a:t>
+            </a:fld>
+            <a:endParaRPr lang="en-US"/>
+          </a:p>
+        </p:txBody>
+      </p:sp>
+      <p:sp>
+        <p:nvSpPr>
+          <p:cNvPr id="4" name="Slide Image Placeholder 3"/>
+          <p:cNvSpPr>
+            <a:spLocks noGrp="1" noRot="1" noChangeAspect="1"/>
+          </p:cNvSpPr>
+          <p:nvPr>
+            <p:ph type="sldImg" idx="2"/>
+          </p:nvPr>
+        </p:nvSpPr>
+        <p:spPr>
+          <a:xfrm>
+            <a:off x="685800" y="1143000"/>
+            <a:ext cx="5486400" cy="3086100"/>
+          </a:xfrm>
+          <a:prstGeom prst="rect">
+            <a:avLst/>
+          </a:prstGeom>
+          <a:noFill/>
+          <a:ln w="12700">
+            <a:solidFill>
+              <a:prstClr val="black"/>
+            </a:solidFill>
+          </a:ln>
+        </p:spPr>
+        <p:txBody>
+          <a:bodyPr vert="horz" lIns="91440" tIns="45720" rIns="91440" bIns="45720" rtlCol="0" anchor="ctr"/>
+          <a:lstStyle/>
+          <a:p>
+            <a:endParaRPr lang="en-US"/>
+          </a:p>
+        </p:txBody>
+      </p:sp>
+      <p:sp>
+        <p:nvSpPr>
+          <p:cNvPr id="5" name="Notes Placeholder 4"/>
+          <p:cNvSpPr>
+            <a:spLocks noGrp="1"/>
+          </p:cNvSpPr>
+          <p:nvPr>
+            <p:ph type="body" sz="quarter" idx="3"/>
+          </p:nvPr>
+        </p:nvSpPr>
+        <p:spPr>
+          <a:xfrm>
+            <a:off x="685800" y="4400550"/>
+            <a:ext cx="5486400" cy="3600450"/>
+          </a:xfrm>
+          <a:prstGeom prst="rect">
+            <a:avLst/>
+          </a:prstGeom>
+        </p:spPr>
+        <p:txBody>
+          <a:bodyPr vert="horz" lIns="91440" tIns="45720" rIns="91440" bIns="45720" rtlCol="0"/>
+          <a:lstStyle/>
+          <a:p>
+            <a:pPr lvl="0"/>
+            <a:r>
+              <a:rPr lang="en-US"/>
+              <a:t>Click to edit Master text styles</a:t>
+            </a:r>
+          </a:p>
+          <a:p>
+            <a:pPr lvl="1"/>
+            <a:r>
+              <a:rPr lang="en-US"/>
+              <a:t>Second level</a:t>
+            </a:r>
+          </a:p>
+          <a:p>
+            <a:pPr lvl="2"/>
+            <a:r>
+              <a:rPr lang="en-US"/>
+              <a:t>Third level</a:t>
+            </a:r>
+          </a:p>
+          <a:p>
+            <a:pPr lvl="3"/>
+            <a:r>
+              <a:rPr lang="en-US"/>
+              <a:t>Fourth level</a:t>
+            </a:r>
+          </a:p>
+          <a:p>
+            <a:pPr lvl="4"/>
+            <a:r>
+              <a:rPr lang="en-US"/>
+              <a:t>Fifth level</a:t>
+            </a:r>
+          </a:p>
+        </p:txBody>
+      </p:sp>
+      <p:sp>
+        <p:nvSpPr>
+          <p:cNvPr id="6" name="Footer Placeholder 5"/>
+          <p:cNvSpPr>
+            <a:spLocks noGrp="1"/>
+          </p:cNvSpPr>
+          <p:nvPr>
+            <p:ph type="ftr" sz="quarter" idx="4"/>
+          </p:nvPr>
+        </p:nvSpPr>
+        <p:spPr>
+          <a:xfrm>
+            <a:off x="0" y="8685213"/>
+            <a:ext cx="2971800" cy="458787"/>
+          </a:xfrm>
+          <a:prstGeom prst="rect">
+            <a:avLst/>
+          </a:prstGeom>
+        </p:spPr>
+        <p:txBody>
+          <a:bodyPr vert="horz" lIns="91440" tIns="45720" rIns="91440" bIns="45720" rtlCol="0" anchor="b"/>
+          <a:lstStyle>
+            <a:lvl1pPr algn="l">
+              <a:defRPr sz="1200"/>
+            </a:lvl1pPr>
+          </a:lstStyle>
+          <a:p>
+            <a:endParaRPr lang="en-US"/>
+          </a:p>
+        </p:txBody>
+      </p:sp>
+      <p:sp>
+        <p:nvSpPr>
+          <p:cNvPr id="7" name="Slide Number Placeholder 6"/>
+          <p:cNvSpPr>
+            <a:spLocks noGrp="1"/>
+          </p:cNvSpPr>
+          <p:nvPr>
+            <p:ph type="sldNum" sz="quarter" idx="5"/>
+          </p:nvPr>
+        </p:nvSpPr>
+        <p:spPr>
+          <a:xfrm>
+            <a:off x="3884613" y="8685213"/>
+            <a:ext cx="2971800" cy="458787"/>
+          </a:xfrm>
+          <a:prstGeom prst="rect">
+            <a:avLst/>
+          </a:prstGeom>
+        </p:spPr>
+        <p:txBody>
+          <a:bodyPr vert="horz" lIns="91440" tIns="45720" rIns="91440" bIns="45720" rtlCol="0" anchor="b"/>
+          <a:lstStyle>
+            <a:lvl1pPr algn="r">
+              <a:defRPr sz="1200"/>
+            </a:lvl1pPr>
+          </a:lstStyle>
+          <a:p>
+            <a:fld id="{CE5E9CC1-C706-0F49-92D6-E571CC5EEA8F}" type="slidenum">
+              <a:rPr lang="en-US"/>
+              <a:t>‹#›</a:t>
+            </a:fld>
+            <a:endParaRPr lang="en-US"/>
+          </a:p>
+        </p:txBody>
+      </p:sp>
     </p:spTree>
     <p:extLst>
       <p:ext uri="{BB962C8B-B14F-4D97-AF65-F5344CB8AC3E}">
-        <p14:creationId xmlns:p14="http://schemas.microsoft.com/office/powerpoint/2010/main" val="4238507043"/>
+        <p14:creationId xmlns:p14="http://schemas.microsoft.com/office/powerpoint/2010/main" val="1024086991"/>
       </p:ext>
     </p:extLst>
   </p:cSld>
@@ -281,6 +500,10 @@
           <a:bodyPr/>
           <a:lstStyle/>
           <a:p>
+            <a:r>
+              <a:rPr lang="en-US" dirty="0"/>
+              <a:t/>
+            </a:r>
             <a:endParaRPr lang="en-US" dirty="0"/>
           </a:p>
         </p:txBody>
@@ -354,11 +577,6 @@
 <file path=ppt/slideMasters/slideMaster1.xml><?xml version="1.0" encoding="utf-8"?>
 <p:sldMaster xmlns:a="http://schemas.openxmlformats.org/drawingml/2006/main" xmlns:r="http://schemas.openxmlformats.org/officeDocument/2006/relationships" xmlns:p="http://schemas.openxmlformats.org/presentationml/2006/main">
   <p:cSld>
-    <p:bg>
-      <p:bgRef idx="1001">
-        <a:schemeClr val="bg1"/>
-      </p:bgRef>
-    </p:bg>
     <p:spTree>
       <p:nvGrpSpPr>
         <p:cNvPr id="1" name=""/>
@@ -639,7 +857,7 @@
     <p:bg>
       <p:bgPr>
         <a:blipFill dpi="0" rotWithShape="1">
-          <a:blip r:embed="rId3">
+          <a:blip r:embed="rId1">
             <a:lum/>
           </a:blip>
           <a:srcRect/>
@@ -685,7 +903,7 @@
           <a:bodyPr wrap="square" lIns="0" tIns="0" rIns="0" bIns="0" rtlCol="0" anchor="ctr"/>
           <a:lstStyle/>
           <a:p>
-            <a:pPr marL="0" indent="0" algn="l">
+            <a:pPr algn="l" indent="0" marL="0">
               <a:buNone/>
             </a:pPr>
             <a:r>
@@ -699,6 +917,9 @@
               </a:rPr>
               <a:t>Agentic AI Hacks</a:t>
             </a:r>
+            <a:pPr algn="l" indent="0" marL="0">
+              <a:buNone/>
+            </a:pPr>
             <a:r>
               <a:rPr lang="en-US" sz="2700" b="1" dirty="0">
                 <a:solidFill>
@@ -708,8 +929,11 @@
                 <a:ea typeface="Segoe UI" pitchFamily="34" charset="-122"/>
                 <a:cs typeface="Segoe UI" pitchFamily="34" charset="-120"/>
               </a:rPr>
-              <a:t>  |  </a:t>
-            </a:r>
+              <a:t xml:space="preserve">  |  </a:t>
+            </a:r>
+            <a:pPr algn="l" indent="0" marL="0">
+              <a:buNone/>
+            </a:pPr>
             <a:r>
               <a:rPr lang="en-US" sz="2700" b="1" dirty="0">
                 <a:solidFill>
@@ -734,7 +958,7 @@
           <p:nvPr/>
         </p:nvPicPr>
         <p:blipFill>
-          <a:blip r:embed="rId4"/>
+          <a:blip r:embed="rId2"/>
           <a:stretch>
             <a:fillRect/>
           </a:stretch>
@@ -770,7 +994,7 @@
           <a:bodyPr wrap="square" lIns="0" tIns="0" rIns="0" bIns="0" rtlCol="0" anchor="ctr"/>
           <a:lstStyle/>
           <a:p>
-            <a:pPr marL="0" indent="0" algn="l">
+            <a:pPr algn="l" indent="0" marL="0">
               <a:buNone/>
             </a:pPr>
             <a:r>
@@ -809,7 +1033,7 @@
           <a:bodyPr wrap="square" lIns="0" tIns="0" rIns="0" bIns="0" rtlCol="0" anchor="ctr"/>
           <a:lstStyle/>
           <a:p>
-            <a:pPr marL="0" indent="0" algn="r">
+            <a:pPr algn="r" indent="0" marL="0">
               <a:buNone/>
             </a:pPr>
             <a:r>
@@ -821,8 +1045,11 @@
                 <a:ea typeface="Segoe UI" pitchFamily="34" charset="-122"/>
                 <a:cs typeface="Segoe UI" pitchFamily="34" charset="-120"/>
               </a:rPr>
-              <a:t>Reg Page Copy </a:t>
-            </a:r>
+              <a:t xml:space="preserve">Reg Page Copy </a:t>
+            </a:r>
+            <a:pPr algn="r" indent="0" marL="0">
+              <a:buNone/>
+            </a:pPr>
             <a:r>
               <a:rPr lang="en-US" sz="850" b="1" dirty="0">
                 <a:solidFill>
@@ -834,6 +1061,9 @@
               </a:rPr>
               <a:t>HERE</a:t>
             </a:r>
+            <a:pPr algn="r" indent="0" marL="0">
+              <a:buNone/>
+            </a:pPr>
             <a:r>
               <a:rPr lang="en-US" sz="850" dirty="0">
                 <a:solidFill>
@@ -843,8 +1073,11 @@
                 <a:ea typeface="Segoe UI" pitchFamily="34" charset="-122"/>
                 <a:cs typeface="Segoe UI" pitchFamily="34" charset="-120"/>
               </a:rPr>
-              <a:t> / Invitation Copy </a:t>
-            </a:r>
+              <a:t xml:space="preserve"> / Invitation Copy </a:t>
+            </a:r>
+            <a:pPr algn="r" indent="0" marL="0">
+              <a:buNone/>
+            </a:pPr>
             <a:r>
               <a:rPr lang="en-US" sz="850" b="1" dirty="0">
                 <a:solidFill>
@@ -856,6 +1089,9 @@
               </a:rPr>
               <a:t>HERE</a:t>
             </a:r>
+            <a:pPr algn="r" indent="0" marL="0">
+              <a:buNone/>
+            </a:pPr>
             <a:r>
               <a:rPr lang="en-US" sz="850" dirty="0">
                 <a:solidFill>
@@ -865,8 +1101,11 @@
                 <a:ea typeface="Segoe UI" pitchFamily="34" charset="-122"/>
                 <a:cs typeface="Segoe UI" pitchFamily="34" charset="-120"/>
               </a:rPr>
-              <a:t> / Marketing BOM </a:t>
-            </a:r>
+              <a:t xml:space="preserve"> / Marketing BOM </a:t>
+            </a:r>
+            <a:pPr algn="r" indent="0" marL="0">
+              <a:buNone/>
+            </a:pPr>
             <a:r>
               <a:rPr lang="en-US" sz="850" b="1" dirty="0">
                 <a:solidFill>
@@ -891,7 +1130,7 @@
           <p:nvPr/>
         </p:nvPicPr>
         <p:blipFill>
-          <a:blip r:embed="rId4"/>
+          <a:blip r:embed="rId3"/>
           <a:stretch>
             <a:fillRect/>
           </a:stretch>
@@ -927,7 +1166,7 @@
           <a:bodyPr wrap="square" lIns="0" tIns="0" rIns="0" bIns="0" rtlCol="0" anchor="ctr"/>
           <a:lstStyle/>
           <a:p>
-            <a:pPr marL="0" indent="0" algn="l">
+            <a:pPr algn="l" indent="0" marL="0">
               <a:buNone/>
             </a:pPr>
             <a:r>
@@ -971,20 +1210,13 @@
             <a:prstDash val="solid"/>
           </a:ln>
           <a:effectLst>
-            <a:outerShdw blurRad="63500" dist="25400" dir="8100000" algn="bl" rotWithShape="0">
+            <a:outerShdw sx="100000" sy="100000" kx="0" ky="0" algn="bl" rotWithShape="0" blurRad="63500" dist="25400" dir="8100000">
               <a:srgbClr val="1F3864">
                 <a:alpha val="12000"/>
               </a:srgbClr>
             </a:outerShdw>
           </a:effectLst>
         </p:spPr>
-        <p:txBody>
-          <a:bodyPr/>
-          <a:lstStyle/>
-          <a:p>
-            <a:endParaRPr lang="en-DE"/>
-          </a:p>
-        </p:txBody>
       </p:sp>
       <p:sp>
         <p:nvSpPr>
@@ -1007,11 +1239,11 @@
           <a:bodyPr wrap="square" lIns="0" tIns="0" rIns="0" bIns="0" rtlCol="0" anchor="t"/>
           <a:lstStyle/>
           <a:p>
-            <a:pPr marL="0" indent="0" algn="l">
+            <a:pPr algn="l" indent="0" marL="0">
               <a:buNone/>
             </a:pPr>
             <a:r>
-              <a:rPr lang="en-US" sz="880" dirty="0">
+              <a:rPr lang="en-US" sz="850" dirty="0">
                 <a:solidFill>
                   <a:srgbClr val="2B2B2B"/>
                 </a:solidFill>
@@ -1019,19 +1251,19 @@
                 <a:ea typeface="Segoe UI" pitchFamily="34" charset="-122"/>
                 <a:cs typeface="Segoe UI" pitchFamily="34" charset="-120"/>
               </a:rPr>
-              <a:t>Enterprises sign hundreds of contracts a month. Legal &amp; Procurement drown in intake, clause review and renewals — ~17-day turnaround and ~11% of auto-renewals missed.</a:t>
-            </a:r>
-            <a:endParaRPr lang="en-US" sz="880" dirty="0"/>
+              <a:t>Every organization runs on contracts. Drafts arrive in mixed formats, clause libraries go unused, reviews stall in inboxes, and obligations slip after signature.</a:t>
+            </a:r>
+            <a:endParaRPr lang="en-US" sz="850" dirty="0"/>
           </a:p>
           <a:p>
-            <a:pPr marL="0" indent="0" algn="l">
+            <a:pPr algn="l" indent="0" marL="0">
               <a:spcBef>
                 <a:spcPts val="400"/>
               </a:spcBef>
               <a:buNone/>
             </a:pPr>
             <a:r>
-              <a:rPr lang="en-US" sz="880" dirty="0">
+              <a:rPr lang="en-US" sz="850" dirty="0">
                 <a:solidFill>
                   <a:srgbClr val="2B2B2B"/>
                 </a:solidFill>
@@ -1039,19 +1271,19 @@
                 <a:ea typeface="Segoe UI" pitchFamily="34" charset="-122"/>
                 <a:cs typeface="Segoe UI" pitchFamily="34" charset="-120"/>
               </a:rPr>
-              <a:t>Traditional CLM is scattered across SharePoint, email and legacy systems; comparing a counterparty draft to the enterprise standard is slow and manual.</a:t>
-            </a:r>
-            <a:endParaRPr lang="en-US" sz="880" dirty="0"/>
+              <a:t>Comparing a third-party draft to the enterprise standard is slow and manual, so deviations and missed renewals go unnoticed until they cost money.</a:t>
+            </a:r>
+            <a:endParaRPr lang="en-US" sz="850" dirty="0"/>
           </a:p>
           <a:p>
-            <a:pPr marL="0" indent="0" algn="l">
+            <a:pPr algn="l" indent="0" marL="0">
               <a:spcBef>
                 <a:spcPts val="400"/>
               </a:spcBef>
               <a:buNone/>
             </a:pPr>
             <a:r>
-              <a:rPr lang="en-US" sz="880" b="1" dirty="0">
+              <a:rPr lang="en-US" sz="850" b="1" dirty="0">
                 <a:solidFill>
                   <a:srgbClr val="1F6FB4"/>
                 </a:solidFill>
@@ -1059,10 +1291,10 @@
                 <a:ea typeface="Segoe UI" pitchFamily="34" charset="-122"/>
                 <a:cs typeface="Segoe UI" pitchFamily="34" charset="-120"/>
               </a:rPr>
-              <a:t>Agentic CLM </a:t>
-            </a:r>
-            <a:r>
-              <a:rPr lang="en-US" sz="880" dirty="0">
+              <a:t xml:space="preserve">Agentic CLM </a:t>
+            </a:r>
+            <a:r>
+              <a:rPr lang="en-US" sz="850" dirty="0">
                 <a:solidFill>
                   <a:srgbClr val="2B2B2B"/>
                 </a:solidFill>
@@ -1070,19 +1302,19 @@
                 <a:ea typeface="Segoe UI" pitchFamily="34" charset="-122"/>
                 <a:cs typeface="Segoe UI" pitchFamily="34" charset="-120"/>
               </a:rPr>
-              <a:t>puts an orchestrator + grounded specialist agents on top: draft from approved templates, extract and risk-score clauses, answer cited questions, and proactively alert on renewals — with human sign-off and full tracing.</a:t>
-            </a:r>
-            <a:endParaRPr lang="en-US" sz="880" dirty="0"/>
+              <a:t>puts an orchestrator + grounded specialist agents on top: draft from approved templates, extract and risk-score clauses, route reviews, capture e-signatures, and track obligations — with human sign-off and full tracing.</a:t>
+            </a:r>
+            <a:endParaRPr lang="en-US" sz="850" dirty="0"/>
           </a:p>
           <a:p>
-            <a:pPr marL="0" indent="0" algn="l">
+            <a:pPr algn="l" indent="0" marL="0">
               <a:spcBef>
                 <a:spcPts val="400"/>
               </a:spcBef>
               <a:buNone/>
             </a:pPr>
             <a:r>
-              <a:rPr lang="en-US" sz="880" b="1" dirty="0">
+              <a:rPr lang="en-US" sz="850" b="1" dirty="0">
                 <a:solidFill>
                   <a:srgbClr val="1F6FB4"/>
                 </a:solidFill>
@@ -1090,10 +1322,10 @@
                 <a:ea typeface="Segoe UI" pitchFamily="34" charset="-122"/>
                 <a:cs typeface="Segoe UI" pitchFamily="34" charset="-120"/>
               </a:rPr>
-              <a:t>Concretely: </a:t>
-            </a:r>
-            <a:r>
-              <a:rPr lang="en-US" sz="880" dirty="0">
+              <a:t xml:space="preserve">Impact: </a:t>
+            </a:r>
+            <a:r>
+              <a:rPr lang="en-US" sz="850" dirty="0">
                 <a:solidFill>
                   <a:srgbClr val="2B2B2B"/>
                 </a:solidFill>
@@ -1101,19 +1333,19 @@
                 <a:ea typeface="Segoe UI" pitchFamily="34" charset="-122"/>
                 <a:cs typeface="Segoe UI" pitchFamily="34" charset="-120"/>
               </a:rPr>
-              <a:t>cited template drafts, risk-scored clauses, and human-approved renewal alerts.</a:t>
-            </a:r>
-            <a:endParaRPr lang="en-US" sz="880" dirty="0"/>
+              <a:t>~30–50% faster request-to-signature, ~15–30% less outside counsel &amp; rework, and ~2–5% less revenue leakage from missed renewals.</a:t>
+            </a:r>
+            <a:endParaRPr lang="en-US" sz="850" dirty="0"/>
           </a:p>
           <a:p>
-            <a:pPr marL="0" indent="0" algn="l">
+            <a:pPr algn="l" indent="0" marL="0">
               <a:spcBef>
                 <a:spcPts val="400"/>
               </a:spcBef>
               <a:buNone/>
             </a:pPr>
             <a:r>
-              <a:rPr lang="en-US" sz="880" b="1" dirty="0">
+              <a:rPr lang="en-US" sz="850" b="1" dirty="0">
                 <a:solidFill>
                   <a:srgbClr val="1F6FB4"/>
                 </a:solidFill>
@@ -1121,10 +1353,10 @@
                 <a:ea typeface="Segoe UI" pitchFamily="34" charset="-122"/>
                 <a:cs typeface="Segoe UI" pitchFamily="34" charset="-120"/>
               </a:rPr>
-              <a:t>Beyond FSI &amp; Legal: </a:t>
-            </a:r>
-            <a:r>
-              <a:rPr lang="en-US" sz="880" dirty="0">
+              <a:t xml:space="preserve">Cross-industry: </a:t>
+            </a:r>
+            <a:r>
+              <a:rPr lang="en-US" sz="850" dirty="0">
                 <a:solidFill>
                   <a:srgbClr val="2B2B2B"/>
                 </a:solidFill>
@@ -1132,9 +1364,9 @@
                 <a:ea typeface="Segoe UI" pitchFamily="34" charset="-122"/>
                 <a:cs typeface="Segoe UI" pitchFamily="34" charset="-120"/>
               </a:rPr>
-              <a:t>the agentic pattern extends to any contract-heavy function — procurement, sales, HR — so attendees leave with a template they can reuse in their own industry.</a:t>
-            </a:r>
-            <a:endParaRPr lang="en-US" sz="880" dirty="0"/>
+              <a:t>every sector runs on contracts, so the same pattern serves legal, procurement and sales in any business — attendees leave with a reusable template.</a:t>
+            </a:r>
+            <a:endParaRPr lang="en-US" sz="850" dirty="0"/>
           </a:p>
         </p:txBody>
       </p:sp>
@@ -1183,7 +1415,7 @@
           <a:bodyPr wrap="square" lIns="0" tIns="0" rIns="0" bIns="0" rtlCol="0" anchor="ctr"/>
           <a:lstStyle/>
           <a:p>
-            <a:pPr marL="0" indent="0" algn="l">
+            <a:pPr algn="l" indent="0" marL="0">
               <a:buNone/>
             </a:pPr>
             <a:r>
@@ -1227,20 +1459,13 @@
             <a:prstDash val="solid"/>
           </a:ln>
           <a:effectLst>
-            <a:outerShdw blurRad="63500" dist="25400" dir="8100000" algn="bl" rotWithShape="0">
+            <a:outerShdw sx="100000" sy="100000" kx="0" ky="0" algn="bl" rotWithShape="0" blurRad="63500" dist="25400" dir="8100000">
               <a:srgbClr val="1F3864">
                 <a:alpha val="12000"/>
               </a:srgbClr>
             </a:outerShdw>
           </a:effectLst>
         </p:spPr>
-        <p:txBody>
-          <a:bodyPr/>
-          <a:lstStyle/>
-          <a:p>
-            <a:endParaRPr lang="en-DE"/>
-          </a:p>
-        </p:txBody>
       </p:sp>
       <p:sp>
         <p:nvSpPr>
@@ -1263,7 +1488,7 @@
           <a:bodyPr wrap="square" lIns="0" tIns="0" rIns="0" bIns="0" rtlCol="0" anchor="ctr"/>
           <a:lstStyle/>
           <a:p>
-            <a:pPr marL="0" indent="0" algn="l">
+            <a:pPr algn="l" indent="0" marL="0">
               <a:buNone/>
             </a:pPr>
             <a:r>
@@ -1307,20 +1532,13 @@
             <a:prstDash val="solid"/>
           </a:ln>
           <a:effectLst>
-            <a:outerShdw blurRad="63500" dist="25400" dir="8100000" algn="bl" rotWithShape="0">
+            <a:outerShdw sx="100000" sy="100000" kx="0" ky="0" algn="bl" rotWithShape="0" blurRad="63500" dist="25400" dir="8100000">
               <a:srgbClr val="1F3864">
                 <a:alpha val="12000"/>
               </a:srgbClr>
             </a:outerShdw>
           </a:effectLst>
         </p:spPr>
-        <p:txBody>
-          <a:bodyPr/>
-          <a:lstStyle/>
-          <a:p>
-            <a:endParaRPr lang="en-DE"/>
-          </a:p>
-        </p:txBody>
       </p:sp>
       <p:sp>
         <p:nvSpPr>
@@ -1343,13 +1561,6 @@
           </a:solidFill>
           <a:ln/>
         </p:spPr>
-        <p:txBody>
-          <a:bodyPr/>
-          <a:lstStyle/>
-          <a:p>
-            <a:endParaRPr lang="en-DE"/>
-          </a:p>
-        </p:txBody>
       </p:sp>
       <p:sp>
         <p:nvSpPr>
@@ -1372,7 +1583,7 @@
           <a:bodyPr wrap="square" lIns="0" tIns="0" rIns="0" bIns="0" rtlCol="0" anchor="ctr"/>
           <a:lstStyle/>
           <a:p>
-            <a:pPr marL="0" indent="0" algn="ctr">
+            <a:pPr algn="ctr" indent="0" marL="0">
               <a:buNone/>
             </a:pPr>
             <a:r>
@@ -1386,6 +1597,9 @@
               </a:rPr>
               <a:t>ORCHESTRATOR AGENT</a:t>
             </a:r>
+            <a:pPr algn="ctr" indent="0" marL="0">
+              <a:buNone/>
+            </a:pPr>
             <a:r>
               <a:rPr lang="en-US" sz="1000" dirty="0">
                 <a:solidFill>
@@ -1395,7 +1609,7 @@
                 <a:ea typeface="Segoe UI" pitchFamily="34" charset="-122"/>
                 <a:cs typeface="Segoe UI" pitchFamily="34" charset="-120"/>
               </a:rPr>
-              <a:t>    ·    GPT-5.4</a:t>
+              <a:t xml:space="preserve">    ·    GPT-5.4</a:t>
             </a:r>
             <a:endParaRPr lang="en-US" sz="1000" dirty="0"/>
           </a:p>
@@ -1423,13 +1637,6 @@
             <a:prstDash val="solid"/>
           </a:ln>
         </p:spPr>
-        <p:txBody>
-          <a:bodyPr/>
-          <a:lstStyle/>
-          <a:p>
-            <a:endParaRPr lang="en-DE"/>
-          </a:p>
-        </p:txBody>
       </p:sp>
       <p:sp>
         <p:nvSpPr>
@@ -1452,13 +1659,6 @@
           </a:solidFill>
           <a:ln/>
         </p:spPr>
-        <p:txBody>
-          <a:bodyPr/>
-          <a:lstStyle/>
-          <a:p>
-            <a:endParaRPr lang="en-DE"/>
-          </a:p>
-        </p:txBody>
       </p:sp>
       <p:sp>
         <p:nvSpPr>
@@ -1481,7 +1681,7 @@
           <a:bodyPr wrap="square" lIns="0" tIns="0" rIns="0" bIns="0" rtlCol="0" anchor="ctr"/>
           <a:lstStyle/>
           <a:p>
-            <a:pPr marL="0" indent="0" algn="ctr">
+            <a:pPr algn="ctr" indent="0" marL="0">
               <a:buNone/>
             </a:pPr>
             <a:r>
@@ -1498,7 +1698,7 @@
             <a:endParaRPr lang="en-US" sz="950" dirty="0"/>
           </a:p>
           <a:p>
-            <a:pPr marL="0" indent="0" algn="ctr">
+            <a:pPr algn="ctr" indent="0" marL="0">
               <a:buNone/>
             </a:pPr>
             <a:r>
@@ -1515,7 +1715,7 @@
             <a:endParaRPr lang="en-US" sz="950" dirty="0"/>
           </a:p>
           <a:p>
-            <a:pPr marL="0" indent="0" algn="ctr">
+            <a:pPr algn="ctr" indent="0" marL="0">
               <a:buNone/>
             </a:pPr>
             <a:r>
@@ -1555,13 +1755,6 @@
             <a:prstDash val="solid"/>
           </a:ln>
         </p:spPr>
-        <p:txBody>
-          <a:bodyPr/>
-          <a:lstStyle/>
-          <a:p>
-            <a:endParaRPr lang="en-DE"/>
-          </a:p>
-        </p:txBody>
       </p:sp>
       <p:sp>
         <p:nvSpPr>
@@ -1584,13 +1777,6 @@
           </a:solidFill>
           <a:ln/>
         </p:spPr>
-        <p:txBody>
-          <a:bodyPr/>
-          <a:lstStyle/>
-          <a:p>
-            <a:endParaRPr lang="en-DE"/>
-          </a:p>
-        </p:txBody>
       </p:sp>
       <p:sp>
         <p:nvSpPr>
@@ -1613,7 +1799,7 @@
           <a:bodyPr wrap="square" lIns="0" tIns="0" rIns="0" bIns="0" rtlCol="0" anchor="ctr"/>
           <a:lstStyle/>
           <a:p>
-            <a:pPr marL="0" indent="0" algn="ctr">
+            <a:pPr algn="ctr" indent="0" marL="0">
               <a:buNone/>
             </a:pPr>
             <a:r>
@@ -1630,7 +1816,7 @@
             <a:endParaRPr lang="en-US" sz="950" dirty="0"/>
           </a:p>
           <a:p>
-            <a:pPr marL="0" indent="0" algn="ctr">
+            <a:pPr algn="ctr" indent="0" marL="0">
               <a:buNone/>
             </a:pPr>
             <a:r>
@@ -1647,7 +1833,7 @@
             <a:endParaRPr lang="en-US" sz="950" dirty="0"/>
           </a:p>
           <a:p>
-            <a:pPr marL="0" indent="0" algn="ctr">
+            <a:pPr algn="ctr" indent="0" marL="0">
               <a:buNone/>
             </a:pPr>
             <a:r>
@@ -1687,13 +1873,6 @@
             <a:prstDash val="solid"/>
           </a:ln>
         </p:spPr>
-        <p:txBody>
-          <a:bodyPr/>
-          <a:lstStyle/>
-          <a:p>
-            <a:endParaRPr lang="en-DE"/>
-          </a:p>
-        </p:txBody>
       </p:sp>
       <p:sp>
         <p:nvSpPr>
@@ -1716,13 +1895,6 @@
           </a:solidFill>
           <a:ln/>
         </p:spPr>
-        <p:txBody>
-          <a:bodyPr/>
-          <a:lstStyle/>
-          <a:p>
-            <a:endParaRPr lang="en-DE"/>
-          </a:p>
-        </p:txBody>
       </p:sp>
       <p:sp>
         <p:nvSpPr>
@@ -1745,7 +1917,7 @@
           <a:bodyPr wrap="square" lIns="0" tIns="0" rIns="0" bIns="0" rtlCol="0" anchor="ctr"/>
           <a:lstStyle/>
           <a:p>
-            <a:pPr marL="0" indent="0" algn="ctr">
+            <a:pPr algn="ctr" indent="0" marL="0">
               <a:buNone/>
             </a:pPr>
             <a:r>
@@ -1762,7 +1934,7 @@
             <a:endParaRPr lang="en-US" sz="950" dirty="0"/>
           </a:p>
           <a:p>
-            <a:pPr marL="0" indent="0" algn="ctr">
+            <a:pPr algn="ctr" indent="0" marL="0">
               <a:buNone/>
             </a:pPr>
             <a:r>
@@ -1779,7 +1951,7 @@
             <a:endParaRPr lang="en-US" sz="950" dirty="0"/>
           </a:p>
           <a:p>
-            <a:pPr marL="0" indent="0" algn="ctr">
+            <a:pPr algn="ctr" indent="0" marL="0">
               <a:buNone/>
             </a:pPr>
             <a:r>
@@ -1818,13 +1990,6 @@
           </a:solidFill>
           <a:ln/>
         </p:spPr>
-        <p:txBody>
-          <a:bodyPr/>
-          <a:lstStyle/>
-          <a:p>
-            <a:endParaRPr lang="en-DE"/>
-          </a:p>
-        </p:txBody>
       </p:sp>
       <p:sp>
         <p:nvSpPr>
@@ -1847,7 +2012,7 @@
           <a:bodyPr wrap="square" lIns="0" tIns="0" rIns="0" bIns="0" rtlCol="0" anchor="ctr"/>
           <a:lstStyle/>
           <a:p>
-            <a:pPr marL="0" indent="0" algn="ctr">
+            <a:pPr algn="ctr" indent="0" marL="0">
               <a:buNone/>
             </a:pPr>
             <a:r>
@@ -1886,13 +2051,6 @@
           </a:solidFill>
           <a:ln/>
         </p:spPr>
-        <p:txBody>
-          <a:bodyPr/>
-          <a:lstStyle/>
-          <a:p>
-            <a:endParaRPr lang="en-DE"/>
-          </a:p>
-        </p:txBody>
       </p:sp>
       <p:sp>
         <p:nvSpPr>
@@ -1915,7 +2073,7 @@
           <a:bodyPr wrap="square" lIns="0" tIns="0" rIns="0" bIns="0" rtlCol="0" anchor="ctr"/>
           <a:lstStyle/>
           <a:p>
-            <a:pPr marL="0" indent="0" algn="ctr">
+            <a:pPr algn="ctr" indent="0" marL="0">
               <a:buNone/>
             </a:pPr>
             <a:r>
@@ -1954,7 +2112,7 @@
           <a:bodyPr wrap="square" lIns="0" tIns="0" rIns="0" bIns="0" rtlCol="0" anchor="ctr"/>
           <a:lstStyle/>
           <a:p>
-            <a:pPr marL="0" indent="0" algn="ctr">
+            <a:pPr algn="ctr" indent="0" marL="0">
               <a:buNone/>
             </a:pPr>
             <a:r>
@@ -1981,7 +2139,7 @@
           <p:nvPr/>
         </p:nvPicPr>
         <p:blipFill>
-          <a:blip r:embed="rId4"/>
+          <a:blip r:embed="rId5"/>
           <a:stretch>
             <a:fillRect/>
           </a:stretch>
@@ -2017,7 +2175,7 @@
           <a:bodyPr wrap="square" lIns="0" tIns="0" rIns="0" bIns="0" rtlCol="0" anchor="ctr"/>
           <a:lstStyle/>
           <a:p>
-            <a:pPr marL="0" indent="0" algn="l">
+            <a:pPr algn="l" indent="0" marL="0">
               <a:buNone/>
             </a:pPr>
             <a:r>
@@ -2037,41 +2195,29 @@
       </p:sp>
       <p:graphicFrame>
         <p:nvGraphicFramePr>
-          <p:cNvPr id="33" name="Table 0"/>
+          <p:cNvPr id="2" name="Table 0"/>
           <p:cNvGraphicFramePr>
             <a:graphicFrameLocks noGrp="1"/>
           </p:cNvGraphicFramePr>
           <p:nvPr>
             <p:extLst>
               <p:ext uri="{D42A27DB-BD31-4B8C-83A1-F6EECF244321}">
-                <p14:modId xmlns:p14="http://schemas.microsoft.com/office/powerpoint/2010/main" val="2124427120"/>
+                <p14:modId xmlns:p14="http://schemas.microsoft.com/office/powerpoint/2010/main" val="1579011935"/>
               </p:ext>
             </p:extLst>
           </p:nvPr>
         </p:nvGraphicFramePr>
         <p:xfrm>
           <a:off x="6144768" y="1225296"/>
-          <a:ext cx="5742432" cy="1399032"/>
+          <a:ext cx="5742432" cy="914400"/>
         </p:xfrm>
         <a:graphic>
           <a:graphicData uri="http://schemas.openxmlformats.org/drawingml/2006/table">
             <a:tbl>
               <a:tblPr/>
               <a:tblGrid>
-                <a:gridCol w="1371600">
-                  <a:extLst>
-                    <a:ext uri="{9D8B030D-6E8A-4147-A177-3AD203B41FA5}">
-                      <a16:colId xmlns:a16="http://schemas.microsoft.com/office/drawing/2014/main" val="20000"/>
-                    </a:ext>
-                  </a:extLst>
-                </a:gridCol>
-                <a:gridCol w="4370832">
-                  <a:extLst>
-                    <a:ext uri="{9D8B030D-6E8A-4147-A177-3AD203B41FA5}">
-                      <a16:colId xmlns:a16="http://schemas.microsoft.com/office/drawing/2014/main" val="20001"/>
-                    </a:ext>
-                  </a:extLst>
-                </a:gridCol>
+                <a:gridCol w="1371600"/>
+                <a:gridCol w="4370832"/>
               </a:tblGrid>
               <a:tr h="233172">
                 <a:tc>
@@ -2079,7 +2225,7 @@
                     <a:bodyPr/>
                     <a:lstStyle/>
                     <a:p>
-                      <a:pPr marL="0" indent="0">
+                      <a:pPr indent="0" marL="0">
                         <a:buNone/>
                       </a:pPr>
                       <a:r>
@@ -2100,7 +2246,7 @@
                       </a:endParaRPr>
                     </a:p>
                   </a:txBody>
-                  <a:tcPr anchor="ctr">
+                  <a:tcPr marL="91440" marR="91440" marT="45720" marB="45720" anchor="ctr">
                     <a:lnL w="6350" cap="flat" cmpd="sng" algn="ctr">
                       <a:solidFill>
                         <a:srgbClr val="D6DEE8"/>
@@ -2147,7 +2293,7 @@
                     <a:bodyPr/>
                     <a:lstStyle/>
                     <a:p>
-                      <a:pPr marL="0" indent="0">
+                      <a:pPr indent="0" marL="0">
                         <a:buNone/>
                       </a:pPr>
                       <a:r>
@@ -2168,7 +2314,7 @@
                       </a:endParaRPr>
                     </a:p>
                   </a:txBody>
-                  <a:tcPr anchor="ctr">
+                  <a:tcPr marL="91440" marR="91440" marT="45720" marB="45720" anchor="ctr">
                     <a:lnL w="6350" cap="flat" cmpd="sng" algn="ctr">
                       <a:solidFill>
                         <a:srgbClr val="D6DEE8"/>
@@ -2210,11 +2356,6 @@
                     </a:solidFill>
                   </a:tcPr>
                 </a:tc>
-                <a:extLst>
-                  <a:ext uri="{0D108BD9-81ED-4DB2-BD59-A6C34878D82A}">
-                    <a16:rowId xmlns:a16="http://schemas.microsoft.com/office/drawing/2014/main" val="10000"/>
-                  </a:ext>
-                </a:extLst>
               </a:tr>
               <a:tr h="233172">
                 <a:tc>
@@ -2222,7 +2363,7 @@
                     <a:bodyPr/>
                     <a:lstStyle/>
                     <a:p>
-                      <a:pPr marL="0" indent="0">
+                      <a:pPr indent="0" marL="0">
                         <a:buNone/>
                       </a:pPr>
                       <a:r>
@@ -2243,7 +2384,7 @@
                       </a:endParaRPr>
                     </a:p>
                   </a:txBody>
-                  <a:tcPr anchor="ctr">
+                  <a:tcPr marL="91440" marR="91440" marT="45720" marB="45720" anchor="ctr">
                     <a:lnL w="6350" cap="flat" cmpd="sng" algn="ctr">
                       <a:solidFill>
                         <a:srgbClr val="D6DEE8"/>
@@ -2290,7 +2431,7 @@
                     <a:bodyPr/>
                     <a:lstStyle/>
                     <a:p>
-                      <a:pPr marL="0" indent="0">
+                      <a:pPr indent="0" marL="0">
                         <a:buNone/>
                       </a:pPr>
                       <a:r>
@@ -2311,7 +2452,7 @@
                       </a:endParaRPr>
                     </a:p>
                   </a:txBody>
-                  <a:tcPr anchor="ctr">
+                  <a:tcPr marL="91440" marR="91440" marT="45720" marB="45720" anchor="ctr">
                     <a:lnL w="6350" cap="flat" cmpd="sng" algn="ctr">
                       <a:solidFill>
                         <a:srgbClr val="D6DEE8"/>
@@ -2353,11 +2494,6 @@
                     </a:solidFill>
                   </a:tcPr>
                 </a:tc>
-                <a:extLst>
-                  <a:ext uri="{0D108BD9-81ED-4DB2-BD59-A6C34878D82A}">
-                    <a16:rowId xmlns:a16="http://schemas.microsoft.com/office/drawing/2014/main" val="10001"/>
-                  </a:ext>
-                </a:extLst>
               </a:tr>
               <a:tr h="233172">
                 <a:tc>
@@ -2365,7 +2501,7 @@
                     <a:bodyPr/>
                     <a:lstStyle/>
                     <a:p>
-                      <a:pPr marL="0" indent="0">
+                      <a:pPr indent="0" marL="0">
                         <a:buNone/>
                       </a:pPr>
                       <a:r>
@@ -2386,7 +2522,7 @@
                       </a:endParaRPr>
                     </a:p>
                   </a:txBody>
-                  <a:tcPr anchor="ctr">
+                  <a:tcPr marL="91440" marR="91440" marT="45720" marB="45720" anchor="ctr">
                     <a:lnL w="6350" cap="flat" cmpd="sng" algn="ctr">
                       <a:solidFill>
                         <a:srgbClr val="D6DEE8"/>
@@ -2433,7 +2569,7 @@
                     <a:bodyPr/>
                     <a:lstStyle/>
                     <a:p>
-                      <a:pPr marL="0" indent="0">
+                      <a:pPr indent="0" marL="0">
                         <a:buNone/>
                       </a:pPr>
                       <a:r>
@@ -2445,7 +2581,7 @@
                           <a:ea typeface="Segoe UI" pitchFamily="34" charset="-122"/>
                           <a:cs typeface="Segoe UI" pitchFamily="34" charset="-120"/>
                         </a:rPr>
-                        <a:t>Team hacking (2h30) — Challenges 1, 2, 3</a:t>
+                        <a:t>Team hacking (2h30) — Challenges 0, 1, 2</a:t>
                       </a:r>
                       <a:endParaRPr lang="en-US" sz="900" dirty="0">
                         <a:latin typeface="Segoe UI" charset="0"/>
@@ -2454,7 +2590,7 @@
                       </a:endParaRPr>
                     </a:p>
                   </a:txBody>
-                  <a:tcPr anchor="ctr">
+                  <a:tcPr marL="91440" marR="91440" marT="45720" marB="45720" anchor="ctr">
                     <a:lnL w="6350" cap="flat" cmpd="sng" algn="ctr">
                       <a:solidFill>
                         <a:srgbClr val="D6DEE8"/>
@@ -2496,11 +2632,6 @@
                     </a:solidFill>
                   </a:tcPr>
                 </a:tc>
-                <a:extLst>
-                  <a:ext uri="{0D108BD9-81ED-4DB2-BD59-A6C34878D82A}">
-                    <a16:rowId xmlns:a16="http://schemas.microsoft.com/office/drawing/2014/main" val="10002"/>
-                  </a:ext>
-                </a:extLst>
               </a:tr>
               <a:tr h="233172">
                 <a:tc>
@@ -2508,7 +2639,7 @@
                     <a:bodyPr/>
                     <a:lstStyle/>
                     <a:p>
-                      <a:pPr marL="0" indent="0">
+                      <a:pPr indent="0" marL="0">
                         <a:buNone/>
                       </a:pPr>
                       <a:r>
@@ -2529,7 +2660,7 @@
                       </a:endParaRPr>
                     </a:p>
                   </a:txBody>
-                  <a:tcPr anchor="ctr">
+                  <a:tcPr marL="91440" marR="91440" marT="45720" marB="45720" anchor="ctr">
                     <a:lnL w="6350" cap="flat" cmpd="sng" algn="ctr">
                       <a:solidFill>
                         <a:srgbClr val="D6DEE8"/>
@@ -2576,7 +2707,7 @@
                     <a:bodyPr/>
                     <a:lstStyle/>
                     <a:p>
-                      <a:pPr marL="0" indent="0">
+                      <a:pPr indent="0" marL="0">
                         <a:buNone/>
                       </a:pPr>
                       <a:r>
@@ -2597,7 +2728,7 @@
                       </a:endParaRPr>
                     </a:p>
                   </a:txBody>
-                  <a:tcPr anchor="ctr">
+                  <a:tcPr marL="91440" marR="91440" marT="45720" marB="45720" anchor="ctr">
                     <a:lnL w="6350" cap="flat" cmpd="sng" algn="ctr">
                       <a:solidFill>
                         <a:srgbClr val="D6DEE8"/>
@@ -2639,11 +2770,6 @@
                     </a:solidFill>
                   </a:tcPr>
                 </a:tc>
-                <a:extLst>
-                  <a:ext uri="{0D108BD9-81ED-4DB2-BD59-A6C34878D82A}">
-                    <a16:rowId xmlns:a16="http://schemas.microsoft.com/office/drawing/2014/main" val="10003"/>
-                  </a:ext>
-                </a:extLst>
               </a:tr>
               <a:tr h="233172">
                 <a:tc>
@@ -2651,7 +2777,7 @@
                     <a:bodyPr/>
                     <a:lstStyle/>
                     <a:p>
-                      <a:pPr marL="0" indent="0">
+                      <a:pPr indent="0" marL="0">
                         <a:buNone/>
                       </a:pPr>
                       <a:r>
@@ -2672,7 +2798,7 @@
                       </a:endParaRPr>
                     </a:p>
                   </a:txBody>
-                  <a:tcPr anchor="ctr">
+                  <a:tcPr marL="91440" marR="91440" marT="45720" marB="45720" anchor="ctr">
                     <a:lnL w="6350" cap="flat" cmpd="sng" algn="ctr">
                       <a:solidFill>
                         <a:srgbClr val="D6DEE8"/>
@@ -2719,7 +2845,7 @@
                     <a:bodyPr/>
                     <a:lstStyle/>
                     <a:p>
-                      <a:pPr marL="0" indent="0">
+                      <a:pPr indent="0" marL="0">
                         <a:buNone/>
                       </a:pPr>
                       <a:r>
@@ -2731,7 +2857,7 @@
                           <a:ea typeface="Segoe UI" pitchFamily="34" charset="-122"/>
                           <a:cs typeface="Segoe UI" pitchFamily="34" charset="-120"/>
                         </a:rPr>
-                        <a:t>Team hacking (2h) — Challenges 4, 5, 6</a:t>
+                        <a:t>Team hacking (2h) — Challenges 3, 4</a:t>
                       </a:r>
                       <a:endParaRPr lang="en-US" sz="900" dirty="0">
                         <a:latin typeface="Segoe UI" charset="0"/>
@@ -2740,7 +2866,7 @@
                       </a:endParaRPr>
                     </a:p>
                   </a:txBody>
-                  <a:tcPr anchor="ctr">
+                  <a:tcPr marL="91440" marR="91440" marT="45720" marB="45720" anchor="ctr">
                     <a:lnL w="6350" cap="flat" cmpd="sng" algn="ctr">
                       <a:solidFill>
                         <a:srgbClr val="D6DEE8"/>
@@ -2782,11 +2908,6 @@
                     </a:solidFill>
                   </a:tcPr>
                 </a:tc>
-                <a:extLst>
-                  <a:ext uri="{0D108BD9-81ED-4DB2-BD59-A6C34878D82A}">
-                    <a16:rowId xmlns:a16="http://schemas.microsoft.com/office/drawing/2014/main" val="10004"/>
-                  </a:ext>
-                </a:extLst>
               </a:tr>
               <a:tr h="233172">
                 <a:tc>
@@ -2794,7 +2915,7 @@
                     <a:bodyPr/>
                     <a:lstStyle/>
                     <a:p>
-                      <a:pPr marL="0" indent="0">
+                      <a:pPr indent="0" marL="0">
                         <a:buNone/>
                       </a:pPr>
                       <a:r>
@@ -2815,7 +2936,7 @@
                       </a:endParaRPr>
                     </a:p>
                   </a:txBody>
-                  <a:tcPr anchor="ctr">
+                  <a:tcPr marL="91440" marR="91440" marT="45720" marB="45720" anchor="ctr">
                     <a:lnL w="6350" cap="flat" cmpd="sng" algn="ctr">
                       <a:solidFill>
                         <a:srgbClr val="D6DEE8"/>
@@ -2862,7 +2983,7 @@
                     <a:bodyPr/>
                     <a:lstStyle/>
                     <a:p>
-                      <a:pPr marL="0" indent="0">
+                      <a:pPr indent="0" marL="0">
                         <a:buNone/>
                       </a:pPr>
                       <a:r>
@@ -2883,7 +3004,7 @@
                       </a:endParaRPr>
                     </a:p>
                   </a:txBody>
-                  <a:tcPr anchor="ctr">
+                  <a:tcPr marL="91440" marR="91440" marT="45720" marB="45720" anchor="ctr">
                     <a:lnL w="6350" cap="flat" cmpd="sng" algn="ctr">
                       <a:solidFill>
                         <a:srgbClr val="D6DEE8"/>
@@ -2925,11 +3046,6 @@
                     </a:solidFill>
                   </a:tcPr>
                 </a:tc>
-                <a:extLst>
-                  <a:ext uri="{0D108BD9-81ED-4DB2-BD59-A6C34878D82A}">
-                    <a16:rowId xmlns:a16="http://schemas.microsoft.com/office/drawing/2014/main" val="10005"/>
-                  </a:ext>
-                </a:extLst>
               </a:tr>
             </a:tbl>
           </a:graphicData>
@@ -2944,7 +3060,7 @@
           <p:nvPr/>
         </p:nvPicPr>
         <p:blipFill>
-          <a:blip r:embed="rId4"/>
+          <a:blip r:embed="rId6"/>
           <a:stretch>
             <a:fillRect/>
           </a:stretch>
@@ -2980,7 +3096,7 @@
           <a:bodyPr wrap="square" lIns="0" tIns="0" rIns="0" bIns="0" rtlCol="0" anchor="ctr"/>
           <a:lstStyle/>
           <a:p>
-            <a:pPr marL="0" indent="0" algn="l">
+            <a:pPr algn="l" indent="0" marL="0">
               <a:buNone/>
             </a:pPr>
             <a:r>
@@ -3019,7 +3135,7 @@
           <a:bodyPr wrap="square" lIns="0" tIns="0" rIns="0" bIns="0" rtlCol="0" anchor="ctr"/>
           <a:lstStyle/>
           <a:p>
-            <a:pPr marL="0" indent="0" algn="r">
+            <a:pPr algn="r" indent="0" marL="0">
               <a:buNone/>
             </a:pPr>
             <a:r>
@@ -3031,29 +3147,7 @@
                 <a:ea typeface="Segoe UI" pitchFamily="34" charset="-122"/>
                 <a:cs typeface="Segoe UI" pitchFamily="34" charset="-120"/>
               </a:rPr>
-              <a:t>Agnostic </a:t>
-            </a:r>
-            <a:r>
-              <a:rPr lang="en-US" sz="850" b="1" dirty="0">
-                <a:solidFill>
-                  <a:srgbClr val="F4C430"/>
-                </a:solidFill>
-                <a:latin typeface="Segoe UI" pitchFamily="34" charset="0"/>
-                <a:ea typeface="Segoe UI" pitchFamily="34" charset="-122"/>
-                <a:cs typeface="Segoe UI" pitchFamily="34" charset="-120"/>
-              </a:rPr>
-              <a:t>HERE</a:t>
-            </a:r>
-            <a:r>
-              <a:rPr lang="en-US" sz="850" dirty="0">
-                <a:solidFill>
-                  <a:srgbClr val="FFFFFF"/>
-                </a:solidFill>
-                <a:latin typeface="Segoe UI" pitchFamily="34" charset="0"/>
-                <a:ea typeface="Segoe UI" pitchFamily="34" charset="-122"/>
-                <a:cs typeface="Segoe UI" pitchFamily="34" charset="-120"/>
-              </a:rPr>
-              <a:t> / FSI-Legal </a:t>
+              <a:t xml:space="preserve">Cross-industry deck </a:t>
             </a:r>
             <a:r>
               <a:rPr lang="en-US" sz="850" b="1" dirty="0">
@@ -3096,20 +3190,13 @@
             <a:prstDash val="solid"/>
           </a:ln>
           <a:effectLst>
-            <a:outerShdw blurRad="63500" dist="25400" dir="8100000" algn="bl" rotWithShape="0">
+            <a:outerShdw sx="100000" sy="100000" kx="0" ky="0" algn="bl" rotWithShape="0" blurRad="63500" dist="25400" dir="8100000">
               <a:srgbClr val="1F3864">
                 <a:alpha val="12000"/>
               </a:srgbClr>
             </a:outerShdw>
           </a:effectLst>
         </p:spPr>
-        <p:txBody>
-          <a:bodyPr/>
-          <a:lstStyle/>
-          <a:p>
-            <a:endParaRPr lang="en-DE"/>
-          </a:p>
-        </p:txBody>
       </p:sp>
       <p:sp>
         <p:nvSpPr>
@@ -3132,7 +3219,7 @@
           <a:bodyPr wrap="square" lIns="0" tIns="0" rIns="0" bIns="0" rtlCol="0" anchor="t"/>
           <a:lstStyle/>
           <a:p>
-            <a:pPr marL="0" indent="0" algn="l">
+            <a:pPr algn="l" indent="0" marL="0">
               <a:buNone/>
             </a:pPr>
             <a:r>
@@ -3149,7 +3236,7 @@
             <a:endParaRPr lang="en-US" sz="820" dirty="0"/>
           </a:p>
           <a:p>
-            <a:pPr marL="0" indent="0" algn="l">
+            <a:pPr algn="l" indent="0" marL="0">
               <a:spcBef>
                 <a:spcPts val="200"/>
               </a:spcBef>
@@ -3180,7 +3267,7 @@
             <a:endParaRPr lang="en-US" sz="820" dirty="0"/>
           </a:p>
           <a:p>
-            <a:pPr marL="0" indent="0" algn="l">
+            <a:pPr algn="l" indent="0" marL="0">
               <a:spcBef>
                 <a:spcPts val="200"/>
               </a:spcBef>
@@ -3211,7 +3298,7 @@
             <a:endParaRPr lang="en-US" sz="820" dirty="0"/>
           </a:p>
           <a:p>
-            <a:pPr marL="0" indent="0" algn="l">
+            <a:pPr algn="l" indent="0" marL="0">
               <a:spcBef>
                 <a:spcPts val="200"/>
               </a:spcBef>
@@ -3252,7 +3339,7 @@
           <p:nvPr/>
         </p:nvPicPr>
         <p:blipFill>
-          <a:blip r:embed="rId4"/>
+          <a:blip r:embed="rId7"/>
           <a:stretch>
             <a:fillRect/>
           </a:stretch>
@@ -3288,7 +3375,7 @@
           <a:bodyPr wrap="square" lIns="0" tIns="0" rIns="0" bIns="0" rtlCol="0" anchor="ctr"/>
           <a:lstStyle/>
           <a:p>
-            <a:pPr marL="0" indent="0" algn="l">
+            <a:pPr algn="l" indent="0" marL="0">
               <a:buNone/>
             </a:pPr>
             <a:r>
@@ -3327,7 +3414,7 @@
           <a:bodyPr wrap="square" lIns="0" tIns="0" rIns="0" bIns="0" rtlCol="0" anchor="ctr"/>
           <a:lstStyle/>
           <a:p>
-            <a:pPr marL="0" indent="0" algn="r">
+            <a:pPr algn="r" indent="0" marL="0">
               <a:buNone/>
             </a:pPr>
             <a:r>
@@ -3339,8 +3426,11 @@
                 <a:ea typeface="Segoe UI" pitchFamily="34" charset="-122"/>
                 <a:cs typeface="Segoe UI" pitchFamily="34" charset="-120"/>
               </a:rPr>
-              <a:t>GitHub Repo </a:t>
-            </a:r>
+              <a:t xml:space="preserve">GitHub Repo </a:t>
+            </a:r>
+            <a:pPr algn="r" indent="0" marL="0">
+              <a:buNone/>
+            </a:pPr>
             <a:r>
               <a:rPr lang="en-US" sz="850" b="1" u="sng" dirty="0">
                 <a:solidFill>
@@ -3349,7 +3439,7 @@
                 <a:latin typeface="Segoe UI" pitchFamily="34" charset="0"/>
                 <a:ea typeface="Segoe UI" pitchFamily="34" charset="-122"/>
                 <a:cs typeface="Segoe UI" pitchFamily="34" charset="-120"/>
-                <a:hlinkClick r:id="rId5">
+                <a:hlinkClick r:id="rId8" invalidUrl="" action="" tgtFrame="" tooltip="" history="1" highlightClick="0" endSnd="0">
                   <a:extLst>
                     <a:ext uri="{A12FA001-AC4F-418D-AE19-62706E023703}">
                       <ahyp:hlinkClr xmlns:ahyp="http://schemas.microsoft.com/office/drawing/2018/hyperlinkcolor" val="tx"/>
@@ -3359,6 +3449,9 @@
               </a:rPr>
               <a:t>HERE</a:t>
             </a:r>
+            <a:pPr algn="r" indent="0" marL="0">
+              <a:buNone/>
+            </a:pPr>
             <a:r>
               <a:rPr lang="en-US" sz="850" dirty="0">
                 <a:solidFill>
@@ -3368,8 +3461,11 @@
                 <a:ea typeface="Segoe UI" pitchFamily="34" charset="-122"/>
                 <a:cs typeface="Segoe UI" pitchFamily="34" charset="-120"/>
               </a:rPr>
-              <a:t> / Train the Trainer video </a:t>
-            </a:r>
+              <a:t xml:space="preserve"> / Train the Trainer video </a:t>
+            </a:r>
+            <a:pPr algn="r" indent="0" marL="0">
+              <a:buNone/>
+            </a:pPr>
             <a:r>
               <a:rPr lang="en-US" sz="850" b="1" dirty="0">
                 <a:solidFill>
@@ -3387,41 +3483,29 @@
       </p:sp>
       <p:graphicFrame>
         <p:nvGraphicFramePr>
-          <p:cNvPr id="42" name="Table 1"/>
+          <p:cNvPr id="3" name="Table 1"/>
           <p:cNvGraphicFramePr>
             <a:graphicFrameLocks noGrp="1"/>
           </p:cNvGraphicFramePr>
           <p:nvPr>
             <p:extLst>
               <p:ext uri="{D42A27DB-BD31-4B8C-83A1-F6EECF244321}">
-                <p14:modId xmlns:p14="http://schemas.microsoft.com/office/powerpoint/2010/main" val="93457208"/>
+                <p14:modId xmlns:p14="http://schemas.microsoft.com/office/powerpoint/2010/main" val="1579011935"/>
               </p:ext>
             </p:extLst>
           </p:nvPr>
         </p:nvGraphicFramePr>
         <p:xfrm>
           <a:off x="6144768" y="4443984"/>
-          <a:ext cx="5742432" cy="1600200"/>
+          <a:ext cx="5742432" cy="914400"/>
         </p:xfrm>
         <a:graphic>
           <a:graphicData uri="http://schemas.openxmlformats.org/drawingml/2006/table">
             <a:tbl>
               <a:tblPr/>
               <a:tblGrid>
-                <a:gridCol w="4919472">
-                  <a:extLst>
-                    <a:ext uri="{9D8B030D-6E8A-4147-A177-3AD203B41FA5}">
-                      <a16:colId xmlns:a16="http://schemas.microsoft.com/office/drawing/2014/main" val="20000"/>
-                    </a:ext>
-                  </a:extLst>
-                </a:gridCol>
-                <a:gridCol w="822960">
-                  <a:extLst>
-                    <a:ext uri="{9D8B030D-6E8A-4147-A177-3AD203B41FA5}">
-                      <a16:colId xmlns:a16="http://schemas.microsoft.com/office/drawing/2014/main" val="20001"/>
-                    </a:ext>
-                  </a:extLst>
-                </a:gridCol>
+                <a:gridCol w="4919472"/>
+                <a:gridCol w="822960"/>
               </a:tblGrid>
               <a:tr h="228600">
                 <a:tc>
@@ -3429,7 +3513,7 @@
                     <a:bodyPr/>
                     <a:lstStyle/>
                     <a:p>
-                      <a:pPr marL="0" indent="0">
+                      <a:pPr indent="0" marL="0">
                         <a:buNone/>
                       </a:pPr>
                       <a:r>
@@ -3450,7 +3534,7 @@
                       </a:endParaRPr>
                     </a:p>
                   </a:txBody>
-                  <a:tcPr anchor="ctr">
+                  <a:tcPr marL="91440" marR="91440" marT="45720" marB="45720" anchor="ctr">
                     <a:lnL w="6350" cap="flat" cmpd="sng" algn="ctr">
                       <a:solidFill>
                         <a:srgbClr val="D6DEE8"/>
@@ -3497,7 +3581,7 @@
                     <a:bodyPr/>
                     <a:lstStyle/>
                     <a:p>
-                      <a:pPr marL="0" indent="0" algn="r">
+                      <a:pPr algn="r" indent="0" marL="0">
                         <a:buNone/>
                       </a:pPr>
                       <a:r>
@@ -3518,7 +3602,7 @@
                       </a:endParaRPr>
                     </a:p>
                   </a:txBody>
-                  <a:tcPr anchor="ctr">
+                  <a:tcPr marL="91440" marR="91440" marT="45720" marB="45720" anchor="ctr">
                     <a:lnL w="6350" cap="flat" cmpd="sng" algn="ctr">
                       <a:solidFill>
                         <a:srgbClr val="D6DEE8"/>
@@ -3560,11 +3644,6 @@
                     </a:solidFill>
                   </a:tcPr>
                 </a:tc>
-                <a:extLst>
-                  <a:ext uri="{0D108BD9-81ED-4DB2-BD59-A6C34878D82A}">
-                    <a16:rowId xmlns:a16="http://schemas.microsoft.com/office/drawing/2014/main" val="10000"/>
-                  </a:ext>
-                </a:extLst>
               </a:tr>
               <a:tr h="228600">
                 <a:tc>
@@ -3572,7 +3651,7 @@
                     <a:bodyPr/>
                     <a:lstStyle/>
                     <a:p>
-                      <a:pPr marL="0" indent="0">
+                      <a:pPr indent="0" marL="0">
                         <a:buNone/>
                       </a:pPr>
                       <a:r>
@@ -3584,7 +3663,7 @@
                           <a:ea typeface="Segoe UI" pitchFamily="34" charset="-122"/>
                           <a:cs typeface="Segoe UI" pitchFamily="34" charset="-120"/>
                         </a:rPr>
-                        <a:t>1   Resource Deployment · Codespaces · .env · Corpus seeding</a:t>
+                        <a:t>0   Resource Deployment · Codespaces · .env · Corpus seeding</a:t>
                       </a:r>
                       <a:endParaRPr lang="en-US" sz="900" dirty="0">
                         <a:latin typeface="Segoe UI" charset="0"/>
@@ -3593,7 +3672,7 @@
                       </a:endParaRPr>
                     </a:p>
                   </a:txBody>
-                  <a:tcPr anchor="ctr">
+                  <a:tcPr marL="91440" marR="91440" marT="45720" marB="45720" anchor="ctr">
                     <a:lnL w="6350" cap="flat" cmpd="sng" algn="ctr">
                       <a:solidFill>
                         <a:srgbClr val="D6DEE8"/>
@@ -3640,7 +3719,7 @@
                     <a:bodyPr/>
                     <a:lstStyle/>
                     <a:p>
-                      <a:pPr marL="0" indent="0" algn="r">
+                      <a:pPr algn="r" indent="0" marL="0">
                         <a:buNone/>
                       </a:pPr>
                       <a:r>
@@ -3661,7 +3740,7 @@
                       </a:endParaRPr>
                     </a:p>
                   </a:txBody>
-                  <a:tcPr anchor="ctr">
+                  <a:tcPr marL="91440" marR="91440" marT="45720" marB="45720" anchor="ctr">
                     <a:lnL w="6350" cap="flat" cmpd="sng" algn="ctr">
                       <a:solidFill>
                         <a:srgbClr val="D6DEE8"/>
@@ -3703,11 +3782,6 @@
                     </a:solidFill>
                   </a:tcPr>
                 </a:tc>
-                <a:extLst>
-                  <a:ext uri="{0D108BD9-81ED-4DB2-BD59-A6C34878D82A}">
-                    <a16:rowId xmlns:a16="http://schemas.microsoft.com/office/drawing/2014/main" val="10001"/>
-                  </a:ext>
-                </a:extLst>
               </a:tr>
               <a:tr h="228600">
                 <a:tc>
@@ -3715,7 +3789,7 @@
                     <a:bodyPr/>
                     <a:lstStyle/>
                     <a:p>
-                      <a:pPr marL="0" indent="0">
+                      <a:pPr indent="0" marL="0">
                         <a:buNone/>
                       </a:pPr>
                       <a:r>
@@ -3727,7 +3801,7 @@
                           <a:ea typeface="Segoe UI" pitchFamily="34" charset="-122"/>
                           <a:cs typeface="Segoe UI" pitchFamily="34" charset="-120"/>
                         </a:rPr>
-                        <a:t>2   Intake &amp; Drafting Agent + Foundry IQ + Tools</a:t>
+                        <a:t>1   Intake &amp; Drafting Agent + Foundry IQ + Tools</a:t>
                       </a:r>
                       <a:endParaRPr lang="en-US" sz="900" dirty="0">
                         <a:latin typeface="Segoe UI" charset="0"/>
@@ -3736,7 +3810,7 @@
                       </a:endParaRPr>
                     </a:p>
                   </a:txBody>
-                  <a:tcPr anchor="ctr">
+                  <a:tcPr marL="91440" marR="91440" marT="45720" marB="45720" anchor="ctr">
                     <a:lnL w="6350" cap="flat" cmpd="sng" algn="ctr">
                       <a:solidFill>
                         <a:srgbClr val="D6DEE8"/>
@@ -3783,7 +3857,7 @@
                     <a:bodyPr/>
                     <a:lstStyle/>
                     <a:p>
-                      <a:pPr marL="0" indent="0" algn="r">
+                      <a:pPr algn="r" indent="0" marL="0">
                         <a:buNone/>
                       </a:pPr>
                       <a:r>
@@ -3804,7 +3878,7 @@
                       </a:endParaRPr>
                     </a:p>
                   </a:txBody>
-                  <a:tcPr anchor="ctr">
+                  <a:tcPr marL="91440" marR="91440" marT="45720" marB="45720" anchor="ctr">
                     <a:lnL w="6350" cap="flat" cmpd="sng" algn="ctr">
                       <a:solidFill>
                         <a:srgbClr val="D6DEE8"/>
@@ -3846,11 +3920,6 @@
                     </a:solidFill>
                   </a:tcPr>
                 </a:tc>
-                <a:extLst>
-                  <a:ext uri="{0D108BD9-81ED-4DB2-BD59-A6C34878D82A}">
-                    <a16:rowId xmlns:a16="http://schemas.microsoft.com/office/drawing/2014/main" val="10002"/>
-                  </a:ext>
-                </a:extLst>
               </a:tr>
               <a:tr h="228600">
                 <a:tc>
@@ -3858,7 +3927,7 @@
                     <a:bodyPr/>
                     <a:lstStyle/>
                     <a:p>
-                      <a:pPr marL="0" indent="0">
+                      <a:pPr indent="0" marL="0">
                         <a:buNone/>
                       </a:pPr>
                       <a:r>
@@ -3870,7 +3939,7 @@
                           <a:ea typeface="Segoe UI" pitchFamily="34" charset="-122"/>
                           <a:cs typeface="Segoe UI" pitchFamily="34" charset="-120"/>
                         </a:rPr>
-                        <a:t>3   Observability, Tracing &amp; Evaluation</a:t>
+                        <a:t>2   Observability, Tracing &amp; Evaluation</a:t>
                       </a:r>
                       <a:endParaRPr lang="en-US" sz="900" dirty="0">
                         <a:latin typeface="Segoe UI" charset="0"/>
@@ -3879,7 +3948,7 @@
                       </a:endParaRPr>
                     </a:p>
                   </a:txBody>
-                  <a:tcPr anchor="ctr">
+                  <a:tcPr marL="91440" marR="91440" marT="45720" marB="45720" anchor="ctr">
                     <a:lnL w="6350" cap="flat" cmpd="sng" algn="ctr">
                       <a:solidFill>
                         <a:srgbClr val="D6DEE8"/>
@@ -3926,7 +3995,7 @@
                     <a:bodyPr/>
                     <a:lstStyle/>
                     <a:p>
-                      <a:pPr marL="0" indent="0" algn="r">
+                      <a:pPr algn="r" indent="0" marL="0">
                         <a:buNone/>
                       </a:pPr>
                       <a:r>
@@ -3947,7 +4016,7 @@
                       </a:endParaRPr>
                     </a:p>
                   </a:txBody>
-                  <a:tcPr anchor="ctr">
+                  <a:tcPr marL="91440" marR="91440" marT="45720" marB="45720" anchor="ctr">
                     <a:lnL w="6350" cap="flat" cmpd="sng" algn="ctr">
                       <a:solidFill>
                         <a:srgbClr val="D6DEE8"/>
@@ -3989,11 +4058,6 @@
                     </a:solidFill>
                   </a:tcPr>
                 </a:tc>
-                <a:extLst>
-                  <a:ext uri="{0D108BD9-81ED-4DB2-BD59-A6C34878D82A}">
-                    <a16:rowId xmlns:a16="http://schemas.microsoft.com/office/drawing/2014/main" val="10003"/>
-                  </a:ext>
-                </a:extLst>
               </a:tr>
               <a:tr h="228600">
                 <a:tc>
@@ -4001,7 +4065,7 @@
                     <a:bodyPr/>
                     <a:lstStyle/>
                     <a:p>
-                      <a:pPr marL="0" indent="0">
+                      <a:pPr indent="0" marL="0">
                         <a:buNone/>
                       </a:pPr>
                       <a:r>
@@ -4013,7 +4077,7 @@
                           <a:ea typeface="Segoe UI" pitchFamily="34" charset="-122"/>
                           <a:cs typeface="Segoe UI" pitchFamily="34" charset="-120"/>
                         </a:rPr>
-                        <a:t>4   Clause &amp; Risk Agent + Orchestrator + MCP Server</a:t>
+                        <a:t>3   Clause &amp; Risk Agent + Orchestrator + MCP Server</a:t>
                       </a:r>
                       <a:endParaRPr lang="en-US" sz="900" dirty="0">
                         <a:latin typeface="Segoe UI" charset="0"/>
@@ -4022,7 +4086,7 @@
                       </a:endParaRPr>
                     </a:p>
                   </a:txBody>
-                  <a:tcPr anchor="ctr">
+                  <a:tcPr marL="91440" marR="91440" marT="45720" marB="45720" anchor="ctr">
                     <a:lnL w="6350" cap="flat" cmpd="sng" algn="ctr">
                       <a:solidFill>
                         <a:srgbClr val="D6DEE8"/>
@@ -4069,7 +4133,7 @@
                     <a:bodyPr/>
                     <a:lstStyle/>
                     <a:p>
-                      <a:pPr marL="0" indent="0" algn="r">
+                      <a:pPr algn="r" indent="0" marL="0">
                         <a:buNone/>
                       </a:pPr>
                       <a:r>
@@ -4090,7 +4154,7 @@
                       </a:endParaRPr>
                     </a:p>
                   </a:txBody>
-                  <a:tcPr anchor="ctr">
+                  <a:tcPr marL="91440" marR="91440" marT="45720" marB="45720" anchor="ctr">
                     <a:lnL w="6350" cap="flat" cmpd="sng" algn="ctr">
                       <a:solidFill>
                         <a:srgbClr val="D6DEE8"/>
@@ -4132,11 +4196,6 @@
                     </a:solidFill>
                   </a:tcPr>
                 </a:tc>
-                <a:extLst>
-                  <a:ext uri="{0D108BD9-81ED-4DB2-BD59-A6C34878D82A}">
-                    <a16:rowId xmlns:a16="http://schemas.microsoft.com/office/drawing/2014/main" val="10004"/>
-                  </a:ext>
-                </a:extLst>
               </a:tr>
               <a:tr h="228600">
                 <a:tc>
@@ -4144,7 +4203,7 @@
                     <a:bodyPr/>
                     <a:lstStyle/>
                     <a:p>
-                      <a:pPr marL="0" indent="0">
+                      <a:pPr indent="0" marL="0">
                         <a:buNone/>
                       </a:pPr>
                       <a:r>
@@ -4156,7 +4215,7 @@
                           <a:ea typeface="Segoe UI" pitchFamily="34" charset="-122"/>
                           <a:cs typeface="Segoe UI" pitchFamily="34" charset="-120"/>
                         </a:rPr>
-                        <a:t>5   Publish to M365 Copilot &amp; Teams + Proactive Alerts</a:t>
+                        <a:t>4   Publish to M365 Copilot &amp; Teams + Proactive Alerts</a:t>
                       </a:r>
                       <a:endParaRPr lang="en-US" sz="900" dirty="0">
                         <a:latin typeface="Segoe UI" charset="0"/>
@@ -4165,7 +4224,7 @@
                       </a:endParaRPr>
                     </a:p>
                   </a:txBody>
-                  <a:tcPr anchor="ctr">
+                  <a:tcPr marL="91440" marR="91440" marT="45720" marB="45720" anchor="ctr">
                     <a:lnL w="6350" cap="flat" cmpd="sng" algn="ctr">
                       <a:solidFill>
                         <a:srgbClr val="D6DEE8"/>
@@ -4212,7 +4271,7 @@
                     <a:bodyPr/>
                     <a:lstStyle/>
                     <a:p>
-                      <a:pPr marL="0" indent="0" algn="r">
+                      <a:pPr algn="r" indent="0" marL="0">
                         <a:buNone/>
                       </a:pPr>
                       <a:r>
@@ -4233,7 +4292,7 @@
                       </a:endParaRPr>
                     </a:p>
                   </a:txBody>
-                  <a:tcPr anchor="ctr">
+                  <a:tcPr marL="91440" marR="91440" marT="45720" marB="45720" anchor="ctr">
                     <a:lnL w="6350" cap="flat" cmpd="sng" algn="ctr">
                       <a:solidFill>
                         <a:srgbClr val="D6DEE8"/>
@@ -4275,11 +4334,6 @@
                     </a:solidFill>
                   </a:tcPr>
                 </a:tc>
-                <a:extLst>
-                  <a:ext uri="{0D108BD9-81ED-4DB2-BD59-A6C34878D82A}">
-                    <a16:rowId xmlns:a16="http://schemas.microsoft.com/office/drawing/2014/main" val="10005"/>
-                  </a:ext>
-                </a:extLst>
               </a:tr>
               <a:tr h="228600">
                 <a:tc>
@@ -4287,7 +4341,7 @@
                     <a:bodyPr/>
                     <a:lstStyle/>
                     <a:p>
-                      <a:pPr marL="0" indent="0">
+                      <a:pPr indent="0" marL="0">
                         <a:buNone/>
                       </a:pPr>
                       <a:r>
@@ -4299,8 +4353,11 @@
                           <a:ea typeface="Segoe UI" pitchFamily="34" charset="-122"/>
                           <a:cs typeface="Segoe UI" pitchFamily="34" charset="-120"/>
                         </a:rPr>
-                        <a:t>6   Safety, Red-Teaming &amp; Continuous Eval   </a:t>
+                        <a:t xml:space="preserve">5   Safety, Red-Teaming &amp; Continuous Eval   </a:t>
                       </a:r>
+                      <a:pPr indent="0" marL="0">
+                        <a:buNone/>
+                      </a:pPr>
                       <a:r>
                         <a:rPr lang="en-US" sz="900" b="1" dirty="0">
                           <a:solidFill>
@@ -4319,7 +4376,7 @@
                       </a:endParaRPr>
                     </a:p>
                   </a:txBody>
-                  <a:tcPr anchor="ctr">
+                  <a:tcPr marL="91440" marR="91440" marT="45720" marB="45720" anchor="ctr">
                     <a:lnL w="6350" cap="flat" cmpd="sng" algn="ctr">
                       <a:solidFill>
                         <a:srgbClr val="D6DEE8"/>
@@ -4366,7 +4423,7 @@
                     <a:bodyPr/>
                     <a:lstStyle/>
                     <a:p>
-                      <a:pPr marL="0" indent="0" algn="r">
+                      <a:pPr algn="r" indent="0" marL="0">
                         <a:buNone/>
                       </a:pPr>
                       <a:r>
@@ -4387,7 +4444,7 @@
                       </a:endParaRPr>
                     </a:p>
                   </a:txBody>
-                  <a:tcPr anchor="ctr">
+                  <a:tcPr marL="91440" marR="91440" marT="45720" marB="45720" anchor="ctr">
                     <a:lnL w="6350" cap="flat" cmpd="sng" algn="ctr">
                       <a:solidFill>
                         <a:srgbClr val="D6DEE8"/>
@@ -4429,11 +4486,6 @@
                     </a:solidFill>
                   </a:tcPr>
                 </a:tc>
-                <a:extLst>
-                  <a:ext uri="{0D108BD9-81ED-4DB2-BD59-A6C34878D82A}">
-                    <a16:rowId xmlns:a16="http://schemas.microsoft.com/office/drawing/2014/main" val="10006"/>
-                  </a:ext>
-                </a:extLst>
               </a:tr>
             </a:tbl>
           </a:graphicData>
@@ -4448,7 +4500,7 @@
           <p:nvPr/>
         </p:nvPicPr>
         <p:blipFill>
-          <a:blip r:embed="rId4"/>
+          <a:blip r:embed="rId9"/>
           <a:stretch>
             <a:fillRect/>
           </a:stretch>
@@ -4484,7 +4536,7 @@
           <a:bodyPr wrap="square" lIns="0" tIns="0" rIns="0" bIns="0" rtlCol="0" anchor="ctr"/>
           <a:lstStyle/>
           <a:p>
-            <a:pPr marL="0" indent="0" algn="l">
+            <a:pPr algn="l" indent="0" marL="0">
               <a:buNone/>
             </a:pPr>
             <a:r>
@@ -4523,7 +4575,7 @@
           <a:bodyPr wrap="square" lIns="0" tIns="0" rIns="0" bIns="0" rtlCol="0" anchor="ctr"/>
           <a:lstStyle/>
           <a:p>
-            <a:pPr marL="0" indent="0" algn="r">
+            <a:pPr algn="r" indent="0" marL="0">
               <a:buNone/>
             </a:pPr>
             <a:r>
@@ -4842,325 +4894,4 @@
     </a:ext>
   </a:extLst>
 </a:theme>
-</file>
-
-<file path=ppt/theme/theme2.xml><?xml version="1.0" encoding="utf-8"?>
-<a:theme xmlns:a="http://schemas.openxmlformats.org/drawingml/2006/main" name="Office Theme">
-  <a:themeElements>
-    <a:clrScheme name="Office">
-      <a:dk1>
-        <a:sysClr val="windowText" lastClr="000000"/>
-      </a:dk1>
-      <a:lt1>
-        <a:sysClr val="window" lastClr="FFFFFF"/>
-      </a:lt1>
-      <a:dk2>
-        <a:srgbClr val="0E2841"/>
-      </a:dk2>
-      <a:lt2>
-        <a:srgbClr val="E8E8E8"/>
-      </a:lt2>
-      <a:accent1>
-        <a:srgbClr val="156082"/>
-      </a:accent1>
-      <a:accent2>
-        <a:srgbClr val="E97132"/>
-      </a:accent2>
-      <a:accent3>
-        <a:srgbClr val="196B24"/>
-      </a:accent3>
-      <a:accent4>
-        <a:srgbClr val="0F9ED5"/>
-      </a:accent4>
-      <a:accent5>
-        <a:srgbClr val="A02B93"/>
-      </a:accent5>
-      <a:accent6>
-        <a:srgbClr val="4EA72E"/>
-      </a:accent6>
-      <a:hlink>
-        <a:srgbClr val="467886"/>
-      </a:hlink>
-      <a:folHlink>
-        <a:srgbClr val="96607D"/>
-      </a:folHlink>
-    </a:clrScheme>
-    <a:fontScheme name="Office">
-      <a:majorFont>
-        <a:latin typeface="Aptos Display" panose="02110004020202020204"/>
-        <a:ea typeface=""/>
-        <a:cs typeface=""/>
-        <a:font script="Jpan" typeface="游ゴシック Light"/>
-        <a:font script="Hang" typeface="맑은 고딕"/>
-        <a:font script="Hans" typeface="等线 Light"/>
-        <a:font script="Hant" typeface="新細明體"/>
-        <a:font script="Arab" typeface="Times New Roman"/>
-        <a:font script="Hebr" typeface="Times New Roman"/>
-        <a:font script="Thai" typeface="Angsana New"/>
-        <a:font script="Ethi" typeface="Nyala"/>
-        <a:font script="Beng" typeface="Vrinda"/>
-        <a:font script="Gujr" typeface="Shruti"/>
-        <a:font script="Khmr" typeface="MoolBoran"/>
-        <a:font script="Knda" typeface="Tunga"/>
-        <a:font script="Guru" typeface="Raavi"/>
-        <a:font script="Cans" typeface="Euphemia"/>
-        <a:font script="Cher" typeface="Plantagenet Cherokee"/>
-        <a:font script="Yiii" typeface="Microsoft Yi Baiti"/>
-        <a:font script="Tibt" typeface="Microsoft Himalaya"/>
-        <a:font script="Thaa" typeface="MV Boli"/>
-        <a:font script="Deva" typeface="Mangal"/>
-        <a:font script="Telu" typeface="Gautami"/>
-        <a:font script="Taml" typeface="Latha"/>
-        <a:font script="Syrc" typeface="Estrangelo Edessa"/>
-        <a:font script="Orya" typeface="Kalinga"/>
-        <a:font script="Mlym" typeface="Kartika"/>
-        <a:font script="Laoo" typeface="DokChampa"/>
-        <a:font script="Sinh" typeface="Iskoola Pota"/>
-        <a:font script="Mong" typeface="Mongolian Baiti"/>
-        <a:font script="Viet" typeface="Times New Roman"/>
-        <a:font script="Uigh" typeface="Microsoft Uighur"/>
-        <a:font script="Geor" typeface="Sylfaen"/>
-        <a:font script="Armn" typeface="Arial"/>
-        <a:font script="Bugi" typeface="Leelawadee UI"/>
-        <a:font script="Bopo" typeface="Microsoft JhengHei"/>
-        <a:font script="Java" typeface="Javanese Text"/>
-        <a:font script="Lisu" typeface="Segoe UI"/>
-        <a:font script="Mymr" typeface="Myanmar Text"/>
-        <a:font script="Nkoo" typeface="Ebrima"/>
-        <a:font script="Olck" typeface="Nirmala UI"/>
-        <a:font script="Osma" typeface="Ebrima"/>
-        <a:font script="Phag" typeface="Phagspa"/>
-        <a:font script="Syrn" typeface="Estrangelo Edessa"/>
-        <a:font script="Syrj" typeface="Estrangelo Edessa"/>
-        <a:font script="Syre" typeface="Estrangelo Edessa"/>
-        <a:font script="Sora" typeface="Nirmala UI"/>
-        <a:font script="Tale" typeface="Microsoft Tai Le"/>
-        <a:font script="Talu" typeface="Microsoft New Tai Lue"/>
-        <a:font script="Tfng" typeface="Ebrima"/>
-      </a:majorFont>
-      <a:minorFont>
-        <a:latin typeface="Aptos" panose="02110004020202020204"/>
-        <a:ea typeface=""/>
-        <a:cs typeface=""/>
-        <a:font script="Jpan" typeface="游ゴシック"/>
-        <a:font script="Hang" typeface="맑은 고딕"/>
-        <a:font script="Hans" typeface="等线"/>
-        <a:font script="Hant" typeface="新細明體"/>
-        <a:font script="Arab" typeface="Arial"/>
-        <a:font script="Hebr" typeface="Arial"/>
-        <a:font script="Thai" typeface="Cordia New"/>
-        <a:font script="Ethi" typeface="Nyala"/>
-        <a:font script="Beng" typeface="Vrinda"/>
-        <a:font script="Gujr" typeface="Shruti"/>
-        <a:font script="Khmr" typeface="DaunPenh"/>
-        <a:font script="Knda" typeface="Tunga"/>
-        <a:font script="Guru" typeface="Raavi"/>
-        <a:font script="Cans" typeface="Euphemia"/>
-        <a:font script="Cher" typeface="Plantagenet Cherokee"/>
-        <a:font script="Yiii" typeface="Microsoft Yi Baiti"/>
-        <a:font script="Tibt" typeface="Microsoft Himalaya"/>
-        <a:font script="Thaa" typeface="MV Boli"/>
-        <a:font script="Deva" typeface="Mangal"/>
-        <a:font script="Telu" typeface="Gautami"/>
-        <a:font script="Taml" typeface="Latha"/>
-        <a:font script="Syrc" typeface="Estrangelo Edessa"/>
-        <a:font script="Orya" typeface="Kalinga"/>
-        <a:font script="Mlym" typeface="Kartika"/>
-        <a:font script="Laoo" typeface="DokChampa"/>
-        <a:font script="Sinh" typeface="Iskoola Pota"/>
-        <a:font script="Mong" typeface="Mongolian Baiti"/>
-        <a:font script="Viet" typeface="Arial"/>
-        <a:font script="Uigh" typeface="Microsoft Uighur"/>
-        <a:font script="Geor" typeface="Sylfaen"/>
-        <a:font script="Armn" typeface="Arial"/>
-        <a:font script="Bugi" typeface="Leelawadee UI"/>
-        <a:font script="Bopo" typeface="Microsoft JhengHei"/>
-        <a:font script="Java" typeface="Javanese Text"/>
-        <a:font script="Lisu" typeface="Segoe UI"/>
-        <a:font script="Mymr" typeface="Myanmar Text"/>
-        <a:font script="Nkoo" typeface="Ebrima"/>
-        <a:font script="Olck" typeface="Nirmala UI"/>
-        <a:font script="Osma" typeface="Ebrima"/>
-        <a:font script="Phag" typeface="Phagspa"/>
-        <a:font script="Syrn" typeface="Estrangelo Edessa"/>
-        <a:font script="Syrj" typeface="Estrangelo Edessa"/>
-        <a:font script="Syre" typeface="Estrangelo Edessa"/>
-        <a:font script="Sora" typeface="Nirmala UI"/>
-        <a:font script="Tale" typeface="Microsoft Tai Le"/>
-        <a:font script="Talu" typeface="Microsoft New Tai Lue"/>
-        <a:font script="Tfng" typeface="Ebrima"/>
-      </a:minorFont>
-    </a:fontScheme>
-    <a:fmtScheme name="Office">
-      <a:fillStyleLst>
-        <a:solidFill>
-          <a:schemeClr val="phClr"/>
-        </a:solidFill>
-        <a:gradFill rotWithShape="1">
-          <a:gsLst>
-            <a:gs pos="0">
-              <a:schemeClr val="phClr">
-                <a:lumMod val="110000"/>
-                <a:satMod val="105000"/>
-                <a:tint val="67000"/>
-              </a:schemeClr>
-            </a:gs>
-            <a:gs pos="50000">
-              <a:schemeClr val="phClr">
-                <a:lumMod val="105000"/>
-                <a:satMod val="103000"/>
-                <a:tint val="73000"/>
-              </a:schemeClr>
-            </a:gs>
-            <a:gs pos="100000">
-              <a:schemeClr val="phClr">
-                <a:lumMod val="105000"/>
-                <a:satMod val="109000"/>
-                <a:tint val="81000"/>
-              </a:schemeClr>
-            </a:gs>
-          </a:gsLst>
-          <a:lin ang="5400000" scaled="0"/>
-        </a:gradFill>
-        <a:gradFill rotWithShape="1">
-          <a:gsLst>
-            <a:gs pos="0">
-              <a:schemeClr val="phClr">
-                <a:satMod val="103000"/>
-                <a:lumMod val="102000"/>
-                <a:tint val="94000"/>
-              </a:schemeClr>
-            </a:gs>
-            <a:gs pos="50000">
-              <a:schemeClr val="phClr">
-                <a:satMod val="110000"/>
-                <a:lumMod val="100000"/>
-                <a:shade val="100000"/>
-              </a:schemeClr>
-            </a:gs>
-            <a:gs pos="100000">
-              <a:schemeClr val="phClr">
-                <a:lumMod val="99000"/>
-                <a:satMod val="120000"/>
-                <a:shade val="78000"/>
-              </a:schemeClr>
-            </a:gs>
-          </a:gsLst>
-          <a:lin ang="5400000" scaled="0"/>
-        </a:gradFill>
-      </a:fillStyleLst>
-      <a:lnStyleLst>
-        <a:ln w="12700" cap="flat" cmpd="sng" algn="ctr">
-          <a:solidFill>
-            <a:schemeClr val="phClr"/>
-          </a:solidFill>
-          <a:prstDash val="solid"/>
-          <a:miter lim="800000"/>
-        </a:ln>
-        <a:ln w="19050" cap="flat" cmpd="sng" algn="ctr">
-          <a:solidFill>
-            <a:schemeClr val="phClr"/>
-          </a:solidFill>
-          <a:prstDash val="solid"/>
-          <a:miter lim="800000"/>
-        </a:ln>
-        <a:ln w="25400" cap="flat" cmpd="sng" algn="ctr">
-          <a:solidFill>
-            <a:schemeClr val="phClr"/>
-          </a:solidFill>
-          <a:prstDash val="solid"/>
-          <a:miter lim="800000"/>
-        </a:ln>
-      </a:lnStyleLst>
-      <a:effectStyleLst>
-        <a:effectStyle>
-          <a:effectLst/>
-        </a:effectStyle>
-        <a:effectStyle>
-          <a:effectLst/>
-        </a:effectStyle>
-        <a:effectStyle>
-          <a:effectLst>
-            <a:outerShdw blurRad="57150" dist="19050" dir="5400000" algn="ctr" rotWithShape="0">
-              <a:srgbClr val="000000">
-                <a:alpha val="63000"/>
-              </a:srgbClr>
-            </a:outerShdw>
-          </a:effectLst>
-        </a:effectStyle>
-      </a:effectStyleLst>
-      <a:bgFillStyleLst>
-        <a:solidFill>
-          <a:schemeClr val="phClr"/>
-        </a:solidFill>
-        <a:solidFill>
-          <a:schemeClr val="phClr">
-            <a:tint val="95000"/>
-            <a:satMod val="170000"/>
-          </a:schemeClr>
-        </a:solidFill>
-        <a:gradFill rotWithShape="1">
-          <a:gsLst>
-            <a:gs pos="0">
-              <a:schemeClr val="phClr">
-                <a:tint val="93000"/>
-                <a:satMod val="150000"/>
-                <a:shade val="98000"/>
-                <a:lumMod val="102000"/>
-              </a:schemeClr>
-            </a:gs>
-            <a:gs pos="50000">
-              <a:schemeClr val="phClr">
-                <a:tint val="98000"/>
-                <a:satMod val="130000"/>
-                <a:shade val="90000"/>
-                <a:lumMod val="103000"/>
-              </a:schemeClr>
-            </a:gs>
-            <a:gs pos="100000">
-              <a:schemeClr val="phClr">
-                <a:shade val="63000"/>
-                <a:satMod val="120000"/>
-              </a:schemeClr>
-            </a:gs>
-          </a:gsLst>
-          <a:lin ang="5400000" scaled="0"/>
-        </a:gradFill>
-      </a:bgFillStyleLst>
-    </a:fmtScheme>
-  </a:themeElements>
-  <a:objectDefaults>
-    <a:lnDef>
-      <a:spPr/>
-      <a:bodyPr/>
-      <a:lstStyle/>
-      <a:style>
-        <a:lnRef idx="2">
-          <a:schemeClr val="accent1"/>
-        </a:lnRef>
-        <a:fillRef idx="0">
-          <a:schemeClr val="accent1"/>
-        </a:fillRef>
-        <a:effectRef idx="1">
-          <a:schemeClr val="accent1"/>
-        </a:effectRef>
-        <a:fontRef idx="minor">
-          <a:schemeClr val="tx1"/>
-        </a:fontRef>
-      </a:style>
-    </a:lnDef>
-  </a:objectDefaults>
-  <a:extraClrSchemeLst/>
-  <a:extLst>
-    <a:ext uri="{05A4C25C-085E-4340-85A3-A5531E510DB2}">
-      <thm15:themeFamily xmlns:thm15="http://schemas.microsoft.com/office/thememl/2012/main" name="Office Theme" id="{2E142A2C-CD16-42D6-873A-C26D2A0506FA}" vid="{1BDDFF52-6CD6-40A5-AB3C-68EB2F1E4D0A}"/>
-    </a:ext>
-  </a:extLst>
-</a:theme>
-</file>
-
-<file path=docMetadata/LabelInfo.xml><?xml version="1.0" encoding="utf-8"?>
-<clbl:labelList xmlns:clbl="http://schemas.microsoft.com/office/2020/mipLabelMetadata">
-  <clbl:label id="{f42aa342-8706-4288-bd11-ebb85995028c}" enabled="1" method="Standard" siteId="{72f988bf-86f1-41af-91ab-2d7cd011db47}" contentBits="0" removed="0"/>
-</clbl:labelList>
 </file>
</xml_diff>